<commit_message>
Flappy: step names for the concept each step teaches
Co-Authored-By: Claude Opus 5.5 <noreply@anthropic.com>
Claude-Session: https://claude.ai/code/session_012sjsUQBbC7zon57rWHoo9d
</commit_message>
<xml_diff>
--- a/slides/02 Flappy Bird.pptx
+++ b/slides/02 Flappy Bird.pptx
@@ -8418,7 +8418,7 @@
                   <a:schemeClr val="accent5"/>
                 </a:solidFill>
               </a:rPr>
-              <a:t>Flappy -1: Class Library</a:t>
+              <a:t>Flappy -1: A Class Library</a:t>
             </a:r>
             <a:endParaRPr>
               <a:solidFill>
@@ -9742,7 +9742,7 @@
                   <a:schemeClr val="accent5"/>
                 </a:solidFill>
               </a:rPr>
-              <a:t>Flappy 0: Consuming the Class Library</a:t>
+              <a:t>Flappy 0: A Game on the Library</a:t>
             </a:r>
             <a:endParaRPr>
               <a:solidFill>
@@ -10668,7 +10668,7 @@
                   <a:schemeClr val="accent5"/>
                 </a:solidFill>
               </a:rPr>
-              <a:t>Flappy 1: Background</a:t>
+              <a:t>Flappy 1: Drawing Images</a:t>
             </a:r>
             <a:endParaRPr>
               <a:solidFill>
@@ -11120,7 +11120,7 @@
                   <a:schemeClr val="accent5"/>
                 </a:solidFill>
               </a:rPr>
-              <a:t>Flappy 2: Parallax</a:t>
+              <a:t>Flappy 2: Parallax Scrolling</a:t>
             </a:r>
             <a:endParaRPr>
               <a:solidFill>
@@ -11826,7 +11826,7 @@
                   <a:schemeClr val="accent5"/>
                 </a:solidFill>
               </a:rPr>
-              <a:t>Flappy 3: Bird &amp; Assets</a:t>
+              <a:t>Flappy 3: The Bird and the Art Class</a:t>
             </a:r>
             <a:endParaRPr>
               <a:solidFill>
@@ -13449,7 +13449,7 @@
                   <a:schemeClr val="accent5"/>
                 </a:solidFill>
               </a:rPr>
-              <a:t>Flappy 5: Flap</a:t>
+              <a:t>Flappy 5: An Input Manager</a:t>
             </a:r>
             <a:endParaRPr>
               <a:solidFill>
@@ -14675,7 +14675,7 @@
                   <a:schemeClr val="accent5"/>
                 </a:solidFill>
               </a:rPr>
-              <a:t>Flappy 6: Infinite Pipes</a:t>
+              <a:t>Flappy 6: Spawning on a Timer</a:t>
             </a:r>
             <a:endParaRPr>
               <a:solidFill>
@@ -15546,7 +15546,7 @@
                   <a:schemeClr val="accent5"/>
                 </a:solidFill>
               </a:rPr>
-              <a:t>Flappy 7: Pipe Pairs</a:t>
+              <a:t>Flappy 7: A Drifting Gap</a:t>
             </a:r>
             <a:endParaRPr>
               <a:solidFill>
@@ -17043,7 +17043,7 @@
                   <a:schemeClr val="accent5"/>
                 </a:solidFill>
               </a:rPr>
-              <a:t>Flappy 8: Collisions</a:t>
+              <a:t>Flappy 8: Hitboxes</a:t>
             </a:r>
             <a:endParaRPr>
               <a:solidFill>
@@ -23421,7 +23421,7 @@
                   <a:schemeClr val="accent5"/>
                 </a:solidFill>
               </a:rPr>
-              <a:t>Flappy 9: State Machine</a:t>
+              <a:t>Flappy 9: A State Machine</a:t>
             </a:r>
             <a:endParaRPr>
               <a:solidFill>
@@ -24537,7 +24537,7 @@
                   <a:schemeClr val="accent5"/>
                 </a:solidFill>
               </a:rPr>
-              <a:t>Flappy 10: Scoring</a:t>
+              <a:t>Flappy 10: Passing Data Between States</a:t>
             </a:r>
             <a:endParaRPr>
               <a:solidFill>
@@ -25212,7 +25212,7 @@
                   <a:schemeClr val="accent5"/>
                 </a:solidFill>
               </a:rPr>
-              <a:t>Flappy 11: Countdown</a:t>
+              <a:t>Flappy 11: A Countdown State</a:t>
             </a:r>
             <a:endParaRPr>
               <a:solidFill>
@@ -25723,7 +25723,7 @@
                   <a:schemeClr val="accent5"/>
                 </a:solidFill>
               </a:rPr>
-              <a:t>Flappy 12: Audio</a:t>
+              <a:t>Flappy 12: Audio as a Singleton</a:t>
             </a:r>
             <a:endParaRPr>
               <a:solidFill>

</xml_diff>

<commit_message>
Session 02: what a student needs from the dry run (GMDCore without templates, where the assets come from, the tuning numbers)
Co-Authored-By: Claude Opus 5.5 <noreply@anthropic.com>
Claude-Session: https://claude.ai/code/session_012sjsUQBbC7zon57rWHoo9d
</commit_message>
<xml_diff>
--- a/slides/02 Flappy Bird.pptx
+++ b/slides/02 Flappy Bird.pptx
@@ -1007,7 +1007,12 @@
           <a:lstStyle/>
           <a:p>
             <a:r>
-              <a:t>Exercise: create GMDCore with a Core class that derives from Game and owns the window and screen scaling.</a:t>
+              <a:t>Exercise: a repository from gar-starter, then GMDCore with a Core class that derives from Game and owns the window and screen scaling.</a:t>
+            </a:r>
+          </a:p>
+          <a:p>
+            <a:r>
+              <a:t>The site has the four dotnet commands; no MonoGame templates needed. Common snag: the classlib template turns on nullable warnings; they delete that line.</a:t>
             </a:r>
           </a:p>
           <a:p>
@@ -1101,7 +1106,7 @@
           <a:lstStyle/>
           <a:p>
             <a:r>
-              <a:t>Exercise: a new game from the gar-starter template whose Game1 derives from Core. The window should look like the screenshot.</a:t>
+              <a:t>Exercise: Game1 derives from Core. The window should look like the screenshot.</a:t>
             </a:r>
           </a:p>
           <a:p>

</xml_diff>

<commit_message>
Session 02: GMDCore comes empty with the starter; exercise 1 is about the reference and its direction
Co-Authored-By: Claude Opus 5.5 <noreply@anthropic.com>
Claude-Session: https://claude.ai/code/session_012sjsUQBbC7zon57rWHoo9d
</commit_message>
<xml_diff>
--- a/slides/02 Flappy Bird.pptx
+++ b/slides/02 Flappy Bird.pptx
@@ -1007,12 +1007,12 @@
           <a:lstStyle/>
           <a:p>
             <a:r>
-              <a:t>Exercise: a repository from gar-starter, then GMDCore with a Core class that derives from Game and owns the window and screen scaling.</a:t>
+              <a:t>Exercise: a repository from gar-starter, which comes with an empty GMDCore library. They write a Core class in it that derives from Game and owns the window and screen scaling.</a:t>
             </a:r>
           </a:p>
           <a:p>
             <a:r>
-              <a:t>The site has the four dotnet commands; no MonoGame templates needed. Common snag: the classlib template turns on nullable warnings; they delete that line.</a:t>
+              <a:t>Before they code, ask: where is the library connected to the game, and which way does the reference point? Answer: the ProjectReference in the game’s .csproj; the game knows the library, never the other way round. So nothing in Core may mention Flappy.</a:t>
             </a:r>
           </a:p>
           <a:p>

</xml_diff>

<commit_message>
Decks: a polish pass on the slide wording and the notes; the Pokemon JSON example uses hpGrowth
Co-Authored-By: Claude Opus 5.5 <noreply@anthropic.com>
Claude-Session: https://claude.ai/code/session_012sjsUQBbC7zon57rWHoo9d
</commit_message>
<xml_diff>
--- a/slides/02 Flappy Bird.pptx
+++ b/slides/02 Flappy Bird.pptx
@@ -3967,7 +3967,7 @@
           </a:p>
           <a:p>
             <a:r>
-              <a:t>A: It is global state in disguise. It hides dependencies, couples code together and makes testing and reasoning harder, and the "exactly one instance" guarantee is rarely needed.</a:t>
+              <a:t>A: It is global state. It hides dependencies, couples code together and makes testing and reasoning harder, and games rarely need the "exactly one instance" guarantee.</a:t>
             </a:r>
           </a:p>
         </p:txBody>
@@ -4146,7 +4146,7 @@
           </a:p>
           <a:p>
             <a:r>
-              <a:t>Ask two groups to share one answer each. Push for concrete classes and files, not intentions.</a:t>
+              <a:t>Ask two groups to share one answer each, and push them to name actual classes and files.</a:t>
             </a:r>
           </a:p>
         </p:txBody>

</xml_diff>

<commit_message>
Decks: a slide for the original game in every deck, each with a credit line
Co-Authored-By: Claude Opus 5.5 <noreply@anthropic.com>
Claude-Session: https://claude.ai/code/session_012sjsUQBbC7zon57rWHoo9d
</commit_message>
<xml_diff>
--- a/slides/02 Flappy Bird.pptx
+++ b/slides/02 Flappy Bird.pptx
@@ -9,6 +9,7 @@
   </p:notesMasterIdLst>
   <p:sldIdLst>
     <p:sldId id="256" r:id="rId6"/>
+    <p:sldId id="299" r:id="rId58"/>
     <p:sldId id="257" r:id="rId7"/>
     <p:sldId id="258" r:id="rId8"/>
     <p:sldId id="259" r:id="rId9"/>
@@ -4147,6 +4148,69 @@
           <a:p>
             <a:r>
               <a:t>Ask two groups to share one answer each, and push them to name actual classes and files.</a:t>
+            </a:r>
+          </a:p>
+        </p:txBody>
+      </p:sp>
+    </p:spTree>
+  </p:cSld>
+  <p:clrMapOvr>
+    <a:masterClrMapping/>
+  </p:clrMapOvr>
+</p:notes>
+</file>
+
+<file path=ppt/notesSlides/notesSlide44.xml><?xml version="1.0" encoding="utf-8"?>
+<p:notes xmlns:a="http://schemas.openxmlformats.org/drawingml/2006/main" xmlns:p="http://schemas.openxmlformats.org/presentationml/2006/main" xmlns:r="http://schemas.openxmlformats.org/officeDocument/2006/relationships">
+  <p:cSld>
+    <p:spTree>
+      <p:nvGrpSpPr>
+        <p:cNvPr id="1" name=""/>
+        <p:cNvGrpSpPr/>
+        <p:nvPr/>
+      </p:nvGrpSpPr>
+      <p:grpSpPr>
+        <a:xfrm>
+          <a:off x="0" y="0"/>
+          <a:ext cx="0" cy="0"/>
+          <a:chOff x="0" y="0"/>
+          <a:chExt cx="0" cy="0"/>
+        </a:xfrm>
+      </p:grpSpPr>
+      <p:sp>
+        <p:nvSpPr>
+          <p:cNvPr id="2" name="Slide Image Placeholder 1"/>
+          <p:cNvSpPr>
+            <a:spLocks noGrp="1"/>
+          </p:cNvSpPr>
+          <p:nvPr>
+            <p:ph type="sldImg" idx="2"/>
+          </p:nvPr>
+        </p:nvSpPr>
+        <p:spPr/>
+      </p:sp>
+      <p:sp>
+        <p:nvSpPr>
+          <p:cNvPr id="3" name="Notes Placeholder 2"/>
+          <p:cNvSpPr>
+            <a:spLocks noGrp="1"/>
+          </p:cNvSpPr>
+          <p:nvPr>
+            <p:ph type="body" idx="1"/>
+          </p:nvPr>
+        </p:nvSpPr>
+        <p:spPr/>
+        <p:txBody>
+          <a:bodyPr/>
+          <a:lstStyle/>
+          <a:p>
+            <a:r>
+              <a:t>The original: Flappy Bird. Ask who has played it, and what they remember of how it plays.</a:t>
+            </a:r>
+          </a:p>
+          <a:p>
+            <a:r>
+              <a:t>Today we build the parts that matter for the architecture, not the whole game.</a:t>
             </a:r>
           </a:p>
         </p:txBody>
@@ -8280,6 +8344,99 @@
   <p:cSld>
     <p:spTree>
       <p:nvGrpSpPr>
+        <p:cNvPr id="85" name="Shape 85"/>
+        <p:cNvGrpSpPr/>
+        <p:nvPr/>
+      </p:nvGrpSpPr>
+      <p:grpSpPr>
+        <a:xfrm>
+          <a:off x="0" y="0"/>
+          <a:ext cx="0" cy="0"/>
+          <a:chOff x="0" y="0"/>
+          <a:chExt cx="0" cy="0"/>
+        </a:xfrm>
+      </p:grpSpPr>
+      <p:sp>
+        <p:nvSpPr>
+          <p:cNvPr id="86" name="Google Shape;86;p17"/>
+          <p:cNvSpPr txBox="1"/>
+          <p:nvPr>
+            <p:ph type="title"/>
+          </p:nvPr>
+        </p:nvSpPr>
+        <p:spPr>
+          <a:xfrm>
+            <a:off x="311700" y="195615"/>
+            <a:ext cx="8520600" cy="572700"/>
+          </a:xfrm>
+          <a:prstGeom prst="rect">
+            <a:avLst/>
+          </a:prstGeom>
+        </p:spPr>
+        <p:txBody>
+          <a:bodyPr anchorCtr="0" anchor="t" bIns="91425" lIns="91425" spcFirstLastPara="1" rIns="91425" wrap="square" tIns="91425">
+            <a:normAutofit fontScale="90000"/>
+          </a:bodyPr>
+          <a:lstStyle/>
+          <a:p>
+            <a:pPr indent="0" lvl="0" marL="0" rtl="0" algn="l">
+              <a:spcBef>
+                <a:spcPts val="0"/>
+              </a:spcBef>
+              <a:spcAft>
+                <a:spcPts val="0"/>
+              </a:spcAft>
+              <a:buNone/>
+            </a:pPr>
+            <a:r>
+              <a:rPr lang="en"/>
+              <a:t>Class Library</a:t>
+            </a:r>
+            <a:endParaRPr/>
+          </a:p>
+        </p:txBody>
+      </p:sp>
+      <p:pic>
+        <p:nvPicPr>
+          <p:cNvPr id="87" name="Google Shape;87;p17"/>
+          <p:cNvPicPr preferRelativeResize="0"/>
+          <p:nvPr/>
+        </p:nvPicPr>
+        <p:blipFill>
+          <a:blip r:embed="rId3">
+            <a:alphaModFix/>
+          </a:blip>
+          <a:stretch>
+            <a:fillRect/>
+          </a:stretch>
+        </p:blipFill>
+        <p:spPr>
+          <a:xfrm>
+            <a:off x="270188" y="1400650"/>
+            <a:ext cx="8603624" cy="2342200"/>
+          </a:xfrm>
+          <a:prstGeom prst="rect">
+            <a:avLst/>
+          </a:prstGeom>
+          <a:noFill/>
+          <a:ln>
+            <a:noFill/>
+          </a:ln>
+        </p:spPr>
+      </p:pic>
+    </p:spTree>
+  </p:cSld>
+  <p:clrMapOvr>
+    <a:masterClrMapping/>
+  </p:clrMapOvr>
+</p:sld>
+</file>
+
+<file path=ppt/slides/slide11.xml><?xml version="1.0" encoding="utf-8"?>
+<p:sld xmlns:a="http://schemas.openxmlformats.org/drawingml/2006/main" xmlns:r="http://schemas.openxmlformats.org/officeDocument/2006/relationships" xmlns:mc="http://schemas.openxmlformats.org/markup-compatibility/2006" xmlns:mv="urn:schemas-microsoft-com:mac:vml" xmlns:p="http://schemas.openxmlformats.org/presentationml/2006/main" xmlns:c="http://schemas.openxmlformats.org/drawingml/2006/chart" xmlns:dgm="http://schemas.openxmlformats.org/drawingml/2006/diagram" xmlns:o="urn:schemas-microsoft-com:office:office" xmlns:v="urn:schemas-microsoft-com:vml" xmlns:pvml="urn:schemas-microsoft-com:office:powerpoint" xmlns:com="http://schemas.openxmlformats.org/drawingml/2006/compatibility" xmlns:p14="http://schemas.microsoft.com/office/powerpoint/2010/main" xmlns:p15="http://schemas.microsoft.com/office/powerpoint/2012/main" xmlns:ahyp="http://schemas.microsoft.com/office/drawing/2018/hyperlinkcolor">
+  <p:cSld>
+    <p:spTree>
+      <p:nvGrpSpPr>
         <p:cNvPr id="91" name="Shape 91"/>
         <p:cNvGrpSpPr/>
         <p:nvPr/>
@@ -8368,7 +8525,7 @@
 </p:sld>
 </file>
 
-<file path=ppt/slides/slide11.xml><?xml version="1.0" encoding="utf-8"?>
+<file path=ppt/slides/slide12.xml><?xml version="1.0" encoding="utf-8"?>
 <p:sld xmlns:a="http://schemas.openxmlformats.org/drawingml/2006/main" xmlns:r="http://schemas.openxmlformats.org/officeDocument/2006/relationships" xmlns:mc="http://schemas.openxmlformats.org/markup-compatibility/2006" xmlns:mv="urn:schemas-microsoft-com:mac:vml" xmlns:p="http://schemas.openxmlformats.org/presentationml/2006/main" xmlns:c="http://schemas.openxmlformats.org/drawingml/2006/chart" xmlns:dgm="http://schemas.openxmlformats.org/drawingml/2006/diagram" xmlns:o="urn:schemas-microsoft-com:office:office" xmlns:v="urn:schemas-microsoft-com:vml" xmlns:pvml="urn:schemas-microsoft-com:office:powerpoint" xmlns:com="http://schemas.openxmlformats.org/drawingml/2006/compatibility" xmlns:p14="http://schemas.microsoft.com/office/powerpoint/2010/main" xmlns:p15="http://schemas.microsoft.com/office/powerpoint/2012/main" xmlns:ahyp="http://schemas.microsoft.com/office/drawing/2018/hyperlinkcolor">
   <p:cSld>
     <p:spTree>
@@ -9692,7 +9849,7 @@
 </p:sld>
 </file>
 
-<file path=ppt/slides/slide12.xml><?xml version="1.0" encoding="utf-8"?>
+<file path=ppt/slides/slide13.xml><?xml version="1.0" encoding="utf-8"?>
 <p:sld xmlns:a="http://schemas.openxmlformats.org/drawingml/2006/main" xmlns:r="http://schemas.openxmlformats.org/officeDocument/2006/relationships" xmlns:mc="http://schemas.openxmlformats.org/markup-compatibility/2006" xmlns:mv="urn:schemas-microsoft-com:mac:vml" xmlns:p="http://schemas.openxmlformats.org/presentationml/2006/main" xmlns:c="http://schemas.openxmlformats.org/drawingml/2006/chart" xmlns:dgm="http://schemas.openxmlformats.org/drawingml/2006/diagram" xmlns:o="urn:schemas-microsoft-com:office:office" xmlns:v="urn:schemas-microsoft-com:vml" xmlns:pvml="urn:schemas-microsoft-com:office:powerpoint" xmlns:com="http://schemas.openxmlformats.org/drawingml/2006/compatibility" xmlns:p14="http://schemas.microsoft.com/office/powerpoint/2010/main" xmlns:p15="http://schemas.microsoft.com/office/powerpoint/2012/main" xmlns:ahyp="http://schemas.microsoft.com/office/drawing/2018/hyperlinkcolor">
   <p:cSld>
     <p:spTree>
@@ -10367,7 +10524,7 @@
 </p:sld>
 </file>
 
-<file path=ppt/slides/slide13.xml><?xml version="1.0" encoding="utf-8"?>
+<file path=ppt/slides/slide14.xml><?xml version="1.0" encoding="utf-8"?>
 <p:sld xmlns:a="http://schemas.openxmlformats.org/drawingml/2006/main" xmlns:r="http://schemas.openxmlformats.org/officeDocument/2006/relationships" xmlns:mc="http://schemas.openxmlformats.org/markup-compatibility/2006" xmlns:mv="urn:schemas-microsoft-com:mac:vml" xmlns:p="http://schemas.openxmlformats.org/presentationml/2006/main" xmlns:c="http://schemas.openxmlformats.org/drawingml/2006/chart" xmlns:dgm="http://schemas.openxmlformats.org/drawingml/2006/diagram" xmlns:o="urn:schemas-microsoft-com:office:office" xmlns:v="urn:schemas-microsoft-com:vml" xmlns:pvml="urn:schemas-microsoft-com:office:powerpoint" xmlns:com="http://schemas.openxmlformats.org/drawingml/2006/compatibility" xmlns:p14="http://schemas.microsoft.com/office/powerpoint/2010/main" xmlns:p15="http://schemas.microsoft.com/office/powerpoint/2012/main" xmlns:ahyp="http://schemas.microsoft.com/office/drawing/2018/hyperlinkcolor">
   <p:cSld>
     <p:spTree>
@@ -10618,7 +10775,7 @@
 </p:sld>
 </file>
 
-<file path=ppt/slides/slide14.xml><?xml version="1.0" encoding="utf-8"?>
+<file path=ppt/slides/slide15.xml><?xml version="1.0" encoding="utf-8"?>
 <p:sld xmlns:a="http://schemas.openxmlformats.org/drawingml/2006/main" xmlns:r="http://schemas.openxmlformats.org/officeDocument/2006/relationships" xmlns:mc="http://schemas.openxmlformats.org/markup-compatibility/2006" xmlns:mv="urn:schemas-microsoft-com:mac:vml" xmlns:p="http://schemas.openxmlformats.org/presentationml/2006/main" xmlns:c="http://schemas.openxmlformats.org/drawingml/2006/chart" xmlns:dgm="http://schemas.openxmlformats.org/drawingml/2006/diagram" xmlns:o="urn:schemas-microsoft-com:office:office" xmlns:v="urn:schemas-microsoft-com:vml" xmlns:pvml="urn:schemas-microsoft-com:office:powerpoint" xmlns:com="http://schemas.openxmlformats.org/drawingml/2006/compatibility" xmlns:p14="http://schemas.microsoft.com/office/powerpoint/2010/main" xmlns:p15="http://schemas.microsoft.com/office/powerpoint/2012/main" xmlns:ahyp="http://schemas.microsoft.com/office/drawing/2018/hyperlinkcolor">
   <p:cSld>
     <p:spTree>
@@ -10933,7 +11090,7 @@
 </p:sld>
 </file>
 
-<file path=ppt/slides/slide15.xml><?xml version="1.0" encoding="utf-8"?>
+<file path=ppt/slides/slide16.xml><?xml version="1.0" encoding="utf-8"?>
 <p:sld xmlns:a="http://schemas.openxmlformats.org/drawingml/2006/main" xmlns:r="http://schemas.openxmlformats.org/officeDocument/2006/relationships" xmlns:mc="http://schemas.openxmlformats.org/markup-compatibility/2006" xmlns:mv="urn:schemas-microsoft-com:mac:vml" xmlns:p="http://schemas.openxmlformats.org/presentationml/2006/main" xmlns:c="http://schemas.openxmlformats.org/drawingml/2006/chart" xmlns:dgm="http://schemas.openxmlformats.org/drawingml/2006/diagram" xmlns:o="urn:schemas-microsoft-com:office:office" xmlns:v="urn:schemas-microsoft-com:vml" xmlns:pvml="urn:schemas-microsoft-com:office:powerpoint" xmlns:com="http://schemas.openxmlformats.org/drawingml/2006/compatibility" xmlns:p14="http://schemas.microsoft.com/office/powerpoint/2010/main" xmlns:p15="http://schemas.microsoft.com/office/powerpoint/2012/main" xmlns:ahyp="http://schemas.microsoft.com/office/drawing/2018/hyperlinkcolor">
   <p:cSld>
     <p:spTree>
@@ -11070,7 +11227,7 @@
 </p:sld>
 </file>
 
-<file path=ppt/slides/slide16.xml><?xml version="1.0" encoding="utf-8"?>
+<file path=ppt/slides/slide17.xml><?xml version="1.0" encoding="utf-8"?>
 <p:sld xmlns:a="http://schemas.openxmlformats.org/drawingml/2006/main" xmlns:r="http://schemas.openxmlformats.org/officeDocument/2006/relationships" xmlns:mc="http://schemas.openxmlformats.org/markup-compatibility/2006" xmlns:mv="urn:schemas-microsoft-com:mac:vml" xmlns:p="http://schemas.openxmlformats.org/presentationml/2006/main" xmlns:c="http://schemas.openxmlformats.org/drawingml/2006/chart" xmlns:dgm="http://schemas.openxmlformats.org/drawingml/2006/diagram" xmlns:o="urn:schemas-microsoft-com:office:office" xmlns:v="urn:schemas-microsoft-com:vml" xmlns:pvml="urn:schemas-microsoft-com:office:powerpoint" xmlns:com="http://schemas.openxmlformats.org/drawingml/2006/compatibility" xmlns:p14="http://schemas.microsoft.com/office/powerpoint/2010/main" xmlns:p15="http://schemas.microsoft.com/office/powerpoint/2012/main" xmlns:ahyp="http://schemas.microsoft.com/office/drawing/2018/hyperlinkcolor">
   <p:cSld>
     <p:spTree>
@@ -11598,7 +11755,7 @@
 </p:sld>
 </file>
 
-<file path=ppt/slides/slide17.xml><?xml version="1.0" encoding="utf-8"?>
+<file path=ppt/slides/slide18.xml><?xml version="1.0" encoding="utf-8"?>
 <p:sld xmlns:a="http://schemas.openxmlformats.org/drawingml/2006/main" xmlns:r="http://schemas.openxmlformats.org/officeDocument/2006/relationships" xmlns:mc="http://schemas.openxmlformats.org/markup-compatibility/2006" xmlns:mv="urn:schemas-microsoft-com:mac:vml" xmlns:p="http://schemas.openxmlformats.org/presentationml/2006/main" xmlns:c="http://schemas.openxmlformats.org/drawingml/2006/chart" xmlns:dgm="http://schemas.openxmlformats.org/drawingml/2006/diagram" xmlns:o="urn:schemas-microsoft-com:office:office" xmlns:v="urn:schemas-microsoft-com:vml" xmlns:pvml="urn:schemas-microsoft-com:office:powerpoint" xmlns:com="http://schemas.openxmlformats.org/drawingml/2006/compatibility" xmlns:p14="http://schemas.microsoft.com/office/powerpoint/2010/main" xmlns:p15="http://schemas.microsoft.com/office/powerpoint/2012/main" xmlns:ahyp="http://schemas.microsoft.com/office/drawing/2018/hyperlinkcolor">
   <p:cSld>
     <p:spTree>
@@ -11776,7 +11933,7 @@
 </p:sld>
 </file>
 
-<file path=ppt/slides/slide18.xml><?xml version="1.0" encoding="utf-8"?>
+<file path=ppt/slides/slide19.xml><?xml version="1.0" encoding="utf-8"?>
 <p:sld xmlns:a="http://schemas.openxmlformats.org/drawingml/2006/main" xmlns:r="http://schemas.openxmlformats.org/officeDocument/2006/relationships" xmlns:mc="http://schemas.openxmlformats.org/markup-compatibility/2006" xmlns:mv="urn:schemas-microsoft-com:mac:vml" xmlns:p="http://schemas.openxmlformats.org/presentationml/2006/main" xmlns:c="http://schemas.openxmlformats.org/drawingml/2006/chart" xmlns:dgm="http://schemas.openxmlformats.org/drawingml/2006/diagram" xmlns:o="urn:schemas-microsoft-com:office:office" xmlns:v="urn:schemas-microsoft-com:vml" xmlns:pvml="urn:schemas-microsoft-com:office:powerpoint" xmlns:com="http://schemas.openxmlformats.org/drawingml/2006/compatibility" xmlns:p14="http://schemas.microsoft.com/office/powerpoint/2010/main" xmlns:p15="http://schemas.microsoft.com/office/powerpoint/2012/main" xmlns:ahyp="http://schemas.microsoft.com/office/drawing/2018/hyperlinkcolor">
   <p:cSld>
     <p:spTree>
@@ -12946,7 +13103,120 @@
 </p:sld>
 </file>
 
-<file path=ppt/slides/slide19.xml><?xml version="1.0" encoding="utf-8"?>
+<file path=ppt/slides/slide2.xml><?xml version="1.0" encoding="utf-8"?>
+<p:sld xmlns:a="http://schemas.openxmlformats.org/drawingml/2006/main" xmlns:p="http://schemas.openxmlformats.org/presentationml/2006/main" xmlns:r="http://schemas.openxmlformats.org/officeDocument/2006/relationships">
+  <p:cSld>
+    <p:spTree>
+      <p:nvGrpSpPr>
+        <p:cNvPr id="1" name=""/>
+        <p:cNvGrpSpPr/>
+        <p:nvPr/>
+      </p:nvGrpSpPr>
+      <p:grpSpPr/>
+      <p:sp>
+        <p:nvSpPr>
+          <p:cNvPr id="2" name="Title 1"/>
+          <p:cNvSpPr>
+            <a:spLocks noGrp="1"/>
+          </p:cNvSpPr>
+          <p:nvPr>
+            <p:ph type="title"/>
+          </p:nvPr>
+        </p:nvSpPr>
+        <p:spPr>
+          <a:xfrm>
+            <a:off x="311700" y="195615"/>
+            <a:ext cx="8520600" cy="572700"/>
+          </a:xfrm>
+        </p:spPr>
+        <p:txBody>
+          <a:bodyPr/>
+          <a:lstStyle/>
+          <a:p>
+            <a:pPr indent="0" lvl="0" marL="0" rtl="0" algn="l">
+              <a:spcBef>
+                <a:spcPts val="0"/>
+              </a:spcBef>
+              <a:spcAft>
+                <a:spcPts val="0"/>
+              </a:spcAft>
+              <a:buNone/>
+            </a:pPr>
+            <a:r>
+              <a:rPr lang="en"/>
+              <a:t>Flappy Bird</a:t>
+            </a:r>
+            <a:endParaRPr/>
+          </a:p>
+        </p:txBody>
+      </p:sp>
+      <p:pic>
+        <p:nvPicPr>
+          <p:cNvPr id="3" name="Picture 2" descr="flappy-bird.png"/>
+          <p:cNvPicPr>
+            <a:picLocks noChangeAspect="1"/>
+          </p:cNvPicPr>
+          <p:nvPr/>
+        </p:nvPicPr>
+        <p:blipFill>
+          <a:blip r:embed="rId2"/>
+          <a:stretch>
+            <a:fillRect/>
+          </a:stretch>
+        </p:blipFill>
+        <p:spPr>
+          <a:xfrm>
+            <a:off x="3540034" y="960120"/>
+            <a:ext cx="2063931" cy="3657600"/>
+          </a:xfrm>
+          <a:prstGeom prst="rect">
+            <a:avLst/>
+          </a:prstGeom>
+        </p:spPr>
+      </p:pic>
+      <p:sp>
+        <p:nvSpPr>
+          <p:cNvPr id="4" name="TextBox 3"/>
+          <p:cNvSpPr txBox="1"/>
+          <p:nvPr/>
+        </p:nvSpPr>
+        <p:spPr>
+          <a:xfrm>
+            <a:off x="457200" y="4736592"/>
+            <a:ext cx="8229600" cy="274320"/>
+          </a:xfrm>
+          <a:prstGeom prst="rect">
+            <a:avLst/>
+          </a:prstGeom>
+          <a:noFill/>
+        </p:spPr>
+        <p:txBody>
+          <a:bodyPr wrap="square">
+            <a:spAutoFit/>
+          </a:bodyPr>
+          <a:lstStyle/>
+          <a:p>
+            <a:pPr algn="ctr"/>
+            <a:r>
+              <a:rPr sz="900" b="0" i="0">
+                <a:solidFill>
+                  <a:srgbClr val="9AA3AB"/>
+                </a:solidFill>
+              </a:rPr>
+              <a:t>Flappy Bird (dotGears, 2013). Screenshot © dotGears.</a:t>
+            </a:r>
+          </a:p>
+        </p:txBody>
+      </p:sp>
+    </p:spTree>
+  </p:cSld>
+  <p:clrMapOvr>
+    <a:masterClrMapping/>
+  </p:clrMapOvr>
+</p:sld>
+</file>
+
+<file path=ppt/slides/slide20.xml><?xml version="1.0" encoding="utf-8"?>
 <p:sld xmlns:a="http://schemas.openxmlformats.org/drawingml/2006/main" xmlns:r="http://schemas.openxmlformats.org/officeDocument/2006/relationships" xmlns:mc="http://schemas.openxmlformats.org/markup-compatibility/2006" xmlns:mv="urn:schemas-microsoft-com:mac:vml" xmlns:p="http://schemas.openxmlformats.org/presentationml/2006/main" xmlns:c="http://schemas.openxmlformats.org/drawingml/2006/chart" xmlns:dgm="http://schemas.openxmlformats.org/drawingml/2006/diagram" xmlns:o="urn:schemas-microsoft-com:office:office" xmlns:v="urn:schemas-microsoft-com:vml" xmlns:pvml="urn:schemas-microsoft-com:office:powerpoint" xmlns:com="http://schemas.openxmlformats.org/drawingml/2006/compatibility" xmlns:p14="http://schemas.microsoft.com/office/powerpoint/2010/main" xmlns:p15="http://schemas.microsoft.com/office/powerpoint/2012/main" xmlns:ahyp="http://schemas.microsoft.com/office/drawing/2018/hyperlinkcolor">
   <p:cSld>
     <p:spTree>
@@ -13310,96 +13580,7 @@
 </p:sld>
 </file>
 
-<file path=ppt/slides/slide2.xml><?xml version="1.0" encoding="utf-8"?>
-<p:sld xmlns:a="http://schemas.openxmlformats.org/drawingml/2006/main" xmlns:r="http://schemas.openxmlformats.org/officeDocument/2006/relationships" xmlns:mc="http://schemas.openxmlformats.org/markup-compatibility/2006" xmlns:mv="urn:schemas-microsoft-com:mac:vml" xmlns:p="http://schemas.openxmlformats.org/presentationml/2006/main" xmlns:c="http://schemas.openxmlformats.org/drawingml/2006/chart" xmlns:dgm="http://schemas.openxmlformats.org/drawingml/2006/diagram" xmlns:o="urn:schemas-microsoft-com:office:office" xmlns:v="urn:schemas-microsoft-com:vml" xmlns:pvml="urn:schemas-microsoft-com:office:powerpoint" xmlns:com="http://schemas.openxmlformats.org/drawingml/2006/compatibility" xmlns:p14="http://schemas.microsoft.com/office/powerpoint/2010/main" xmlns:p15="http://schemas.microsoft.com/office/powerpoint/2012/main" xmlns:ahyp="http://schemas.microsoft.com/office/drawing/2018/hyperlinkcolor">
-  <p:cSld>
-    <p:spTree>
-      <p:nvGrpSpPr>
-        <p:cNvPr id="44" name="Shape 44"/>
-        <p:cNvGrpSpPr/>
-        <p:nvPr/>
-      </p:nvGrpSpPr>
-      <p:grpSpPr>
-        <a:xfrm>
-          <a:off x="0" y="0"/>
-          <a:ext cx="0" cy="0"/>
-          <a:chOff x="0" y="0"/>
-          <a:chExt cx="0" cy="0"/>
-        </a:xfrm>
-      </p:grpSpPr>
-      <p:sp>
-        <p:nvSpPr>
-          <p:cNvPr id="45" name="Google Shape;45;p10"/>
-          <p:cNvSpPr txBox="1"/>
-          <p:nvPr>
-            <p:ph type="title"/>
-          </p:nvPr>
-        </p:nvSpPr>
-        <p:spPr>
-          <a:xfrm>
-            <a:off x="311700" y="195615"/>
-            <a:ext cx="8520600" cy="572700"/>
-          </a:xfrm>
-          <a:prstGeom prst="rect">
-            <a:avLst/>
-          </a:prstGeom>
-        </p:spPr>
-        <p:txBody>
-          <a:bodyPr anchorCtr="0" anchor="t" bIns="91425" lIns="91425" spcFirstLastPara="1" rIns="91425" wrap="square" tIns="91425">
-            <a:normAutofit fontScale="90000"/>
-          </a:bodyPr>
-          <a:lstStyle/>
-          <a:p>
-            <a:pPr indent="0" lvl="0" marL="0" rtl="0" algn="l">
-              <a:spcBef>
-                <a:spcPts val="0"/>
-              </a:spcBef>
-              <a:spcAft>
-                <a:spcPts val="0"/>
-              </a:spcAft>
-              <a:buNone/>
-            </a:pPr>
-            <a:r>
-              <a:rPr lang="en"/>
-              <a:t>Today’s Goal</a:t>
-            </a:r>
-            <a:endParaRPr/>
-          </a:p>
-        </p:txBody>
-      </p:sp>
-      <p:pic>
-        <p:nvPicPr>
-          <p:cNvPr id="46" name="Picture 46" descr="gif-flappy.gif"/>
-          <p:cNvPicPr>
-            <a:picLocks noChangeAspect="1"/>
-          </p:cNvPicPr>
-          <p:nvPr/>
-        </p:nvPicPr>
-        <p:blipFill>
-          <a:blip r:embed="rId4"/>
-          <a:stretch>
-            <a:fillRect/>
-          </a:stretch>
-        </p:blipFill>
-        <p:spPr>
-          <a:xfrm>
-            <a:off x="1566089" y="1322900"/>
-            <a:ext cx="6011824" cy="3381651"/>
-          </a:xfrm>
-          <a:prstGeom prst="rect">
-            <a:avLst/>
-          </a:prstGeom>
-        </p:spPr>
-      </p:pic>
-    </p:spTree>
-  </p:cSld>
-  <p:clrMapOvr>
-    <a:masterClrMapping/>
-  </p:clrMapOvr>
-</p:sld>
-</file>
-
-<file path=ppt/slides/slide20.xml><?xml version="1.0" encoding="utf-8"?>
+<file path=ppt/slides/slide21.xml><?xml version="1.0" encoding="utf-8"?>
 <p:sld xmlns:a="http://schemas.openxmlformats.org/drawingml/2006/main" xmlns:r="http://schemas.openxmlformats.org/officeDocument/2006/relationships" xmlns:mc="http://schemas.openxmlformats.org/markup-compatibility/2006" xmlns:mv="urn:schemas-microsoft-com:mac:vml" xmlns:p="http://schemas.openxmlformats.org/presentationml/2006/main" xmlns:c="http://schemas.openxmlformats.org/drawingml/2006/chart" xmlns:dgm="http://schemas.openxmlformats.org/drawingml/2006/diagram" xmlns:o="urn:schemas-microsoft-com:office:office" xmlns:v="urn:schemas-microsoft-com:vml" xmlns:pvml="urn:schemas-microsoft-com:office:powerpoint" xmlns:com="http://schemas.openxmlformats.org/drawingml/2006/compatibility" xmlns:p14="http://schemas.microsoft.com/office/powerpoint/2010/main" xmlns:p15="http://schemas.microsoft.com/office/powerpoint/2012/main" xmlns:ahyp="http://schemas.microsoft.com/office/drawing/2018/hyperlinkcolor">
   <p:cSld>
     <p:spTree>
@@ -14532,7 +14713,7 @@
 </p:sld>
 </file>
 
-<file path=ppt/slides/slide21.xml><?xml version="1.0" encoding="utf-8"?>
+<file path=ppt/slides/slide22.xml><?xml version="1.0" encoding="utf-8"?>
 <p:sld xmlns:a="http://schemas.openxmlformats.org/drawingml/2006/main" xmlns:r="http://schemas.openxmlformats.org/officeDocument/2006/relationships" xmlns:mc="http://schemas.openxmlformats.org/markup-compatibility/2006" xmlns:mv="urn:schemas-microsoft-com:mac:vml" xmlns:p="http://schemas.openxmlformats.org/presentationml/2006/main" xmlns:c="http://schemas.openxmlformats.org/drawingml/2006/chart" xmlns:dgm="http://schemas.openxmlformats.org/drawingml/2006/diagram" xmlns:o="urn:schemas-microsoft-com:office:office" xmlns:v="urn:schemas-microsoft-com:vml" xmlns:pvml="urn:schemas-microsoft-com:office:powerpoint" xmlns:com="http://schemas.openxmlformats.org/drawingml/2006/compatibility" xmlns:p14="http://schemas.microsoft.com/office/powerpoint/2010/main" xmlns:p15="http://schemas.microsoft.com/office/powerpoint/2012/main" xmlns:ahyp="http://schemas.microsoft.com/office/drawing/2018/hyperlinkcolor">
   <p:cSld>
     <p:spTree>
@@ -14625,7 +14806,7 @@
 </p:sld>
 </file>
 
-<file path=ppt/slides/slide22.xml><?xml version="1.0" encoding="utf-8"?>
+<file path=ppt/slides/slide23.xml><?xml version="1.0" encoding="utf-8"?>
 <p:sld xmlns:a="http://schemas.openxmlformats.org/drawingml/2006/main" xmlns:r="http://schemas.openxmlformats.org/officeDocument/2006/relationships" xmlns:mc="http://schemas.openxmlformats.org/markup-compatibility/2006" xmlns:mv="urn:schemas-microsoft-com:mac:vml" xmlns:p="http://schemas.openxmlformats.org/presentationml/2006/main" xmlns:c="http://schemas.openxmlformats.org/drawingml/2006/chart" xmlns:dgm="http://schemas.openxmlformats.org/drawingml/2006/diagram" xmlns:o="urn:schemas-microsoft-com:office:office" xmlns:v="urn:schemas-microsoft-com:vml" xmlns:pvml="urn:schemas-microsoft-com:office:powerpoint" xmlns:com="http://schemas.openxmlformats.org/drawingml/2006/compatibility" xmlns:p14="http://schemas.microsoft.com/office/powerpoint/2010/main" xmlns:p15="http://schemas.microsoft.com/office/powerpoint/2012/main" xmlns:ahyp="http://schemas.microsoft.com/office/drawing/2018/hyperlinkcolor">
   <p:cSld>
     <p:spTree>
@@ -15447,7 +15628,7 @@
 </p:sld>
 </file>
 
-<file path=ppt/slides/slide23.xml><?xml version="1.0" encoding="utf-8"?>
+<file path=ppt/slides/slide24.xml><?xml version="1.0" encoding="utf-8"?>
 <p:sld xmlns:a="http://schemas.openxmlformats.org/drawingml/2006/main" xmlns:r="http://schemas.openxmlformats.org/officeDocument/2006/relationships" xmlns:mc="http://schemas.openxmlformats.org/markup-compatibility/2006" xmlns:mv="urn:schemas-microsoft-com:mac:vml" xmlns:p="http://schemas.openxmlformats.org/presentationml/2006/main" xmlns:c="http://schemas.openxmlformats.org/drawingml/2006/chart" xmlns:dgm="http://schemas.openxmlformats.org/drawingml/2006/diagram" xmlns:o="urn:schemas-microsoft-com:office:office" xmlns:v="urn:schemas-microsoft-com:vml" xmlns:pvml="urn:schemas-microsoft-com:office:powerpoint" xmlns:com="http://schemas.openxmlformats.org/drawingml/2006/compatibility" xmlns:p14="http://schemas.microsoft.com/office/powerpoint/2010/main" xmlns:p15="http://schemas.microsoft.com/office/powerpoint/2012/main" xmlns:ahyp="http://schemas.microsoft.com/office/drawing/2018/hyperlinkcolor">
   <p:cSld>
     <p:spTree>
@@ -15496,7 +15677,7 @@
 </p:sld>
 </file>
 
-<file path=ppt/slides/slide24.xml><?xml version="1.0" encoding="utf-8"?>
+<file path=ppt/slides/slide25.xml><?xml version="1.0" encoding="utf-8"?>
 <p:sld xmlns:a="http://schemas.openxmlformats.org/drawingml/2006/main" xmlns:r="http://schemas.openxmlformats.org/officeDocument/2006/relationships" xmlns:mc="http://schemas.openxmlformats.org/markup-compatibility/2006" xmlns:mv="urn:schemas-microsoft-com:mac:vml" xmlns:p="http://schemas.openxmlformats.org/presentationml/2006/main" xmlns:c="http://schemas.openxmlformats.org/drawingml/2006/chart" xmlns:dgm="http://schemas.openxmlformats.org/drawingml/2006/diagram" xmlns:o="urn:schemas-microsoft-com:office:office" xmlns:v="urn:schemas-microsoft-com:vml" xmlns:pvml="urn:schemas-microsoft-com:office:powerpoint" xmlns:com="http://schemas.openxmlformats.org/drawingml/2006/compatibility" xmlns:p14="http://schemas.microsoft.com/office/powerpoint/2010/main" xmlns:p15="http://schemas.microsoft.com/office/powerpoint/2012/main" xmlns:ahyp="http://schemas.microsoft.com/office/drawing/2018/hyperlinkcolor">
   <p:cSld>
     <p:spTree>
@@ -16612,7 +16793,7 @@
 </p:sld>
 </file>
 
-<file path=ppt/slides/slide25.xml><?xml version="1.0" encoding="utf-8"?>
+<file path=ppt/slides/slide26.xml><?xml version="1.0" encoding="utf-8"?>
 <p:sld xmlns:a="http://schemas.openxmlformats.org/drawingml/2006/main" xmlns:r="http://schemas.openxmlformats.org/officeDocument/2006/relationships" xmlns:mc="http://schemas.openxmlformats.org/markup-compatibility/2006" xmlns:mv="urn:schemas-microsoft-com:mac:vml" xmlns:p="http://schemas.openxmlformats.org/presentationml/2006/main" xmlns:c="http://schemas.openxmlformats.org/drawingml/2006/chart" xmlns:dgm="http://schemas.openxmlformats.org/drawingml/2006/diagram" xmlns:o="urn:schemas-microsoft-com:office:office" xmlns:v="urn:schemas-microsoft-com:vml" xmlns:pvml="urn:schemas-microsoft-com:office:powerpoint" xmlns:com="http://schemas.openxmlformats.org/drawingml/2006/compatibility" xmlns:p14="http://schemas.microsoft.com/office/powerpoint/2010/main" xmlns:p15="http://schemas.microsoft.com/office/powerpoint/2012/main" xmlns:ahyp="http://schemas.microsoft.com/office/drawing/2018/hyperlinkcolor">
   <p:cSld>
     <p:spTree>
@@ -16993,7 +17174,7 @@
 </p:sld>
 </file>
 
-<file path=ppt/slides/slide26.xml><?xml version="1.0" encoding="utf-8"?>
+<file path=ppt/slides/slide27.xml><?xml version="1.0" encoding="utf-8"?>
 <p:sld xmlns:a="http://schemas.openxmlformats.org/drawingml/2006/main" xmlns:r="http://schemas.openxmlformats.org/officeDocument/2006/relationships" xmlns:mc="http://schemas.openxmlformats.org/markup-compatibility/2006" xmlns:mv="urn:schemas-microsoft-com:mac:vml" xmlns:p="http://schemas.openxmlformats.org/presentationml/2006/main" xmlns:c="http://schemas.openxmlformats.org/drawingml/2006/chart" xmlns:dgm="http://schemas.openxmlformats.org/drawingml/2006/diagram" xmlns:o="urn:schemas-microsoft-com:office:office" xmlns:v="urn:schemas-microsoft-com:vml" xmlns:pvml="urn:schemas-microsoft-com:office:powerpoint" xmlns:com="http://schemas.openxmlformats.org/drawingml/2006/compatibility" xmlns:p14="http://schemas.microsoft.com/office/powerpoint/2010/main" xmlns:p15="http://schemas.microsoft.com/office/powerpoint/2012/main" xmlns:ahyp="http://schemas.microsoft.com/office/drawing/2018/hyperlinkcolor">
   <p:cSld>
     <p:spTree>
@@ -17570,7 +17751,7 @@
 </p:sld>
 </file>
 
-<file path=ppt/slides/slide27.xml><?xml version="1.0" encoding="utf-8"?>
+<file path=ppt/slides/slide28.xml><?xml version="1.0" encoding="utf-8"?>
 <p:sld xmlns:a="http://schemas.openxmlformats.org/drawingml/2006/main" xmlns:r="http://schemas.openxmlformats.org/officeDocument/2006/relationships" xmlns:mc="http://schemas.openxmlformats.org/markup-compatibility/2006" xmlns:mv="urn:schemas-microsoft-com:mac:vml" xmlns:p="http://schemas.openxmlformats.org/presentationml/2006/main" xmlns:c="http://schemas.openxmlformats.org/drawingml/2006/chart" xmlns:dgm="http://schemas.openxmlformats.org/drawingml/2006/diagram" xmlns:o="urn:schemas-microsoft-com:office:office" xmlns:v="urn:schemas-microsoft-com:vml" xmlns:pvml="urn:schemas-microsoft-com:office:powerpoint" xmlns:com="http://schemas.openxmlformats.org/drawingml/2006/compatibility" xmlns:p14="http://schemas.microsoft.com/office/powerpoint/2010/main" xmlns:p15="http://schemas.microsoft.com/office/powerpoint/2012/main" xmlns:ahyp="http://schemas.microsoft.com/office/drawing/2018/hyperlinkcolor">
   <p:cSld>
     <p:spTree>
@@ -17821,7 +18002,7 @@
 </p:sld>
 </file>
 
-<file path=ppt/slides/slide28.xml><?xml version="1.0" encoding="utf-8"?>
+<file path=ppt/slides/slide29.xml><?xml version="1.0" encoding="utf-8"?>
 <p:sld xmlns:a="http://schemas.openxmlformats.org/drawingml/2006/main" xmlns:r="http://schemas.openxmlformats.org/officeDocument/2006/relationships" xmlns:mc="http://schemas.openxmlformats.org/markup-compatibility/2006" xmlns:mv="urn:schemas-microsoft-com:mac:vml" xmlns:p="http://schemas.openxmlformats.org/presentationml/2006/main" xmlns:c="http://schemas.openxmlformats.org/drawingml/2006/chart" xmlns:dgm="http://schemas.openxmlformats.org/drawingml/2006/diagram" xmlns:o="urn:schemas-microsoft-com:office:office" xmlns:v="urn:schemas-microsoft-com:vml" xmlns:pvml="urn:schemas-microsoft-com:office:powerpoint" xmlns:com="http://schemas.openxmlformats.org/drawingml/2006/compatibility" xmlns:p14="http://schemas.microsoft.com/office/powerpoint/2010/main" xmlns:p15="http://schemas.microsoft.com/office/powerpoint/2012/main" xmlns:ahyp="http://schemas.microsoft.com/office/drawing/2018/hyperlinkcolor">
   <p:cSld>
     <p:spTree>
@@ -17914,7 +18095,96 @@
 </p:sld>
 </file>
 
-<file path=ppt/slides/slide29.xml><?xml version="1.0" encoding="utf-8"?>
+<file path=ppt/slides/slide3.xml><?xml version="1.0" encoding="utf-8"?>
+<p:sld xmlns:a="http://schemas.openxmlformats.org/drawingml/2006/main" xmlns:r="http://schemas.openxmlformats.org/officeDocument/2006/relationships" xmlns:mc="http://schemas.openxmlformats.org/markup-compatibility/2006" xmlns:mv="urn:schemas-microsoft-com:mac:vml" xmlns:p="http://schemas.openxmlformats.org/presentationml/2006/main" xmlns:c="http://schemas.openxmlformats.org/drawingml/2006/chart" xmlns:dgm="http://schemas.openxmlformats.org/drawingml/2006/diagram" xmlns:o="urn:schemas-microsoft-com:office:office" xmlns:v="urn:schemas-microsoft-com:vml" xmlns:pvml="urn:schemas-microsoft-com:office:powerpoint" xmlns:com="http://schemas.openxmlformats.org/drawingml/2006/compatibility" xmlns:p14="http://schemas.microsoft.com/office/powerpoint/2010/main" xmlns:p15="http://schemas.microsoft.com/office/powerpoint/2012/main" xmlns:ahyp="http://schemas.microsoft.com/office/drawing/2018/hyperlinkcolor">
+  <p:cSld>
+    <p:spTree>
+      <p:nvGrpSpPr>
+        <p:cNvPr id="44" name="Shape 44"/>
+        <p:cNvGrpSpPr/>
+        <p:nvPr/>
+      </p:nvGrpSpPr>
+      <p:grpSpPr>
+        <a:xfrm>
+          <a:off x="0" y="0"/>
+          <a:ext cx="0" cy="0"/>
+          <a:chOff x="0" y="0"/>
+          <a:chExt cx="0" cy="0"/>
+        </a:xfrm>
+      </p:grpSpPr>
+      <p:sp>
+        <p:nvSpPr>
+          <p:cNvPr id="45" name="Google Shape;45;p10"/>
+          <p:cNvSpPr txBox="1"/>
+          <p:nvPr>
+            <p:ph type="title"/>
+          </p:nvPr>
+        </p:nvSpPr>
+        <p:spPr>
+          <a:xfrm>
+            <a:off x="311700" y="195615"/>
+            <a:ext cx="8520600" cy="572700"/>
+          </a:xfrm>
+          <a:prstGeom prst="rect">
+            <a:avLst/>
+          </a:prstGeom>
+        </p:spPr>
+        <p:txBody>
+          <a:bodyPr anchorCtr="0" anchor="t" bIns="91425" lIns="91425" spcFirstLastPara="1" rIns="91425" wrap="square" tIns="91425">
+            <a:normAutofit fontScale="90000"/>
+          </a:bodyPr>
+          <a:lstStyle/>
+          <a:p>
+            <a:pPr indent="0" lvl="0" marL="0" rtl="0" algn="l">
+              <a:spcBef>
+                <a:spcPts val="0"/>
+              </a:spcBef>
+              <a:spcAft>
+                <a:spcPts val="0"/>
+              </a:spcAft>
+              <a:buNone/>
+            </a:pPr>
+            <a:r>
+              <a:rPr lang="en"/>
+              <a:t>Today’s Goal</a:t>
+            </a:r>
+            <a:endParaRPr/>
+          </a:p>
+        </p:txBody>
+      </p:sp>
+      <p:pic>
+        <p:nvPicPr>
+          <p:cNvPr id="46" name="Picture 46" descr="gif-flappy.gif"/>
+          <p:cNvPicPr>
+            <a:picLocks noChangeAspect="1"/>
+          </p:cNvPicPr>
+          <p:nvPr/>
+        </p:nvPicPr>
+        <p:blipFill>
+          <a:blip r:embed="rId4"/>
+          <a:stretch>
+            <a:fillRect/>
+          </a:stretch>
+        </p:blipFill>
+        <p:spPr>
+          <a:xfrm>
+            <a:off x="1566089" y="1322900"/>
+            <a:ext cx="6011824" cy="3381651"/>
+          </a:xfrm>
+          <a:prstGeom prst="rect">
+            <a:avLst/>
+          </a:prstGeom>
+        </p:spPr>
+      </p:pic>
+    </p:spTree>
+  </p:cSld>
+  <p:clrMapOvr>
+    <a:masterClrMapping/>
+  </p:clrMapOvr>
+</p:sld>
+</file>
+
+<file path=ppt/slides/slide30.xml><?xml version="1.0" encoding="utf-8"?>
 <p:sld xmlns:a="http://schemas.openxmlformats.org/drawingml/2006/main" xmlns:r="http://schemas.openxmlformats.org/officeDocument/2006/relationships" xmlns:mc="http://schemas.openxmlformats.org/markup-compatibility/2006" xmlns:mv="urn:schemas-microsoft-com:mac:vml" xmlns:p="http://schemas.openxmlformats.org/presentationml/2006/main" xmlns:c="http://schemas.openxmlformats.org/drawingml/2006/chart" xmlns:dgm="http://schemas.openxmlformats.org/drawingml/2006/diagram" xmlns:o="urn:schemas-microsoft-com:office:office" xmlns:v="urn:schemas-microsoft-com:vml" xmlns:pvml="urn:schemas-microsoft-com:office:powerpoint" xmlns:com="http://schemas.openxmlformats.org/drawingml/2006/compatibility" xmlns:p14="http://schemas.microsoft.com/office/powerpoint/2010/main" xmlns:p15="http://schemas.microsoft.com/office/powerpoint/2012/main" xmlns:ahyp="http://schemas.microsoft.com/office/drawing/2018/hyperlinkcolor">
   <p:cSld>
     <p:spTree>
@@ -17967,654 +18237,7 @@
 </p:sld>
 </file>
 
-<file path=ppt/slides/slide3.xml><?xml version="1.0" encoding="utf-8"?>
-<p:sld xmlns:a="http://schemas.openxmlformats.org/drawingml/2006/main" xmlns:r="http://schemas.openxmlformats.org/officeDocument/2006/relationships" xmlns:mc="http://schemas.openxmlformats.org/markup-compatibility/2006" xmlns:mv="urn:schemas-microsoft-com:mac:vml" xmlns:p="http://schemas.openxmlformats.org/presentationml/2006/main" xmlns:c="http://schemas.openxmlformats.org/drawingml/2006/chart" xmlns:dgm="http://schemas.openxmlformats.org/drawingml/2006/diagram" xmlns:o="urn:schemas-microsoft-com:office:office" xmlns:v="urn:schemas-microsoft-com:vml" xmlns:pvml="urn:schemas-microsoft-com:office:powerpoint" xmlns:com="http://schemas.openxmlformats.org/drawingml/2006/compatibility" xmlns:p14="http://schemas.microsoft.com/office/powerpoint/2010/main" xmlns:p15="http://schemas.microsoft.com/office/powerpoint/2012/main" xmlns:ahyp="http://schemas.microsoft.com/office/drawing/2018/hyperlinkcolor">
-  <p:cSld>
-    <p:spTree>
-      <p:nvGrpSpPr>
-        <p:cNvPr id="50" name="Shape 50"/>
-        <p:cNvGrpSpPr/>
-        <p:nvPr/>
-      </p:nvGrpSpPr>
-      <p:grpSpPr>
-        <a:xfrm>
-          <a:off x="0" y="0"/>
-          <a:ext cx="0" cy="0"/>
-          <a:chOff x="0" y="0"/>
-          <a:chExt cx="0" cy="0"/>
-        </a:xfrm>
-      </p:grpSpPr>
-      <p:sp>
-        <p:nvSpPr>
-          <p:cNvPr id="51" name="Google Shape;51;p11"/>
-          <p:cNvSpPr txBox="1"/>
-          <p:nvPr>
-            <p:ph type="title"/>
-          </p:nvPr>
-        </p:nvSpPr>
-        <p:spPr>
-          <a:xfrm>
-            <a:off x="311700" y="195615"/>
-            <a:ext cx="8520600" cy="572700"/>
-          </a:xfrm>
-          <a:prstGeom prst="rect">
-            <a:avLst/>
-          </a:prstGeom>
-        </p:spPr>
-        <p:txBody>
-          <a:bodyPr anchorCtr="0" anchor="t" bIns="91425" lIns="91425" spcFirstLastPara="1" rIns="91425" wrap="square" tIns="91425">
-            <a:normAutofit fontScale="90000"/>
-          </a:bodyPr>
-          <a:lstStyle/>
-          <a:p>
-            <a:pPr indent="0" lvl="0" marL="0" rtl="0" algn="l">
-              <a:spcBef>
-                <a:spcPts val="0"/>
-              </a:spcBef>
-              <a:spcAft>
-                <a:spcPts val="0"/>
-              </a:spcAft>
-              <a:buNone/>
-            </a:pPr>
-            <a:r>
-              <a:rPr lang="en"/>
-              <a:t>Today’s Topics</a:t>
-            </a:r>
-            <a:endParaRPr/>
-          </a:p>
-        </p:txBody>
-      </p:sp>
-      <p:sp>
-        <p:nvSpPr>
-          <p:cNvPr id="52" name="Google Shape;52;p11"/>
-          <p:cNvSpPr txBox="1"/>
-          <p:nvPr>
-            <p:ph idx="1" type="body"/>
-          </p:nvPr>
-        </p:nvSpPr>
-        <p:spPr>
-          <a:xfrm>
-            <a:off x="311700" y="885950"/>
-            <a:ext cx="8520600" cy="4023300"/>
-          </a:xfrm>
-          <a:prstGeom prst="rect">
-            <a:avLst/>
-          </a:prstGeom>
-        </p:spPr>
-        <p:txBody>
-          <a:bodyPr anchorCtr="0" anchor="t" bIns="91425" lIns="91425" spcFirstLastPara="1" rIns="91425" wrap="square" tIns="91425">
-            <a:normAutofit/>
-          </a:bodyPr>
-          <a:lstStyle/>
-          <a:p>
-            <a:pPr indent="-330200" lvl="0" marL="457200" rtl="0" algn="l">
-              <a:spcBef>
-                <a:spcPts val="0"/>
-              </a:spcBef>
-              <a:spcAft>
-                <a:spcPts val="0"/>
-              </a:spcAft>
-              <a:buSzPts val="1600"/>
-              <a:buChar char="●"/>
-            </a:pPr>
-            <a:r>
-              <a:rPr lang="en"/>
-              <a:t>Game Architecture</a:t>
-            </a:r>
-            <a:endParaRPr/>
-          </a:p>
-          <a:p>
-            <a:pPr indent="-330200" lvl="0" marL="457200" rtl="0" algn="l">
-              <a:spcBef>
-                <a:spcPts val="0"/>
-              </a:spcBef>
-              <a:spcAft>
-                <a:spcPts val="0"/>
-              </a:spcAft>
-              <a:buSzPts val="1600"/>
-              <a:buChar char="●"/>
-            </a:pPr>
-            <a:r>
-              <a:rPr lang="en"/>
-              <a:t>Class Libraries</a:t>
-            </a:r>
-            <a:endParaRPr/>
-          </a:p>
-          <a:p>
-            <a:pPr indent="-330200" lvl="0" marL="457200" rtl="0" algn="l">
-              <a:spcBef>
-                <a:spcPts val="0"/>
-              </a:spcBef>
-              <a:spcAft>
-                <a:spcPts val="0"/>
-              </a:spcAft>
-              <a:buSzPts val="1600"/>
-              <a:buChar char="●"/>
-            </a:pPr>
-            <a:r>
-              <a:rPr lang="en"/>
-              <a:t>Images</a:t>
-            </a:r>
-            <a:endParaRPr/>
-          </a:p>
-          <a:p>
-            <a:pPr indent="-330200" lvl="0" marL="457200" rtl="0" algn="l">
-              <a:spcBef>
-                <a:spcPts val="0"/>
-              </a:spcBef>
-              <a:spcAft>
-                <a:spcPts val="0"/>
-              </a:spcAft>
-              <a:buSzPts val="1600"/>
-              <a:buChar char="●"/>
-            </a:pPr>
-            <a:r>
-              <a:rPr lang="en"/>
-              <a:t>Infinite Scrolling</a:t>
-            </a:r>
-            <a:endParaRPr/>
-          </a:p>
-          <a:p>
-            <a:pPr indent="-330200" lvl="0" marL="457200" rtl="0" algn="l">
-              <a:spcBef>
-                <a:spcPts val="0"/>
-              </a:spcBef>
-              <a:spcAft>
-                <a:spcPts val="0"/>
-              </a:spcAft>
-              <a:buSzPts val="1600"/>
-              <a:buChar char="●"/>
-            </a:pPr>
-            <a:r>
-              <a:rPr lang="en"/>
-              <a:t>Procedural Generation</a:t>
-            </a:r>
-            <a:endParaRPr/>
-          </a:p>
-          <a:p>
-            <a:pPr indent="-330200" lvl="0" marL="457200" rtl="0" algn="l">
-              <a:spcBef>
-                <a:spcPts val="0"/>
-              </a:spcBef>
-              <a:spcAft>
-                <a:spcPts val="0"/>
-              </a:spcAft>
-              <a:buSzPts val="1600"/>
-              <a:buChar char="●"/>
-            </a:pPr>
-            <a:r>
-              <a:rPr lang="en"/>
-              <a:t>Interfaces</a:t>
-            </a:r>
-            <a:endParaRPr/>
-          </a:p>
-          <a:p>
-            <a:pPr indent="-330200" lvl="0" marL="457200" rtl="0" algn="l">
-              <a:spcBef>
-                <a:spcPts val="0"/>
-              </a:spcBef>
-              <a:spcAft>
-                <a:spcPts val="0"/>
-              </a:spcAft>
-              <a:buSzPts val="1600"/>
-              <a:buChar char="●"/>
-            </a:pPr>
-            <a:r>
-              <a:rPr lang="en"/>
-              <a:t>State Machines</a:t>
-            </a:r>
-            <a:endParaRPr/>
-          </a:p>
-          <a:p>
-            <a:pPr indent="-330200" lvl="0" marL="457200" rtl="0" algn="l">
-              <a:spcBef>
-                <a:spcPts val="0"/>
-              </a:spcBef>
-              <a:spcAft>
-                <a:spcPts val="0"/>
-              </a:spcAft>
-              <a:buSzPts val="1600"/>
-              <a:buChar char="●"/>
-            </a:pPr>
-            <a:r>
-              <a:rPr lang="en"/>
-              <a:t>Singleton Pattern</a:t>
-            </a:r>
-            <a:endParaRPr/>
-          </a:p>
-        </p:txBody>
-      </p:sp>
-    </p:spTree>
-  </p:cSld>
-  <p:clrMapOvr>
-    <a:masterClrMapping/>
-  </p:clrMapOvr>
-  <p:timing>
-    <p:tnLst>
-      <p:par>
-        <p:cTn dur="indefinite" nodeType="tmRoot" restart="never">
-          <p:childTnLst>
-            <p:seq concurrent="1" nextAc="seek">
-              <p:cTn dur="indefinite" id="2" nodeType="mainSeq">
-                <p:childTnLst>
-                  <p:par>
-                    <p:cTn fill="hold">
-                      <p:stCondLst>
-                        <p:cond delay="indefinite"/>
-                      </p:stCondLst>
-                      <p:childTnLst>
-                        <p:par>
-                          <p:cTn fill="hold">
-                            <p:stCondLst>
-                              <p:cond delay="0"/>
-                            </p:stCondLst>
-                            <p:childTnLst>
-                              <p:par>
-                                <p:cTn fill="hold" nodeType="clickEffect" presetClass="entr" presetID="1" presetSubtype="0">
-                                  <p:stCondLst>
-                                    <p:cond delay="0"/>
-                                  </p:stCondLst>
-                                  <p:childTnLst>
-                                    <p:set>
-                                      <p:cBhvr>
-                                        <p:cTn dur="1" fill="hold">
-                                          <p:stCondLst>
-                                            <p:cond delay="0"/>
-                                          </p:stCondLst>
-                                        </p:cTn>
-                                        <p:tgtEl>
-                                          <p:spTgt spid="52">
-                                            <p:txEl>
-                                              <p:pRg end="0" st="0"/>
-                                            </p:txEl>
-                                          </p:spTgt>
-                                        </p:tgtEl>
-                                        <p:attrNameLst>
-                                          <p:attrName>style.visibility</p:attrName>
-                                        </p:attrNameLst>
-                                      </p:cBhvr>
-                                      <p:to>
-                                        <p:strVal val="visible"/>
-                                      </p:to>
-                                    </p:set>
-                                  </p:childTnLst>
-                                </p:cTn>
-                              </p:par>
-                            </p:childTnLst>
-                          </p:cTn>
-                        </p:par>
-                      </p:childTnLst>
-                    </p:cTn>
-                  </p:par>
-                  <p:par>
-                    <p:cTn fill="hold">
-                      <p:stCondLst>
-                        <p:cond delay="indefinite"/>
-                      </p:stCondLst>
-                      <p:childTnLst>
-                        <p:par>
-                          <p:cTn fill="hold">
-                            <p:stCondLst>
-                              <p:cond delay="0"/>
-                            </p:stCondLst>
-                            <p:childTnLst>
-                              <p:par>
-                                <p:cTn fill="hold" nodeType="clickEffect" presetClass="entr" presetID="1" presetSubtype="0">
-                                  <p:stCondLst>
-                                    <p:cond delay="0"/>
-                                  </p:stCondLst>
-                                  <p:childTnLst>
-                                    <p:set>
-                                      <p:cBhvr>
-                                        <p:cTn dur="1" fill="hold">
-                                          <p:stCondLst>
-                                            <p:cond delay="0"/>
-                                          </p:stCondLst>
-                                        </p:cTn>
-                                        <p:tgtEl>
-                                          <p:spTgt spid="52">
-                                            <p:txEl>
-                                              <p:pRg end="1" st="1"/>
-                                            </p:txEl>
-                                          </p:spTgt>
-                                        </p:tgtEl>
-                                        <p:attrNameLst>
-                                          <p:attrName>style.visibility</p:attrName>
-                                        </p:attrNameLst>
-                                      </p:cBhvr>
-                                      <p:to>
-                                        <p:strVal val="visible"/>
-                                      </p:to>
-                                    </p:set>
-                                  </p:childTnLst>
-                                </p:cTn>
-                              </p:par>
-                            </p:childTnLst>
-                          </p:cTn>
-                        </p:par>
-                      </p:childTnLst>
-                    </p:cTn>
-                  </p:par>
-                  <p:par>
-                    <p:cTn fill="hold">
-                      <p:stCondLst>
-                        <p:cond delay="indefinite"/>
-                      </p:stCondLst>
-                      <p:childTnLst>
-                        <p:par>
-                          <p:cTn fill="hold">
-                            <p:stCondLst>
-                              <p:cond delay="0"/>
-                            </p:stCondLst>
-                            <p:childTnLst>
-                              <p:par>
-                                <p:cTn fill="hold" nodeType="clickEffect" presetClass="entr" presetID="1" presetSubtype="0">
-                                  <p:stCondLst>
-                                    <p:cond delay="0"/>
-                                  </p:stCondLst>
-                                  <p:childTnLst>
-                                    <p:set>
-                                      <p:cBhvr>
-                                        <p:cTn dur="1" fill="hold">
-                                          <p:stCondLst>
-                                            <p:cond delay="0"/>
-                                          </p:stCondLst>
-                                        </p:cTn>
-                                        <p:tgtEl>
-                                          <p:spTgt spid="52">
-                                            <p:txEl>
-                                              <p:pRg end="2" st="2"/>
-                                            </p:txEl>
-                                          </p:spTgt>
-                                        </p:tgtEl>
-                                        <p:attrNameLst>
-                                          <p:attrName>style.visibility</p:attrName>
-                                        </p:attrNameLst>
-                                      </p:cBhvr>
-                                      <p:to>
-                                        <p:strVal val="visible"/>
-                                      </p:to>
-                                    </p:set>
-                                  </p:childTnLst>
-                                </p:cTn>
-                              </p:par>
-                            </p:childTnLst>
-                          </p:cTn>
-                        </p:par>
-                      </p:childTnLst>
-                    </p:cTn>
-                  </p:par>
-                  <p:par>
-                    <p:cTn fill="hold">
-                      <p:stCondLst>
-                        <p:cond delay="indefinite"/>
-                      </p:stCondLst>
-                      <p:childTnLst>
-                        <p:par>
-                          <p:cTn fill="hold">
-                            <p:stCondLst>
-                              <p:cond delay="0"/>
-                            </p:stCondLst>
-                            <p:childTnLst>
-                              <p:par>
-                                <p:cTn fill="hold" nodeType="clickEffect" presetClass="entr" presetID="1" presetSubtype="0">
-                                  <p:stCondLst>
-                                    <p:cond delay="0"/>
-                                  </p:stCondLst>
-                                  <p:childTnLst>
-                                    <p:set>
-                                      <p:cBhvr>
-                                        <p:cTn dur="1" fill="hold">
-                                          <p:stCondLst>
-                                            <p:cond delay="0"/>
-                                          </p:stCondLst>
-                                        </p:cTn>
-                                        <p:tgtEl>
-                                          <p:spTgt spid="52">
-                                            <p:txEl>
-                                              <p:pRg end="3" st="3"/>
-                                            </p:txEl>
-                                          </p:spTgt>
-                                        </p:tgtEl>
-                                        <p:attrNameLst>
-                                          <p:attrName>style.visibility</p:attrName>
-                                        </p:attrNameLst>
-                                      </p:cBhvr>
-                                      <p:to>
-                                        <p:strVal val="visible"/>
-                                      </p:to>
-                                    </p:set>
-                                  </p:childTnLst>
-                                </p:cTn>
-                              </p:par>
-                            </p:childTnLst>
-                          </p:cTn>
-                        </p:par>
-                      </p:childTnLst>
-                    </p:cTn>
-                  </p:par>
-                  <p:par>
-                    <p:cTn fill="hold">
-                      <p:stCondLst>
-                        <p:cond delay="indefinite"/>
-                      </p:stCondLst>
-                      <p:childTnLst>
-                        <p:par>
-                          <p:cTn fill="hold">
-                            <p:stCondLst>
-                              <p:cond delay="0"/>
-                            </p:stCondLst>
-                            <p:childTnLst>
-                              <p:par>
-                                <p:cTn fill="hold" nodeType="clickEffect" presetClass="entr" presetID="1" presetSubtype="0">
-                                  <p:stCondLst>
-                                    <p:cond delay="0"/>
-                                  </p:stCondLst>
-                                  <p:childTnLst>
-                                    <p:set>
-                                      <p:cBhvr>
-                                        <p:cTn dur="1" fill="hold">
-                                          <p:stCondLst>
-                                            <p:cond delay="0"/>
-                                          </p:stCondLst>
-                                        </p:cTn>
-                                        <p:tgtEl>
-                                          <p:spTgt spid="52">
-                                            <p:txEl>
-                                              <p:pRg end="4" st="4"/>
-                                            </p:txEl>
-                                          </p:spTgt>
-                                        </p:tgtEl>
-                                        <p:attrNameLst>
-                                          <p:attrName>style.visibility</p:attrName>
-                                        </p:attrNameLst>
-                                      </p:cBhvr>
-                                      <p:to>
-                                        <p:strVal val="visible"/>
-                                      </p:to>
-                                    </p:set>
-                                  </p:childTnLst>
-                                </p:cTn>
-                              </p:par>
-                            </p:childTnLst>
-                          </p:cTn>
-                        </p:par>
-                      </p:childTnLst>
-                    </p:cTn>
-                  </p:par>
-                  <p:par>
-                    <p:cTn fill="hold">
-                      <p:stCondLst>
-                        <p:cond delay="indefinite"/>
-                      </p:stCondLst>
-                      <p:childTnLst>
-                        <p:par>
-                          <p:cTn fill="hold">
-                            <p:stCondLst>
-                              <p:cond delay="0"/>
-                            </p:stCondLst>
-                            <p:childTnLst>
-                              <p:par>
-                                <p:cTn fill="hold" nodeType="clickEffect" presetClass="entr" presetID="1" presetSubtype="0">
-                                  <p:stCondLst>
-                                    <p:cond delay="0"/>
-                                  </p:stCondLst>
-                                  <p:childTnLst>
-                                    <p:set>
-                                      <p:cBhvr>
-                                        <p:cTn dur="1" fill="hold">
-                                          <p:stCondLst>
-                                            <p:cond delay="0"/>
-                                          </p:stCondLst>
-                                        </p:cTn>
-                                        <p:tgtEl>
-                                          <p:spTgt spid="52">
-                                            <p:txEl>
-                                              <p:pRg end="5" st="5"/>
-                                            </p:txEl>
-                                          </p:spTgt>
-                                        </p:tgtEl>
-                                        <p:attrNameLst>
-                                          <p:attrName>style.visibility</p:attrName>
-                                        </p:attrNameLst>
-                                      </p:cBhvr>
-                                      <p:to>
-                                        <p:strVal val="visible"/>
-                                      </p:to>
-                                    </p:set>
-                                  </p:childTnLst>
-                                </p:cTn>
-                              </p:par>
-                            </p:childTnLst>
-                          </p:cTn>
-                        </p:par>
-                      </p:childTnLst>
-                    </p:cTn>
-                  </p:par>
-                  <p:par>
-                    <p:cTn fill="hold">
-                      <p:stCondLst>
-                        <p:cond delay="indefinite"/>
-                      </p:stCondLst>
-                      <p:childTnLst>
-                        <p:par>
-                          <p:cTn fill="hold">
-                            <p:stCondLst>
-                              <p:cond delay="0"/>
-                            </p:stCondLst>
-                            <p:childTnLst>
-                              <p:par>
-                                <p:cTn fill="hold" nodeType="clickEffect" presetClass="entr" presetID="1" presetSubtype="0">
-                                  <p:stCondLst>
-                                    <p:cond delay="0"/>
-                                  </p:stCondLst>
-                                  <p:childTnLst>
-                                    <p:set>
-                                      <p:cBhvr>
-                                        <p:cTn dur="1" fill="hold">
-                                          <p:stCondLst>
-                                            <p:cond delay="0"/>
-                                          </p:stCondLst>
-                                        </p:cTn>
-                                        <p:tgtEl>
-                                          <p:spTgt spid="52">
-                                            <p:txEl>
-                                              <p:pRg end="6" st="6"/>
-                                            </p:txEl>
-                                          </p:spTgt>
-                                        </p:tgtEl>
-                                        <p:attrNameLst>
-                                          <p:attrName>style.visibility</p:attrName>
-                                        </p:attrNameLst>
-                                      </p:cBhvr>
-                                      <p:to>
-                                        <p:strVal val="visible"/>
-                                      </p:to>
-                                    </p:set>
-                                  </p:childTnLst>
-                                </p:cTn>
-                              </p:par>
-                            </p:childTnLst>
-                          </p:cTn>
-                        </p:par>
-                      </p:childTnLst>
-                    </p:cTn>
-                  </p:par>
-                  <p:par>
-                    <p:cTn fill="hold">
-                      <p:stCondLst>
-                        <p:cond delay="indefinite"/>
-                      </p:stCondLst>
-                      <p:childTnLst>
-                        <p:par>
-                          <p:cTn fill="hold">
-                            <p:stCondLst>
-                              <p:cond delay="0"/>
-                            </p:stCondLst>
-                            <p:childTnLst>
-                              <p:par>
-                                <p:cTn fill="hold" nodeType="clickEffect" presetClass="entr" presetID="1" presetSubtype="0">
-                                  <p:stCondLst>
-                                    <p:cond delay="0"/>
-                                  </p:stCondLst>
-                                  <p:childTnLst>
-                                    <p:set>
-                                      <p:cBhvr>
-                                        <p:cTn dur="1" fill="hold">
-                                          <p:stCondLst>
-                                            <p:cond delay="0"/>
-                                          </p:stCondLst>
-                                        </p:cTn>
-                                        <p:tgtEl>
-                                          <p:spTgt spid="52">
-                                            <p:txEl>
-                                              <p:pRg end="7" st="7"/>
-                                            </p:txEl>
-                                          </p:spTgt>
-                                        </p:tgtEl>
-                                        <p:attrNameLst>
-                                          <p:attrName>style.visibility</p:attrName>
-                                        </p:attrNameLst>
-                                      </p:cBhvr>
-                                      <p:to>
-                                        <p:strVal val="visible"/>
-                                      </p:to>
-                                    </p:set>
-                                  </p:childTnLst>
-                                </p:cTn>
-                              </p:par>
-                            </p:childTnLst>
-                          </p:cTn>
-                        </p:par>
-                      </p:childTnLst>
-                    </p:cTn>
-                  </p:par>
-                </p:childTnLst>
-              </p:cTn>
-              <p:prevCondLst>
-                <p:cond evt="onPrev">
-                  <p:tgtEl>
-                    <p:sldTgt/>
-                  </p:tgtEl>
-                </p:cond>
-              </p:prevCondLst>
-              <p:nextCondLst>
-                <p:cond evt="onNext">
-                  <p:tgtEl>
-                    <p:sldTgt/>
-                  </p:tgtEl>
-                </p:cond>
-              </p:nextCondLst>
-            </p:seq>
-          </p:childTnLst>
-        </p:cTn>
-      </p:par>
-    </p:tnLst>
-  </p:timing>
-</p:sld>
-</file>
-
-<file path=ppt/slides/slide30.xml><?xml version="1.0" encoding="utf-8"?>
+<file path=ppt/slides/slide31.xml><?xml version="1.0" encoding="utf-8"?>
 <p:sld xmlns:a="http://schemas.openxmlformats.org/drawingml/2006/main" xmlns:r="http://schemas.openxmlformats.org/officeDocument/2006/relationships" xmlns:mc="http://schemas.openxmlformats.org/markup-compatibility/2006" xmlns:mv="urn:schemas-microsoft-com:mac:vml" xmlns:p="http://schemas.openxmlformats.org/presentationml/2006/main" xmlns:c="http://schemas.openxmlformats.org/drawingml/2006/chart" xmlns:dgm="http://schemas.openxmlformats.org/drawingml/2006/diagram" xmlns:o="urn:schemas-microsoft-com:office:office" xmlns:v="urn:schemas-microsoft-com:vml" xmlns:pvml="urn:schemas-microsoft-com:office:powerpoint" xmlns:com="http://schemas.openxmlformats.org/drawingml/2006/compatibility" xmlns:p14="http://schemas.microsoft.com/office/powerpoint/2010/main" xmlns:p15="http://schemas.microsoft.com/office/powerpoint/2012/main" xmlns:ahyp="http://schemas.microsoft.com/office/drawing/2018/hyperlinkcolor">
   <p:cSld>
     <p:spTree>
@@ -20717,7 +20340,7 @@
 </p:sld>
 </file>
 
-<file path=ppt/slides/slide31.xml><?xml version="1.0" encoding="utf-8"?>
+<file path=ppt/slides/slide32.xml><?xml version="1.0" encoding="utf-8"?>
 <p:sld xmlns:a="http://schemas.openxmlformats.org/drawingml/2006/main" xmlns:r="http://schemas.openxmlformats.org/officeDocument/2006/relationships" xmlns:mc="http://schemas.openxmlformats.org/markup-compatibility/2006" xmlns:mv="urn:schemas-microsoft-com:mac:vml" xmlns:p="http://schemas.openxmlformats.org/presentationml/2006/main" xmlns:c="http://schemas.openxmlformats.org/drawingml/2006/chart" xmlns:dgm="http://schemas.openxmlformats.org/drawingml/2006/diagram" xmlns:o="urn:schemas-microsoft-com:office:office" xmlns:v="urn:schemas-microsoft-com:vml" xmlns:pvml="urn:schemas-microsoft-com:office:powerpoint" xmlns:com="http://schemas.openxmlformats.org/drawingml/2006/compatibility" xmlns:p14="http://schemas.microsoft.com/office/powerpoint/2010/main" xmlns:p15="http://schemas.microsoft.com/office/powerpoint/2012/main" xmlns:ahyp="http://schemas.microsoft.com/office/drawing/2018/hyperlinkcolor">
   <p:cSld>
     <p:spTree>
@@ -23371,7 +22994,7 @@
 </p:sld>
 </file>
 
-<file path=ppt/slides/slide32.xml><?xml version="1.0" encoding="utf-8"?>
+<file path=ppt/slides/slide33.xml><?xml version="1.0" encoding="utf-8"?>
 <p:sld xmlns:a="http://schemas.openxmlformats.org/drawingml/2006/main" xmlns:r="http://schemas.openxmlformats.org/officeDocument/2006/relationships" xmlns:mc="http://schemas.openxmlformats.org/markup-compatibility/2006" xmlns:mv="urn:schemas-microsoft-com:mac:vml" xmlns:p="http://schemas.openxmlformats.org/presentationml/2006/main" xmlns:c="http://schemas.openxmlformats.org/drawingml/2006/chart" xmlns:dgm="http://schemas.openxmlformats.org/drawingml/2006/diagram" xmlns:o="urn:schemas-microsoft-com:office:office" xmlns:v="urn:schemas-microsoft-com:vml" xmlns:pvml="urn:schemas-microsoft-com:office:powerpoint" xmlns:com="http://schemas.openxmlformats.org/drawingml/2006/compatibility" xmlns:p14="http://schemas.microsoft.com/office/powerpoint/2010/main" xmlns:p15="http://schemas.microsoft.com/office/powerpoint/2012/main" xmlns:ahyp="http://schemas.microsoft.com/office/drawing/2018/hyperlinkcolor">
   <p:cSld>
     <p:spTree>
@@ -24487,7 +24110,7 @@
 </p:sld>
 </file>
 
-<file path=ppt/slides/slide33.xml><?xml version="1.0" encoding="utf-8"?>
+<file path=ppt/slides/slide34.xml><?xml version="1.0" encoding="utf-8"?>
 <p:sld xmlns:a="http://schemas.openxmlformats.org/drawingml/2006/main" xmlns:r="http://schemas.openxmlformats.org/officeDocument/2006/relationships" xmlns:mc="http://schemas.openxmlformats.org/markup-compatibility/2006" xmlns:mv="urn:schemas-microsoft-com:mac:vml" xmlns:p="http://schemas.openxmlformats.org/presentationml/2006/main" xmlns:c="http://schemas.openxmlformats.org/drawingml/2006/chart" xmlns:dgm="http://schemas.openxmlformats.org/drawingml/2006/diagram" xmlns:o="urn:schemas-microsoft-com:office:office" xmlns:v="urn:schemas-microsoft-com:vml" xmlns:pvml="urn:schemas-microsoft-com:office:powerpoint" xmlns:com="http://schemas.openxmlformats.org/drawingml/2006/compatibility" xmlns:p14="http://schemas.microsoft.com/office/powerpoint/2010/main" xmlns:p15="http://schemas.microsoft.com/office/powerpoint/2012/main" xmlns:ahyp="http://schemas.microsoft.com/office/drawing/2018/hyperlinkcolor">
   <p:cSld>
     <p:spTree>
@@ -25162,7 +24785,7 @@
 </p:sld>
 </file>
 
-<file path=ppt/slides/slide34.xml><?xml version="1.0" encoding="utf-8"?>
+<file path=ppt/slides/slide35.xml><?xml version="1.0" encoding="utf-8"?>
 <p:sld xmlns:a="http://schemas.openxmlformats.org/drawingml/2006/main" xmlns:r="http://schemas.openxmlformats.org/officeDocument/2006/relationships" xmlns:mc="http://schemas.openxmlformats.org/markup-compatibility/2006" xmlns:mv="urn:schemas-microsoft-com:mac:vml" xmlns:p="http://schemas.openxmlformats.org/presentationml/2006/main" xmlns:c="http://schemas.openxmlformats.org/drawingml/2006/chart" xmlns:dgm="http://schemas.openxmlformats.org/drawingml/2006/diagram" xmlns:o="urn:schemas-microsoft-com:office:office" xmlns:v="urn:schemas-microsoft-com:vml" xmlns:pvml="urn:schemas-microsoft-com:office:powerpoint" xmlns:com="http://schemas.openxmlformats.org/drawingml/2006/compatibility" xmlns:p14="http://schemas.microsoft.com/office/powerpoint/2010/main" xmlns:p15="http://schemas.microsoft.com/office/powerpoint/2012/main" xmlns:ahyp="http://schemas.microsoft.com/office/drawing/2018/hyperlinkcolor">
   <p:cSld>
     <p:spTree>
@@ -25673,7 +25296,7 @@
 </p:sld>
 </file>
 
-<file path=ppt/slides/slide35.xml><?xml version="1.0" encoding="utf-8"?>
+<file path=ppt/slides/slide36.xml><?xml version="1.0" encoding="utf-8"?>
 <p:sld xmlns:a="http://schemas.openxmlformats.org/drawingml/2006/main" xmlns:r="http://schemas.openxmlformats.org/officeDocument/2006/relationships" xmlns:mc="http://schemas.openxmlformats.org/markup-compatibility/2006" xmlns:mv="urn:schemas-microsoft-com:mac:vml" xmlns:p="http://schemas.openxmlformats.org/presentationml/2006/main" xmlns:c="http://schemas.openxmlformats.org/drawingml/2006/chart" xmlns:dgm="http://schemas.openxmlformats.org/drawingml/2006/diagram" xmlns:o="urn:schemas-microsoft-com:office:office" xmlns:v="urn:schemas-microsoft-com:vml" xmlns:pvml="urn:schemas-microsoft-com:office:powerpoint" xmlns:com="http://schemas.openxmlformats.org/drawingml/2006/compatibility" xmlns:p14="http://schemas.microsoft.com/office/powerpoint/2010/main" xmlns:p15="http://schemas.microsoft.com/office/powerpoint/2012/main" xmlns:ahyp="http://schemas.microsoft.com/office/drawing/2018/hyperlinkcolor">
   <p:cSld>
     <p:spTree>
@@ -26340,7 +25963,7 @@
 </p:sld>
 </file>
 
-<file path=ppt/slides/slide36.xml><?xml version="1.0" encoding="utf-8"?>
+<file path=ppt/slides/slide37.xml><?xml version="1.0" encoding="utf-8"?>
 <p:sld xmlns:a="http://schemas.openxmlformats.org/drawingml/2006/main" xmlns:r="http://schemas.openxmlformats.org/officeDocument/2006/relationships" xmlns:mc="http://schemas.openxmlformats.org/markup-compatibility/2006" xmlns:mv="urn:schemas-microsoft-com:mac:vml" xmlns:p="http://schemas.openxmlformats.org/presentationml/2006/main" xmlns:c="http://schemas.openxmlformats.org/drawingml/2006/chart" xmlns:dgm="http://schemas.openxmlformats.org/drawingml/2006/diagram" xmlns:o="urn:schemas-microsoft-com:office:office" xmlns:v="urn:schemas-microsoft-com:vml" xmlns:pvml="urn:schemas-microsoft-com:office:powerpoint" xmlns:com="http://schemas.openxmlformats.org/drawingml/2006/compatibility" xmlns:p14="http://schemas.microsoft.com/office/powerpoint/2010/main" xmlns:p15="http://schemas.microsoft.com/office/powerpoint/2012/main" xmlns:ahyp="http://schemas.microsoft.com/office/drawing/2018/hyperlinkcolor">
   <p:cSld>
     <p:spTree>
@@ -26473,7 +26096,7 @@
 </p:sld>
 </file>
 
-<file path=ppt/slides/slide37.xml><?xml version="1.0" encoding="utf-8"?>
+<file path=ppt/slides/slide38.xml><?xml version="1.0" encoding="utf-8"?>
 <p:sld xmlns:a="http://schemas.openxmlformats.org/drawingml/2006/main" xmlns:r="http://schemas.openxmlformats.org/officeDocument/2006/relationships" xmlns:mc="http://schemas.openxmlformats.org/markup-compatibility/2006" xmlns:mv="urn:schemas-microsoft-com:mac:vml" xmlns:p="http://schemas.openxmlformats.org/presentationml/2006/main" xmlns:c="http://schemas.openxmlformats.org/drawingml/2006/chart" xmlns:dgm="http://schemas.openxmlformats.org/drawingml/2006/diagram" xmlns:o="urn:schemas-microsoft-com:office:office" xmlns:v="urn:schemas-microsoft-com:vml" xmlns:pvml="urn:schemas-microsoft-com:office:powerpoint" xmlns:com="http://schemas.openxmlformats.org/drawingml/2006/compatibility" xmlns:p14="http://schemas.microsoft.com/office/powerpoint/2010/main" xmlns:p15="http://schemas.microsoft.com/office/powerpoint/2012/main" xmlns:ahyp="http://schemas.microsoft.com/office/drawing/2018/hyperlinkcolor">
   <p:cSld>
     <p:spTree>
@@ -26687,7 +26310,7 @@
 </p:sld>
 </file>
 
-<file path=ppt/slides/slide38.xml><?xml version="1.0" encoding="utf-8"?>
+<file path=ppt/slides/slide39.xml><?xml version="1.0" encoding="utf-8"?>
 <p:sld xmlns:a="http://schemas.openxmlformats.org/drawingml/2006/main" xmlns:r="http://schemas.openxmlformats.org/officeDocument/2006/relationships" xmlns:mc="http://schemas.openxmlformats.org/markup-compatibility/2006" xmlns:mv="urn:schemas-microsoft-com:mac:vml" xmlns:p="http://schemas.openxmlformats.org/presentationml/2006/main" xmlns:c="http://schemas.openxmlformats.org/drawingml/2006/chart" xmlns:dgm="http://schemas.openxmlformats.org/drawingml/2006/diagram" xmlns:o="urn:schemas-microsoft-com:office:office" xmlns:v="urn:schemas-microsoft-com:vml" xmlns:pvml="urn:schemas-microsoft-com:office:powerpoint" xmlns:com="http://schemas.openxmlformats.org/drawingml/2006/compatibility" xmlns:p14="http://schemas.microsoft.com/office/powerpoint/2010/main" xmlns:p15="http://schemas.microsoft.com/office/powerpoint/2012/main" xmlns:ahyp="http://schemas.microsoft.com/office/drawing/2018/hyperlinkcolor">
   <p:cSld>
     <p:spTree>
@@ -27765,7 +27388,654 @@
 </p:sld>
 </file>
 
-<file path=ppt/slides/slide39.xml><?xml version="1.0" encoding="utf-8"?>
+<file path=ppt/slides/slide4.xml><?xml version="1.0" encoding="utf-8"?>
+<p:sld xmlns:a="http://schemas.openxmlformats.org/drawingml/2006/main" xmlns:r="http://schemas.openxmlformats.org/officeDocument/2006/relationships" xmlns:mc="http://schemas.openxmlformats.org/markup-compatibility/2006" xmlns:mv="urn:schemas-microsoft-com:mac:vml" xmlns:p="http://schemas.openxmlformats.org/presentationml/2006/main" xmlns:c="http://schemas.openxmlformats.org/drawingml/2006/chart" xmlns:dgm="http://schemas.openxmlformats.org/drawingml/2006/diagram" xmlns:o="urn:schemas-microsoft-com:office:office" xmlns:v="urn:schemas-microsoft-com:vml" xmlns:pvml="urn:schemas-microsoft-com:office:powerpoint" xmlns:com="http://schemas.openxmlformats.org/drawingml/2006/compatibility" xmlns:p14="http://schemas.microsoft.com/office/powerpoint/2010/main" xmlns:p15="http://schemas.microsoft.com/office/powerpoint/2012/main" xmlns:ahyp="http://schemas.microsoft.com/office/drawing/2018/hyperlinkcolor">
+  <p:cSld>
+    <p:spTree>
+      <p:nvGrpSpPr>
+        <p:cNvPr id="50" name="Shape 50"/>
+        <p:cNvGrpSpPr/>
+        <p:nvPr/>
+      </p:nvGrpSpPr>
+      <p:grpSpPr>
+        <a:xfrm>
+          <a:off x="0" y="0"/>
+          <a:ext cx="0" cy="0"/>
+          <a:chOff x="0" y="0"/>
+          <a:chExt cx="0" cy="0"/>
+        </a:xfrm>
+      </p:grpSpPr>
+      <p:sp>
+        <p:nvSpPr>
+          <p:cNvPr id="51" name="Google Shape;51;p11"/>
+          <p:cNvSpPr txBox="1"/>
+          <p:nvPr>
+            <p:ph type="title"/>
+          </p:nvPr>
+        </p:nvSpPr>
+        <p:spPr>
+          <a:xfrm>
+            <a:off x="311700" y="195615"/>
+            <a:ext cx="8520600" cy="572700"/>
+          </a:xfrm>
+          <a:prstGeom prst="rect">
+            <a:avLst/>
+          </a:prstGeom>
+        </p:spPr>
+        <p:txBody>
+          <a:bodyPr anchorCtr="0" anchor="t" bIns="91425" lIns="91425" spcFirstLastPara="1" rIns="91425" wrap="square" tIns="91425">
+            <a:normAutofit fontScale="90000"/>
+          </a:bodyPr>
+          <a:lstStyle/>
+          <a:p>
+            <a:pPr indent="0" lvl="0" marL="0" rtl="0" algn="l">
+              <a:spcBef>
+                <a:spcPts val="0"/>
+              </a:spcBef>
+              <a:spcAft>
+                <a:spcPts val="0"/>
+              </a:spcAft>
+              <a:buNone/>
+            </a:pPr>
+            <a:r>
+              <a:rPr lang="en"/>
+              <a:t>Today’s Topics</a:t>
+            </a:r>
+            <a:endParaRPr/>
+          </a:p>
+        </p:txBody>
+      </p:sp>
+      <p:sp>
+        <p:nvSpPr>
+          <p:cNvPr id="52" name="Google Shape;52;p11"/>
+          <p:cNvSpPr txBox="1"/>
+          <p:nvPr>
+            <p:ph idx="1" type="body"/>
+          </p:nvPr>
+        </p:nvSpPr>
+        <p:spPr>
+          <a:xfrm>
+            <a:off x="311700" y="885950"/>
+            <a:ext cx="8520600" cy="4023300"/>
+          </a:xfrm>
+          <a:prstGeom prst="rect">
+            <a:avLst/>
+          </a:prstGeom>
+        </p:spPr>
+        <p:txBody>
+          <a:bodyPr anchorCtr="0" anchor="t" bIns="91425" lIns="91425" spcFirstLastPara="1" rIns="91425" wrap="square" tIns="91425">
+            <a:normAutofit/>
+          </a:bodyPr>
+          <a:lstStyle/>
+          <a:p>
+            <a:pPr indent="-330200" lvl="0" marL="457200" rtl="0" algn="l">
+              <a:spcBef>
+                <a:spcPts val="0"/>
+              </a:spcBef>
+              <a:spcAft>
+                <a:spcPts val="0"/>
+              </a:spcAft>
+              <a:buSzPts val="1600"/>
+              <a:buChar char="●"/>
+            </a:pPr>
+            <a:r>
+              <a:rPr lang="en"/>
+              <a:t>Game Architecture</a:t>
+            </a:r>
+            <a:endParaRPr/>
+          </a:p>
+          <a:p>
+            <a:pPr indent="-330200" lvl="0" marL="457200" rtl="0" algn="l">
+              <a:spcBef>
+                <a:spcPts val="0"/>
+              </a:spcBef>
+              <a:spcAft>
+                <a:spcPts val="0"/>
+              </a:spcAft>
+              <a:buSzPts val="1600"/>
+              <a:buChar char="●"/>
+            </a:pPr>
+            <a:r>
+              <a:rPr lang="en"/>
+              <a:t>Class Libraries</a:t>
+            </a:r>
+            <a:endParaRPr/>
+          </a:p>
+          <a:p>
+            <a:pPr indent="-330200" lvl="0" marL="457200" rtl="0" algn="l">
+              <a:spcBef>
+                <a:spcPts val="0"/>
+              </a:spcBef>
+              <a:spcAft>
+                <a:spcPts val="0"/>
+              </a:spcAft>
+              <a:buSzPts val="1600"/>
+              <a:buChar char="●"/>
+            </a:pPr>
+            <a:r>
+              <a:rPr lang="en"/>
+              <a:t>Images</a:t>
+            </a:r>
+            <a:endParaRPr/>
+          </a:p>
+          <a:p>
+            <a:pPr indent="-330200" lvl="0" marL="457200" rtl="0" algn="l">
+              <a:spcBef>
+                <a:spcPts val="0"/>
+              </a:spcBef>
+              <a:spcAft>
+                <a:spcPts val="0"/>
+              </a:spcAft>
+              <a:buSzPts val="1600"/>
+              <a:buChar char="●"/>
+            </a:pPr>
+            <a:r>
+              <a:rPr lang="en"/>
+              <a:t>Infinite Scrolling</a:t>
+            </a:r>
+            <a:endParaRPr/>
+          </a:p>
+          <a:p>
+            <a:pPr indent="-330200" lvl="0" marL="457200" rtl="0" algn="l">
+              <a:spcBef>
+                <a:spcPts val="0"/>
+              </a:spcBef>
+              <a:spcAft>
+                <a:spcPts val="0"/>
+              </a:spcAft>
+              <a:buSzPts val="1600"/>
+              <a:buChar char="●"/>
+            </a:pPr>
+            <a:r>
+              <a:rPr lang="en"/>
+              <a:t>Procedural Generation</a:t>
+            </a:r>
+            <a:endParaRPr/>
+          </a:p>
+          <a:p>
+            <a:pPr indent="-330200" lvl="0" marL="457200" rtl="0" algn="l">
+              <a:spcBef>
+                <a:spcPts val="0"/>
+              </a:spcBef>
+              <a:spcAft>
+                <a:spcPts val="0"/>
+              </a:spcAft>
+              <a:buSzPts val="1600"/>
+              <a:buChar char="●"/>
+            </a:pPr>
+            <a:r>
+              <a:rPr lang="en"/>
+              <a:t>Interfaces</a:t>
+            </a:r>
+            <a:endParaRPr/>
+          </a:p>
+          <a:p>
+            <a:pPr indent="-330200" lvl="0" marL="457200" rtl="0" algn="l">
+              <a:spcBef>
+                <a:spcPts val="0"/>
+              </a:spcBef>
+              <a:spcAft>
+                <a:spcPts val="0"/>
+              </a:spcAft>
+              <a:buSzPts val="1600"/>
+              <a:buChar char="●"/>
+            </a:pPr>
+            <a:r>
+              <a:rPr lang="en"/>
+              <a:t>State Machines</a:t>
+            </a:r>
+            <a:endParaRPr/>
+          </a:p>
+          <a:p>
+            <a:pPr indent="-330200" lvl="0" marL="457200" rtl="0" algn="l">
+              <a:spcBef>
+                <a:spcPts val="0"/>
+              </a:spcBef>
+              <a:spcAft>
+                <a:spcPts val="0"/>
+              </a:spcAft>
+              <a:buSzPts val="1600"/>
+              <a:buChar char="●"/>
+            </a:pPr>
+            <a:r>
+              <a:rPr lang="en"/>
+              <a:t>Singleton Pattern</a:t>
+            </a:r>
+            <a:endParaRPr/>
+          </a:p>
+        </p:txBody>
+      </p:sp>
+    </p:spTree>
+  </p:cSld>
+  <p:clrMapOvr>
+    <a:masterClrMapping/>
+  </p:clrMapOvr>
+  <p:timing>
+    <p:tnLst>
+      <p:par>
+        <p:cTn dur="indefinite" nodeType="tmRoot" restart="never">
+          <p:childTnLst>
+            <p:seq concurrent="1" nextAc="seek">
+              <p:cTn dur="indefinite" id="2" nodeType="mainSeq">
+                <p:childTnLst>
+                  <p:par>
+                    <p:cTn fill="hold">
+                      <p:stCondLst>
+                        <p:cond delay="indefinite"/>
+                      </p:stCondLst>
+                      <p:childTnLst>
+                        <p:par>
+                          <p:cTn fill="hold">
+                            <p:stCondLst>
+                              <p:cond delay="0"/>
+                            </p:stCondLst>
+                            <p:childTnLst>
+                              <p:par>
+                                <p:cTn fill="hold" nodeType="clickEffect" presetClass="entr" presetID="1" presetSubtype="0">
+                                  <p:stCondLst>
+                                    <p:cond delay="0"/>
+                                  </p:stCondLst>
+                                  <p:childTnLst>
+                                    <p:set>
+                                      <p:cBhvr>
+                                        <p:cTn dur="1" fill="hold">
+                                          <p:stCondLst>
+                                            <p:cond delay="0"/>
+                                          </p:stCondLst>
+                                        </p:cTn>
+                                        <p:tgtEl>
+                                          <p:spTgt spid="52">
+                                            <p:txEl>
+                                              <p:pRg end="0" st="0"/>
+                                            </p:txEl>
+                                          </p:spTgt>
+                                        </p:tgtEl>
+                                        <p:attrNameLst>
+                                          <p:attrName>style.visibility</p:attrName>
+                                        </p:attrNameLst>
+                                      </p:cBhvr>
+                                      <p:to>
+                                        <p:strVal val="visible"/>
+                                      </p:to>
+                                    </p:set>
+                                  </p:childTnLst>
+                                </p:cTn>
+                              </p:par>
+                            </p:childTnLst>
+                          </p:cTn>
+                        </p:par>
+                      </p:childTnLst>
+                    </p:cTn>
+                  </p:par>
+                  <p:par>
+                    <p:cTn fill="hold">
+                      <p:stCondLst>
+                        <p:cond delay="indefinite"/>
+                      </p:stCondLst>
+                      <p:childTnLst>
+                        <p:par>
+                          <p:cTn fill="hold">
+                            <p:stCondLst>
+                              <p:cond delay="0"/>
+                            </p:stCondLst>
+                            <p:childTnLst>
+                              <p:par>
+                                <p:cTn fill="hold" nodeType="clickEffect" presetClass="entr" presetID="1" presetSubtype="0">
+                                  <p:stCondLst>
+                                    <p:cond delay="0"/>
+                                  </p:stCondLst>
+                                  <p:childTnLst>
+                                    <p:set>
+                                      <p:cBhvr>
+                                        <p:cTn dur="1" fill="hold">
+                                          <p:stCondLst>
+                                            <p:cond delay="0"/>
+                                          </p:stCondLst>
+                                        </p:cTn>
+                                        <p:tgtEl>
+                                          <p:spTgt spid="52">
+                                            <p:txEl>
+                                              <p:pRg end="1" st="1"/>
+                                            </p:txEl>
+                                          </p:spTgt>
+                                        </p:tgtEl>
+                                        <p:attrNameLst>
+                                          <p:attrName>style.visibility</p:attrName>
+                                        </p:attrNameLst>
+                                      </p:cBhvr>
+                                      <p:to>
+                                        <p:strVal val="visible"/>
+                                      </p:to>
+                                    </p:set>
+                                  </p:childTnLst>
+                                </p:cTn>
+                              </p:par>
+                            </p:childTnLst>
+                          </p:cTn>
+                        </p:par>
+                      </p:childTnLst>
+                    </p:cTn>
+                  </p:par>
+                  <p:par>
+                    <p:cTn fill="hold">
+                      <p:stCondLst>
+                        <p:cond delay="indefinite"/>
+                      </p:stCondLst>
+                      <p:childTnLst>
+                        <p:par>
+                          <p:cTn fill="hold">
+                            <p:stCondLst>
+                              <p:cond delay="0"/>
+                            </p:stCondLst>
+                            <p:childTnLst>
+                              <p:par>
+                                <p:cTn fill="hold" nodeType="clickEffect" presetClass="entr" presetID="1" presetSubtype="0">
+                                  <p:stCondLst>
+                                    <p:cond delay="0"/>
+                                  </p:stCondLst>
+                                  <p:childTnLst>
+                                    <p:set>
+                                      <p:cBhvr>
+                                        <p:cTn dur="1" fill="hold">
+                                          <p:stCondLst>
+                                            <p:cond delay="0"/>
+                                          </p:stCondLst>
+                                        </p:cTn>
+                                        <p:tgtEl>
+                                          <p:spTgt spid="52">
+                                            <p:txEl>
+                                              <p:pRg end="2" st="2"/>
+                                            </p:txEl>
+                                          </p:spTgt>
+                                        </p:tgtEl>
+                                        <p:attrNameLst>
+                                          <p:attrName>style.visibility</p:attrName>
+                                        </p:attrNameLst>
+                                      </p:cBhvr>
+                                      <p:to>
+                                        <p:strVal val="visible"/>
+                                      </p:to>
+                                    </p:set>
+                                  </p:childTnLst>
+                                </p:cTn>
+                              </p:par>
+                            </p:childTnLst>
+                          </p:cTn>
+                        </p:par>
+                      </p:childTnLst>
+                    </p:cTn>
+                  </p:par>
+                  <p:par>
+                    <p:cTn fill="hold">
+                      <p:stCondLst>
+                        <p:cond delay="indefinite"/>
+                      </p:stCondLst>
+                      <p:childTnLst>
+                        <p:par>
+                          <p:cTn fill="hold">
+                            <p:stCondLst>
+                              <p:cond delay="0"/>
+                            </p:stCondLst>
+                            <p:childTnLst>
+                              <p:par>
+                                <p:cTn fill="hold" nodeType="clickEffect" presetClass="entr" presetID="1" presetSubtype="0">
+                                  <p:stCondLst>
+                                    <p:cond delay="0"/>
+                                  </p:stCondLst>
+                                  <p:childTnLst>
+                                    <p:set>
+                                      <p:cBhvr>
+                                        <p:cTn dur="1" fill="hold">
+                                          <p:stCondLst>
+                                            <p:cond delay="0"/>
+                                          </p:stCondLst>
+                                        </p:cTn>
+                                        <p:tgtEl>
+                                          <p:spTgt spid="52">
+                                            <p:txEl>
+                                              <p:pRg end="3" st="3"/>
+                                            </p:txEl>
+                                          </p:spTgt>
+                                        </p:tgtEl>
+                                        <p:attrNameLst>
+                                          <p:attrName>style.visibility</p:attrName>
+                                        </p:attrNameLst>
+                                      </p:cBhvr>
+                                      <p:to>
+                                        <p:strVal val="visible"/>
+                                      </p:to>
+                                    </p:set>
+                                  </p:childTnLst>
+                                </p:cTn>
+                              </p:par>
+                            </p:childTnLst>
+                          </p:cTn>
+                        </p:par>
+                      </p:childTnLst>
+                    </p:cTn>
+                  </p:par>
+                  <p:par>
+                    <p:cTn fill="hold">
+                      <p:stCondLst>
+                        <p:cond delay="indefinite"/>
+                      </p:stCondLst>
+                      <p:childTnLst>
+                        <p:par>
+                          <p:cTn fill="hold">
+                            <p:stCondLst>
+                              <p:cond delay="0"/>
+                            </p:stCondLst>
+                            <p:childTnLst>
+                              <p:par>
+                                <p:cTn fill="hold" nodeType="clickEffect" presetClass="entr" presetID="1" presetSubtype="0">
+                                  <p:stCondLst>
+                                    <p:cond delay="0"/>
+                                  </p:stCondLst>
+                                  <p:childTnLst>
+                                    <p:set>
+                                      <p:cBhvr>
+                                        <p:cTn dur="1" fill="hold">
+                                          <p:stCondLst>
+                                            <p:cond delay="0"/>
+                                          </p:stCondLst>
+                                        </p:cTn>
+                                        <p:tgtEl>
+                                          <p:spTgt spid="52">
+                                            <p:txEl>
+                                              <p:pRg end="4" st="4"/>
+                                            </p:txEl>
+                                          </p:spTgt>
+                                        </p:tgtEl>
+                                        <p:attrNameLst>
+                                          <p:attrName>style.visibility</p:attrName>
+                                        </p:attrNameLst>
+                                      </p:cBhvr>
+                                      <p:to>
+                                        <p:strVal val="visible"/>
+                                      </p:to>
+                                    </p:set>
+                                  </p:childTnLst>
+                                </p:cTn>
+                              </p:par>
+                            </p:childTnLst>
+                          </p:cTn>
+                        </p:par>
+                      </p:childTnLst>
+                    </p:cTn>
+                  </p:par>
+                  <p:par>
+                    <p:cTn fill="hold">
+                      <p:stCondLst>
+                        <p:cond delay="indefinite"/>
+                      </p:stCondLst>
+                      <p:childTnLst>
+                        <p:par>
+                          <p:cTn fill="hold">
+                            <p:stCondLst>
+                              <p:cond delay="0"/>
+                            </p:stCondLst>
+                            <p:childTnLst>
+                              <p:par>
+                                <p:cTn fill="hold" nodeType="clickEffect" presetClass="entr" presetID="1" presetSubtype="0">
+                                  <p:stCondLst>
+                                    <p:cond delay="0"/>
+                                  </p:stCondLst>
+                                  <p:childTnLst>
+                                    <p:set>
+                                      <p:cBhvr>
+                                        <p:cTn dur="1" fill="hold">
+                                          <p:stCondLst>
+                                            <p:cond delay="0"/>
+                                          </p:stCondLst>
+                                        </p:cTn>
+                                        <p:tgtEl>
+                                          <p:spTgt spid="52">
+                                            <p:txEl>
+                                              <p:pRg end="5" st="5"/>
+                                            </p:txEl>
+                                          </p:spTgt>
+                                        </p:tgtEl>
+                                        <p:attrNameLst>
+                                          <p:attrName>style.visibility</p:attrName>
+                                        </p:attrNameLst>
+                                      </p:cBhvr>
+                                      <p:to>
+                                        <p:strVal val="visible"/>
+                                      </p:to>
+                                    </p:set>
+                                  </p:childTnLst>
+                                </p:cTn>
+                              </p:par>
+                            </p:childTnLst>
+                          </p:cTn>
+                        </p:par>
+                      </p:childTnLst>
+                    </p:cTn>
+                  </p:par>
+                  <p:par>
+                    <p:cTn fill="hold">
+                      <p:stCondLst>
+                        <p:cond delay="indefinite"/>
+                      </p:stCondLst>
+                      <p:childTnLst>
+                        <p:par>
+                          <p:cTn fill="hold">
+                            <p:stCondLst>
+                              <p:cond delay="0"/>
+                            </p:stCondLst>
+                            <p:childTnLst>
+                              <p:par>
+                                <p:cTn fill="hold" nodeType="clickEffect" presetClass="entr" presetID="1" presetSubtype="0">
+                                  <p:stCondLst>
+                                    <p:cond delay="0"/>
+                                  </p:stCondLst>
+                                  <p:childTnLst>
+                                    <p:set>
+                                      <p:cBhvr>
+                                        <p:cTn dur="1" fill="hold">
+                                          <p:stCondLst>
+                                            <p:cond delay="0"/>
+                                          </p:stCondLst>
+                                        </p:cTn>
+                                        <p:tgtEl>
+                                          <p:spTgt spid="52">
+                                            <p:txEl>
+                                              <p:pRg end="6" st="6"/>
+                                            </p:txEl>
+                                          </p:spTgt>
+                                        </p:tgtEl>
+                                        <p:attrNameLst>
+                                          <p:attrName>style.visibility</p:attrName>
+                                        </p:attrNameLst>
+                                      </p:cBhvr>
+                                      <p:to>
+                                        <p:strVal val="visible"/>
+                                      </p:to>
+                                    </p:set>
+                                  </p:childTnLst>
+                                </p:cTn>
+                              </p:par>
+                            </p:childTnLst>
+                          </p:cTn>
+                        </p:par>
+                      </p:childTnLst>
+                    </p:cTn>
+                  </p:par>
+                  <p:par>
+                    <p:cTn fill="hold">
+                      <p:stCondLst>
+                        <p:cond delay="indefinite"/>
+                      </p:stCondLst>
+                      <p:childTnLst>
+                        <p:par>
+                          <p:cTn fill="hold">
+                            <p:stCondLst>
+                              <p:cond delay="0"/>
+                            </p:stCondLst>
+                            <p:childTnLst>
+                              <p:par>
+                                <p:cTn fill="hold" nodeType="clickEffect" presetClass="entr" presetID="1" presetSubtype="0">
+                                  <p:stCondLst>
+                                    <p:cond delay="0"/>
+                                  </p:stCondLst>
+                                  <p:childTnLst>
+                                    <p:set>
+                                      <p:cBhvr>
+                                        <p:cTn dur="1" fill="hold">
+                                          <p:stCondLst>
+                                            <p:cond delay="0"/>
+                                          </p:stCondLst>
+                                        </p:cTn>
+                                        <p:tgtEl>
+                                          <p:spTgt spid="52">
+                                            <p:txEl>
+                                              <p:pRg end="7" st="7"/>
+                                            </p:txEl>
+                                          </p:spTgt>
+                                        </p:tgtEl>
+                                        <p:attrNameLst>
+                                          <p:attrName>style.visibility</p:attrName>
+                                        </p:attrNameLst>
+                                      </p:cBhvr>
+                                      <p:to>
+                                        <p:strVal val="visible"/>
+                                      </p:to>
+                                    </p:set>
+                                  </p:childTnLst>
+                                </p:cTn>
+                              </p:par>
+                            </p:childTnLst>
+                          </p:cTn>
+                        </p:par>
+                      </p:childTnLst>
+                    </p:cTn>
+                  </p:par>
+                </p:childTnLst>
+              </p:cTn>
+              <p:prevCondLst>
+                <p:cond evt="onPrev">
+                  <p:tgtEl>
+                    <p:sldTgt/>
+                  </p:tgtEl>
+                </p:cond>
+              </p:prevCondLst>
+              <p:nextCondLst>
+                <p:cond evt="onNext">
+                  <p:tgtEl>
+                    <p:sldTgt/>
+                  </p:tgtEl>
+                </p:cond>
+              </p:nextCondLst>
+            </p:seq>
+          </p:childTnLst>
+        </p:cTn>
+      </p:par>
+    </p:tnLst>
+  </p:timing>
+</p:sld>
+</file>
+
+<file path=ppt/slides/slide40.xml><?xml version="1.0" encoding="utf-8"?>
 <p:sld xmlns:a="http://schemas.openxmlformats.org/drawingml/2006/main" xmlns:r="http://schemas.openxmlformats.org/officeDocument/2006/relationships" xmlns:mc="http://schemas.openxmlformats.org/markup-compatibility/2006" xmlns:mv="urn:schemas-microsoft-com:mac:vml" xmlns:p="http://schemas.openxmlformats.org/presentationml/2006/main" xmlns:c="http://schemas.openxmlformats.org/drawingml/2006/chart" xmlns:dgm="http://schemas.openxmlformats.org/drawingml/2006/diagram" xmlns:o="urn:schemas-microsoft-com:office:office" xmlns:v="urn:schemas-microsoft-com:vml" xmlns:pvml="urn:schemas-microsoft-com:office:powerpoint" xmlns:com="http://schemas.openxmlformats.org/drawingml/2006/compatibility" xmlns:p14="http://schemas.microsoft.com/office/powerpoint/2010/main" xmlns:p15="http://schemas.microsoft.com/office/powerpoint/2012/main" xmlns:ahyp="http://schemas.microsoft.com/office/drawing/2018/hyperlinkcolor">
   <p:cSld>
     <p:spTree>
@@ -27898,7 +28168,1182 @@
 </p:sld>
 </file>
 
-<file path=ppt/slides/slide4.xml><?xml version="1.0" encoding="utf-8"?>
+<file path=ppt/slides/slide41.xml><?xml version="1.0" encoding="utf-8"?>
+<p:sld xmlns:a="http://schemas.openxmlformats.org/drawingml/2006/main" xmlns:p="http://schemas.openxmlformats.org/presentationml/2006/main" xmlns:r="http://schemas.openxmlformats.org/officeDocument/2006/relationships">
+  <p:cSld>
+    <p:spTree>
+      <p:nvGrpSpPr>
+        <p:cNvPr id="1" name=""/>
+        <p:cNvGrpSpPr/>
+        <p:nvPr/>
+      </p:nvGrpSpPr>
+      <p:grpSpPr/>
+      <p:sp>
+        <p:nvSpPr>
+          <p:cNvPr id="263" name="Google Shape;263;p46"/>
+          <p:cNvSpPr txBox="1"/>
+          <p:nvPr>
+            <p:ph type="title"/>
+          </p:nvPr>
+        </p:nvSpPr>
+        <p:spPr>
+          <a:xfrm>
+            <a:off x="311700" y="195615"/>
+            <a:ext cx="8520600" cy="572700"/>
+          </a:xfrm>
+          <a:prstGeom prst="rect">
+            <a:avLst/>
+          </a:prstGeom>
+        </p:spPr>
+        <p:txBody>
+          <a:bodyPr anchorCtr="0" anchor="t" bIns="91425" lIns="91425" spcFirstLastPara="1" rIns="91425" wrap="square" tIns="91425">
+            <a:normAutofit fontScale="90000"/>
+          </a:bodyPr>
+          <a:lstStyle/>
+          <a:p>
+            <a:pPr indent="0" lvl="0" marL="0" rtl="0" algn="l">
+              <a:spcBef>
+                <a:spcPts val="0"/>
+              </a:spcBef>
+              <a:spcAft>
+                <a:spcPts val="0"/>
+              </a:spcAft>
+              <a:buNone/>
+            </a:pPr>
+            <a:r>
+              <a:rPr lang="en"/>
+              <a:t>Singleton in Flappy Bird</a:t>
+            </a:r>
+            <a:endParaRPr/>
+          </a:p>
+        </p:txBody>
+      </p:sp>
+      <p:sp>
+        <p:nvSpPr>
+          <p:cNvPr id="243" name="Google Shape;243;p43"/>
+          <p:cNvSpPr txBox="1"/>
+          <p:nvPr>
+            <p:ph idx="1" type="body"/>
+          </p:nvPr>
+        </p:nvSpPr>
+        <p:spPr>
+          <a:xfrm>
+            <a:off x="311700" y="1152475"/>
+            <a:ext cx="3900000" cy="3400000"/>
+          </a:xfrm>
+          <a:prstGeom prst="rect">
+            <a:avLst/>
+          </a:prstGeom>
+        </p:spPr>
+        <p:txBody>
+          <a:bodyPr anchorCtr="0" anchor="t" bIns="91425" lIns="91425" spcFirstLastPara="1" rIns="91425" wrap="square" tIns="91425">
+            <a:normAutofit/>
+          </a:bodyPr>
+          <a:lstStyle/>
+          <a:p>
+            <a:pPr indent="-330200" lvl="0" marL="457200" rtl="0" algn="l">
+              <a:spcBef>
+                <a:spcPts val="0"/>
+              </a:spcBef>
+              <a:spcAft>
+                <a:spcPts val="0"/>
+              </a:spcAft>
+              <a:buSzPts val="1600"/>
+              <a:buChar char="●"/>
+            </a:pPr>
+            <a:r>
+              <a:rPr lang="en"/>
+              <a:t>Audio is a Singleton: one object, reached through Audio.Instance</a:t>
+            </a:r>
+            <a:endParaRPr/>
+          </a:p>
+          <a:p>
+            <a:pPr indent="-330200" lvl="0" marL="457200" rtl="0" algn="l">
+              <a:spcBef>
+                <a:spcPts val="0"/>
+              </a:spcBef>
+              <a:spcAft>
+                <a:spcPts val="0"/>
+              </a:spcAft>
+              <a:buSzPts val="1600"/>
+              <a:buChar char="●"/>
+            </a:pPr>
+            <a:r>
+              <a:rPr lang="en"/>
+              <a:t>Art is a static class</a:t>
+            </a:r>
+            <a:endParaRPr/>
+          </a:p>
+          <a:p>
+            <a:pPr indent="-330200" lvl="0" marL="457200" rtl="0" algn="l">
+              <a:spcBef>
+                <a:spcPts val="0"/>
+              </a:spcBef>
+              <a:spcAft>
+                <a:spcPts val="0"/>
+              </a:spcAft>
+              <a:buSzPts val="1600"/>
+              <a:buChar char="●"/>
+            </a:pPr>
+            <a:r>
+              <a:rPr lang="en"/>
+              <a:t>Both give global access</a:t>
+            </a:r>
+            <a:endParaRPr/>
+          </a:p>
+          <a:p>
+            <a:pPr indent="-330200" lvl="0" marL="457200" rtl="0" algn="l">
+              <a:spcBef>
+                <a:spcPts val="0"/>
+              </a:spcBef>
+              <a:spcAft>
+                <a:spcPts val="0"/>
+              </a:spcAft>
+              <a:buSzPts val="1600"/>
+              <a:buChar char="●"/>
+            </a:pPr>
+            <a:r>
+              <a:rPr lang="en"/>
+              <a:t>But Audio is an object</a:t>
+            </a:r>
+            <a:endParaRPr/>
+          </a:p>
+          <a:p>
+            <a:pPr indent="-317500" lvl="1" marL="914400" rtl="0" algn="l">
+              <a:spcBef>
+                <a:spcPts val="0"/>
+              </a:spcBef>
+              <a:spcAft>
+                <a:spcPts val="0"/>
+              </a:spcAft>
+              <a:buSzPts val="1400"/>
+              <a:buChar char="○"/>
+            </a:pPr>
+            <a:r>
+              <a:rPr lang="en"/>
+              <a:t>It could implement an interface or be passed as a parameter</a:t>
+            </a:r>
+            <a:endParaRPr/>
+          </a:p>
+          <a:p>
+            <a:pPr indent="-317500" lvl="1" marL="914400" rtl="0" algn="l">
+              <a:spcBef>
+                <a:spcPts val="0"/>
+              </a:spcBef>
+              <a:spcAft>
+                <a:spcPts val="0"/>
+              </a:spcAft>
+              <a:buSzPts val="1400"/>
+              <a:buChar char="○"/>
+            </a:pPr>
+            <a:r>
+              <a:rPr lang="en"/>
+              <a:t>Pokemon builds on this with a Service Locator</a:t>
+            </a:r>
+            <a:endParaRPr/>
+          </a:p>
+          <a:p>
+            <a:pPr indent="-330200" lvl="0" marL="457200" rtl="0" algn="l">
+              <a:spcBef>
+                <a:spcPts val="0"/>
+              </a:spcBef>
+              <a:spcAft>
+                <a:spcPts val="0"/>
+              </a:spcAft>
+              <a:buSzPts val="1600"/>
+              <a:buChar char="●"/>
+            </a:pPr>
+            <a:r>
+              <a:rPr lang="en"/>
+              <a:t>Step: Flappy12</a:t>
+            </a:r>
+            <a:endParaRPr/>
+          </a:p>
+        </p:txBody>
+      </p:sp>
+      <p:sp>
+        <p:nvSpPr>
+          <p:cNvPr id="264" name="Google Shape;264;p46"/>
+          <p:cNvSpPr txBox="1"/>
+          <p:nvPr>
+            <p:ph idx="2" type="body"/>
+          </p:nvPr>
+        </p:nvSpPr>
+        <p:spPr>
+          <a:xfrm>
+            <a:off x="4500000" y="1152475"/>
+            <a:ext cx="4400000" cy="3600000"/>
+          </a:xfrm>
+          <a:prstGeom prst="rect">
+            <a:avLst/>
+          </a:prstGeom>
+        </p:spPr>
+        <p:txBody>
+          <a:bodyPr anchorCtr="0" anchor="t" bIns="91425" lIns="91425" spcFirstLastPara="1" rIns="91425" wrap="square" tIns="91425">
+            <a:noAutofit/>
+          </a:bodyPr>
+          <a:lstStyle/>
+          <a:p>
+            <a:pPr indent="0" lvl="0" marL="0" rtl="0" algn="l">
+              <a:lnSpc>
+                <a:spcPct val="115000"/>
+              </a:lnSpc>
+              <a:spcBef>
+                <a:spcPts val="0"/>
+              </a:spcBef>
+              <a:spcAft>
+                <a:spcPts val="0"/>
+              </a:spcAft>
+              <a:buNone/>
+            </a:pPr>
+            <a:r>
+              <a:rPr lang="en" sz="1000">
+                <a:highlight>
+                  <a:srgbClr val="1F1F1F"/>
+                </a:highlight>
+                <a:latin typeface="Consolas"/>
+                <a:ea typeface="Consolas"/>
+                <a:cs typeface="Consolas"/>
+                <a:sym typeface="Consolas"/>
+              </a:rPr>
+              <a:t>public class Audio</a:t>
+            </a:r>
+            <a:endParaRPr sz="1000">
+              <a:solidFill>
+                <a:srgbClr val="4EC9B0"/>
+              </a:solidFill>
+              <a:highlight>
+                <a:srgbClr val="1F1F1F"/>
+              </a:highlight>
+              <a:latin typeface="Consolas"/>
+              <a:ea typeface="Consolas"/>
+              <a:cs typeface="Consolas"/>
+              <a:sym typeface="Consolas"/>
+            </a:endParaRPr>
+          </a:p>
+          <a:p>
+            <a:pPr indent="0" lvl="0" marL="0" rtl="0" algn="l">
+              <a:lnSpc>
+                <a:spcPct val="115000"/>
+              </a:lnSpc>
+              <a:spcBef>
+                <a:spcPts val="0"/>
+              </a:spcBef>
+              <a:spcAft>
+                <a:spcPts val="0"/>
+              </a:spcAft>
+              <a:buNone/>
+            </a:pPr>
+            <a:r>
+              <a:rPr lang="en" sz="1000">
+                <a:highlight>
+                  <a:srgbClr val="1F1F1F"/>
+                </a:highlight>
+                <a:latin typeface="Consolas"/>
+                <a:ea typeface="Consolas"/>
+                <a:cs typeface="Consolas"/>
+                <a:sym typeface="Consolas"/>
+              </a:rPr>
+              <a:t>{</a:t>
+            </a:r>
+            <a:endParaRPr sz="1000">
+              <a:solidFill>
+                <a:srgbClr val="4EC9B0"/>
+              </a:solidFill>
+              <a:highlight>
+                <a:srgbClr val="1F1F1F"/>
+              </a:highlight>
+              <a:latin typeface="Consolas"/>
+              <a:ea typeface="Consolas"/>
+              <a:cs typeface="Consolas"/>
+              <a:sym typeface="Consolas"/>
+            </a:endParaRPr>
+          </a:p>
+          <a:p>
+            <a:pPr indent="0" lvl="0" marL="0" rtl="0" algn="l">
+              <a:lnSpc>
+                <a:spcPct val="115000"/>
+              </a:lnSpc>
+              <a:spcBef>
+                <a:spcPts val="0"/>
+              </a:spcBef>
+              <a:spcAft>
+                <a:spcPts val="0"/>
+              </a:spcAft>
+              <a:buNone/>
+            </a:pPr>
+            <a:r>
+              <a:rPr lang="en" sz="1000">
+                <a:highlight>
+                  <a:srgbClr val="1F1F1F"/>
+                </a:highlight>
+                <a:latin typeface="Consolas"/>
+                <a:ea typeface="Consolas"/>
+                <a:cs typeface="Consolas"/>
+                <a:sym typeface="Consolas"/>
+              </a:rPr>
+              <a:t>    public static Audio Instance { get; }</a:t>
+            </a:r>
+            <a:endParaRPr sz="1000">
+              <a:solidFill>
+                <a:srgbClr val="4EC9B0"/>
+              </a:solidFill>
+              <a:highlight>
+                <a:srgbClr val="1F1F1F"/>
+              </a:highlight>
+              <a:latin typeface="Consolas"/>
+              <a:ea typeface="Consolas"/>
+              <a:cs typeface="Consolas"/>
+              <a:sym typeface="Consolas"/>
+            </a:endParaRPr>
+          </a:p>
+          <a:p>
+            <a:pPr indent="0" lvl="0" marL="0" rtl="0" algn="l">
+              <a:lnSpc>
+                <a:spcPct val="115000"/>
+              </a:lnSpc>
+              <a:spcBef>
+                <a:spcPts val="0"/>
+              </a:spcBef>
+              <a:spcAft>
+                <a:spcPts val="0"/>
+              </a:spcAft>
+              <a:buNone/>
+            </a:pPr>
+            <a:r>
+              <a:rPr lang="en" sz="1000">
+                <a:highlight>
+                  <a:srgbClr val="1F1F1F"/>
+                </a:highlight>
+                <a:latin typeface="Consolas"/>
+                <a:ea typeface="Consolas"/>
+                <a:cs typeface="Consolas"/>
+                <a:sym typeface="Consolas"/>
+              </a:rPr>
+              <a:t>        = new Audio();</a:t>
+            </a:r>
+            <a:endParaRPr sz="1000">
+              <a:solidFill>
+                <a:srgbClr val="4EC9B0"/>
+              </a:solidFill>
+              <a:highlight>
+                <a:srgbClr val="1F1F1F"/>
+              </a:highlight>
+              <a:latin typeface="Consolas"/>
+              <a:ea typeface="Consolas"/>
+              <a:cs typeface="Consolas"/>
+              <a:sym typeface="Consolas"/>
+            </a:endParaRPr>
+          </a:p>
+          <a:p>
+            <a:pPr indent="0" lvl="0" marL="0" rtl="0" algn="l">
+              <a:lnSpc>
+                <a:spcPct val="115000"/>
+              </a:lnSpc>
+              <a:spcBef>
+                <a:spcPts val="0"/>
+              </a:spcBef>
+              <a:spcAft>
+                <a:spcPts val="0"/>
+              </a:spcAft>
+              <a:buNone/>
+            </a:pPr>
+            <a:r>
+              <a:rPr lang="en" sz="1000">
+                <a:highlight>
+                  <a:srgbClr val="1F1F1F"/>
+                </a:highlight>
+                <a:latin typeface="Consolas"/>
+                <a:ea typeface="Consolas"/>
+                <a:cs typeface="Consolas"/>
+                <a:sym typeface="Consolas"/>
+              </a:rPr>
+              <a:t/>
+            </a:r>
+            <a:endParaRPr sz="1000">
+              <a:solidFill>
+                <a:srgbClr val="4EC9B0"/>
+              </a:solidFill>
+              <a:highlight>
+                <a:srgbClr val="1F1F1F"/>
+              </a:highlight>
+              <a:latin typeface="Consolas"/>
+              <a:ea typeface="Consolas"/>
+              <a:cs typeface="Consolas"/>
+              <a:sym typeface="Consolas"/>
+            </a:endParaRPr>
+          </a:p>
+          <a:p>
+            <a:pPr indent="0" lvl="0" marL="0" rtl="0" algn="l">
+              <a:lnSpc>
+                <a:spcPct val="115000"/>
+              </a:lnSpc>
+              <a:spcBef>
+                <a:spcPts val="0"/>
+              </a:spcBef>
+              <a:spcAft>
+                <a:spcPts val="0"/>
+              </a:spcAft>
+              <a:buNone/>
+            </a:pPr>
+            <a:r>
+              <a:rPr lang="en" sz="1000">
+                <a:highlight>
+                  <a:srgbClr val="1F1F1F"/>
+                </a:highlight>
+                <a:latin typeface="Consolas"/>
+                <a:ea typeface="Consolas"/>
+                <a:cs typeface="Consolas"/>
+                <a:sym typeface="Consolas"/>
+              </a:rPr>
+              <a:t>    private Audio() { }</a:t>
+            </a:r>
+            <a:endParaRPr sz="1000">
+              <a:solidFill>
+                <a:srgbClr val="4EC9B0"/>
+              </a:solidFill>
+              <a:highlight>
+                <a:srgbClr val="1F1F1F"/>
+              </a:highlight>
+              <a:latin typeface="Consolas"/>
+              <a:ea typeface="Consolas"/>
+              <a:cs typeface="Consolas"/>
+              <a:sym typeface="Consolas"/>
+            </a:endParaRPr>
+          </a:p>
+          <a:p>
+            <a:pPr indent="0" lvl="0" marL="0" rtl="0" algn="l">
+              <a:lnSpc>
+                <a:spcPct val="115000"/>
+              </a:lnSpc>
+              <a:spcBef>
+                <a:spcPts val="0"/>
+              </a:spcBef>
+              <a:spcAft>
+                <a:spcPts val="0"/>
+              </a:spcAft>
+              <a:buNone/>
+            </a:pPr>
+            <a:r>
+              <a:rPr lang="en" sz="1000">
+                <a:highlight>
+                  <a:srgbClr val="1F1F1F"/>
+                </a:highlight>
+                <a:latin typeface="Consolas"/>
+                <a:ea typeface="Consolas"/>
+                <a:cs typeface="Consolas"/>
+                <a:sym typeface="Consolas"/>
+              </a:rPr>
+              <a:t/>
+            </a:r>
+            <a:endParaRPr sz="1000">
+              <a:solidFill>
+                <a:srgbClr val="4EC9B0"/>
+              </a:solidFill>
+              <a:highlight>
+                <a:srgbClr val="1F1F1F"/>
+              </a:highlight>
+              <a:latin typeface="Consolas"/>
+              <a:ea typeface="Consolas"/>
+              <a:cs typeface="Consolas"/>
+              <a:sym typeface="Consolas"/>
+            </a:endParaRPr>
+          </a:p>
+          <a:p>
+            <a:pPr indent="0" lvl="0" marL="0" rtl="0" algn="l">
+              <a:lnSpc>
+                <a:spcPct val="115000"/>
+              </a:lnSpc>
+              <a:spcBef>
+                <a:spcPts val="0"/>
+              </a:spcBef>
+              <a:spcAft>
+                <a:spcPts val="0"/>
+              </a:spcAft>
+              <a:buNone/>
+            </a:pPr>
+            <a:r>
+              <a:rPr lang="en" sz="1000">
+                <a:highlight>
+                  <a:srgbClr val="1F1F1F"/>
+                </a:highlight>
+                <a:latin typeface="Consolas"/>
+                <a:ea typeface="Consolas"/>
+                <a:cs typeface="Consolas"/>
+                <a:sym typeface="Consolas"/>
+              </a:rPr>
+              <a:t>    public void PlayFlap() =&gt; _flap.Play();</a:t>
+            </a:r>
+            <a:endParaRPr sz="1000">
+              <a:solidFill>
+                <a:srgbClr val="4EC9B0"/>
+              </a:solidFill>
+              <a:highlight>
+                <a:srgbClr val="1F1F1F"/>
+              </a:highlight>
+              <a:latin typeface="Consolas"/>
+              <a:ea typeface="Consolas"/>
+              <a:cs typeface="Consolas"/>
+              <a:sym typeface="Consolas"/>
+            </a:endParaRPr>
+          </a:p>
+          <a:p>
+            <a:pPr indent="0" lvl="0" marL="0" rtl="0" algn="l">
+              <a:lnSpc>
+                <a:spcPct val="115000"/>
+              </a:lnSpc>
+              <a:spcBef>
+                <a:spcPts val="0"/>
+              </a:spcBef>
+              <a:spcAft>
+                <a:spcPts val="0"/>
+              </a:spcAft>
+              <a:buNone/>
+            </a:pPr>
+            <a:r>
+              <a:rPr lang="en" sz="1000">
+                <a:highlight>
+                  <a:srgbClr val="1F1F1F"/>
+                </a:highlight>
+                <a:latin typeface="Consolas"/>
+                <a:ea typeface="Consolas"/>
+                <a:cs typeface="Consolas"/>
+                <a:sym typeface="Consolas"/>
+              </a:rPr>
+              <a:t>    // PlayMusic, PlayScore, PlayCrash...</a:t>
+            </a:r>
+            <a:endParaRPr sz="1000">
+              <a:solidFill>
+                <a:srgbClr val="4EC9B0"/>
+              </a:solidFill>
+              <a:highlight>
+                <a:srgbClr val="1F1F1F"/>
+              </a:highlight>
+              <a:latin typeface="Consolas"/>
+              <a:ea typeface="Consolas"/>
+              <a:cs typeface="Consolas"/>
+              <a:sym typeface="Consolas"/>
+            </a:endParaRPr>
+          </a:p>
+          <a:p>
+            <a:pPr indent="0" lvl="0" marL="0" rtl="0" algn="l">
+              <a:lnSpc>
+                <a:spcPct val="115000"/>
+              </a:lnSpc>
+              <a:spcBef>
+                <a:spcPts val="0"/>
+              </a:spcBef>
+              <a:spcAft>
+                <a:spcPts val="0"/>
+              </a:spcAft>
+              <a:buNone/>
+            </a:pPr>
+            <a:r>
+              <a:rPr lang="en" sz="1000">
+                <a:highlight>
+                  <a:srgbClr val="1F1F1F"/>
+                </a:highlight>
+                <a:latin typeface="Consolas"/>
+                <a:ea typeface="Consolas"/>
+                <a:cs typeface="Consolas"/>
+                <a:sym typeface="Consolas"/>
+              </a:rPr>
+              <a:t>}</a:t>
+            </a:r>
+            <a:endParaRPr sz="1000">
+              <a:solidFill>
+                <a:srgbClr val="4EC9B0"/>
+              </a:solidFill>
+              <a:highlight>
+                <a:srgbClr val="1F1F1F"/>
+              </a:highlight>
+              <a:latin typeface="Consolas"/>
+              <a:ea typeface="Consolas"/>
+              <a:cs typeface="Consolas"/>
+              <a:sym typeface="Consolas"/>
+            </a:endParaRPr>
+          </a:p>
+          <a:p>
+            <a:pPr indent="0" lvl="0" marL="0" rtl="0" algn="l">
+              <a:lnSpc>
+                <a:spcPct val="115000"/>
+              </a:lnSpc>
+              <a:spcBef>
+                <a:spcPts val="0"/>
+              </a:spcBef>
+              <a:spcAft>
+                <a:spcPts val="0"/>
+              </a:spcAft>
+              <a:buNone/>
+            </a:pPr>
+            <a:r>
+              <a:rPr lang="en" sz="1000">
+                <a:highlight>
+                  <a:srgbClr val="1F1F1F"/>
+                </a:highlight>
+                <a:latin typeface="Consolas"/>
+                <a:ea typeface="Consolas"/>
+                <a:cs typeface="Consolas"/>
+                <a:sym typeface="Consolas"/>
+              </a:rPr>
+              <a:t/>
+            </a:r>
+            <a:endParaRPr sz="1000">
+              <a:solidFill>
+                <a:srgbClr val="4EC9B0"/>
+              </a:solidFill>
+              <a:highlight>
+                <a:srgbClr val="1F1F1F"/>
+              </a:highlight>
+              <a:latin typeface="Consolas"/>
+              <a:ea typeface="Consolas"/>
+              <a:cs typeface="Consolas"/>
+              <a:sym typeface="Consolas"/>
+            </a:endParaRPr>
+          </a:p>
+          <a:p>
+            <a:pPr indent="0" lvl="0" marL="0" rtl="0" algn="l">
+              <a:lnSpc>
+                <a:spcPct val="115000"/>
+              </a:lnSpc>
+              <a:spcBef>
+                <a:spcPts val="0"/>
+              </a:spcBef>
+              <a:spcAft>
+                <a:spcPts val="0"/>
+              </a:spcAft>
+              <a:buNone/>
+            </a:pPr>
+            <a:r>
+              <a:rPr lang="en" sz="1000">
+                <a:highlight>
+                  <a:srgbClr val="1F1F1F"/>
+                </a:highlight>
+                <a:latin typeface="Consolas"/>
+                <a:ea typeface="Consolas"/>
+                <a:cs typeface="Consolas"/>
+                <a:sym typeface="Consolas"/>
+              </a:rPr>
+              <a:t>// Anywhere in the game</a:t>
+            </a:r>
+            <a:endParaRPr sz="1000">
+              <a:solidFill>
+                <a:srgbClr val="4EC9B0"/>
+              </a:solidFill>
+              <a:highlight>
+                <a:srgbClr val="1F1F1F"/>
+              </a:highlight>
+              <a:latin typeface="Consolas"/>
+              <a:ea typeface="Consolas"/>
+              <a:cs typeface="Consolas"/>
+              <a:sym typeface="Consolas"/>
+            </a:endParaRPr>
+          </a:p>
+          <a:p>
+            <a:pPr indent="0" lvl="0" marL="0" rtl="0" algn="l">
+              <a:lnSpc>
+                <a:spcPct val="115000"/>
+              </a:lnSpc>
+              <a:spcBef>
+                <a:spcPts val="0"/>
+              </a:spcBef>
+              <a:spcAft>
+                <a:spcPts val="0"/>
+              </a:spcAft>
+              <a:buNone/>
+            </a:pPr>
+            <a:r>
+              <a:rPr lang="en" sz="1000">
+                <a:highlight>
+                  <a:srgbClr val="1F1F1F"/>
+                </a:highlight>
+                <a:latin typeface="Consolas"/>
+                <a:ea typeface="Consolas"/>
+                <a:cs typeface="Consolas"/>
+                <a:sym typeface="Consolas"/>
+              </a:rPr>
+              <a:t>Audio.Instance.PlayFlap();</a:t>
+            </a:r>
+            <a:endParaRPr sz="1000">
+              <a:solidFill>
+                <a:srgbClr val="4EC9B0"/>
+              </a:solidFill>
+              <a:highlight>
+                <a:srgbClr val="1F1F1F"/>
+              </a:highlight>
+              <a:latin typeface="Consolas"/>
+              <a:ea typeface="Consolas"/>
+              <a:cs typeface="Consolas"/>
+              <a:sym typeface="Consolas"/>
+            </a:endParaRPr>
+          </a:p>
+        </p:txBody>
+      </p:sp>
+    </p:spTree>
+  </p:cSld>
+  <p:clrMapOvr>
+    <a:masterClrMapping/>
+  </p:clrMapOvr>
+</p:sld>
+</file>
+
+<file path=ppt/slides/slide42.xml><?xml version="1.0" encoding="utf-8"?>
+<p:sld xmlns:a="http://schemas.openxmlformats.org/drawingml/2006/main" xmlns:p="http://schemas.openxmlformats.org/presentationml/2006/main" xmlns:r="http://schemas.openxmlformats.org/officeDocument/2006/relationships">
+  <p:cSld>
+    <p:spTree>
+      <p:nvGrpSpPr>
+        <p:cNvPr id="1" name=""/>
+        <p:cNvGrpSpPr/>
+        <p:nvPr/>
+      </p:nvGrpSpPr>
+      <p:grpSpPr/>
+      <p:sp>
+        <p:nvSpPr>
+          <p:cNvPr id="2" name="Title 1"/>
+          <p:cNvSpPr>
+            <a:spLocks noGrp="1"/>
+          </p:cNvSpPr>
+          <p:nvPr>
+            <p:ph type="title"/>
+          </p:nvPr>
+        </p:nvSpPr>
+        <p:spPr/>
+        <p:txBody>
+          <a:bodyPr/>
+          <a:lstStyle/>
+          <a:p>
+            <a:pPr indent="0" lvl="0" marL="0" rtl="0" algn="l">
+              <a:spcBef>
+                <a:spcPts val="0"/>
+              </a:spcBef>
+              <a:spcAft>
+                <a:spcPts val="0"/>
+              </a:spcAft>
+              <a:buNone/>
+            </a:pPr>
+            <a:r>
+              <a:rPr lang="en"/>
+              <a:t>Check Yourself</a:t>
+            </a:r>
+            <a:endParaRPr/>
+          </a:p>
+        </p:txBody>
+      </p:sp>
+      <p:sp>
+        <p:nvSpPr>
+          <p:cNvPr id="3" name="Text Placeholder 2"/>
+          <p:cNvSpPr>
+            <a:spLocks noGrp="1"/>
+          </p:cNvSpPr>
+          <p:nvPr>
+            <p:ph type="body" idx="1"/>
+          </p:nvPr>
+        </p:nvSpPr>
+        <p:spPr>
+          <a:xfrm>
+            <a:off x="311700" y="885950"/>
+            <a:ext cx="8520600" cy="1335024"/>
+          </a:xfrm>
+        </p:spPr>
+        <p:txBody>
+          <a:bodyPr/>
+          <a:lstStyle/>
+          <a:p>
+            <a:pPr indent="-330200" lvl="0" marL="457200" rtl="0" algn="l">
+              <a:spcBef>
+                <a:spcPts val="0"/>
+              </a:spcBef>
+              <a:spcAft>
+                <a:spcPts val="0"/>
+              </a:spcAft>
+              <a:buSzPts val="1600"/>
+              <a:buChar char="●"/>
+            </a:pPr>
+            <a:r>
+              <a:rPr lang="en"/>
+              <a:t>What problem does a state machine solve compared to a string or enum field?</a:t>
+            </a:r>
+            <a:endParaRPr/>
+          </a:p>
+          <a:p>
+            <a:pPr indent="-330200" lvl="0" marL="457200" rtl="0" algn="l">
+              <a:spcBef>
+                <a:spcPts val="0"/>
+              </a:spcBef>
+              <a:spcAft>
+                <a:spcPts val="0"/>
+              </a:spcAft>
+              <a:buSzPts val="1600"/>
+              <a:buChar char="●"/>
+            </a:pPr>
+            <a:r>
+              <a:rPr lang="en"/>
+              <a:t>What happens if you forget to call Exit() when switching state?</a:t>
+            </a:r>
+            <a:endParaRPr/>
+          </a:p>
+          <a:p>
+            <a:pPr indent="-330200" lvl="0" marL="457200" rtl="0" algn="l">
+              <a:spcBef>
+                <a:spcPts val="0"/>
+              </a:spcBef>
+              <a:spcAft>
+                <a:spcPts val="0"/>
+              </a:spcAft>
+              <a:buSzPts val="1600"/>
+              <a:buChar char="●"/>
+            </a:pPr>
+            <a:r>
+              <a:rPr lang="en"/>
+              <a:t>Why is Singleton considered an anti-pattern by many game programmers?</a:t>
+            </a:r>
+            <a:endParaRPr/>
+          </a:p>
+        </p:txBody>
+      </p:sp>
+      <p:sp>
+        <p:nvSpPr>
+          <p:cNvPr id="4" name="TextBox 3"/>
+          <p:cNvSpPr txBox="1"/>
+          <p:nvPr/>
+        </p:nvSpPr>
+        <p:spPr>
+          <a:xfrm>
+            <a:off x="457200" y="2798064"/>
+            <a:ext cx="8229600" cy="457200"/>
+          </a:xfrm>
+          <a:prstGeom prst="rect">
+            <a:avLst/>
+          </a:prstGeom>
+          <a:noFill/>
+        </p:spPr>
+        <p:txBody>
+          <a:bodyPr wrap="square">
+            <a:spAutoFit/>
+          </a:bodyPr>
+          <a:lstStyle/>
+          <a:p>
+            <a:pPr algn="ctr"/>
+            <a:r>
+              <a:rPr sz="1400" b="0" i="0">
+                <a:solidFill>
+                  <a:srgbClr val="9AA3AB"/>
+                </a:solidFill>
+              </a:rPr>
+              <a:t>The answers, and more questions, are on the course site.</a:t>
+            </a:r>
+          </a:p>
+        </p:txBody>
+      </p:sp>
+    </p:spTree>
+  </p:cSld>
+  <p:clrMapOvr>
+    <a:masterClrMapping/>
+  </p:clrMapOvr>
+</p:sld>
+</file>
+
+<file path=ppt/slides/slide43.xml><?xml version="1.0" encoding="utf-8"?>
+<p:sld xmlns:a="http://schemas.openxmlformats.org/drawingml/2006/main" xmlns:p="http://schemas.openxmlformats.org/presentationml/2006/main" xmlns:r="http://schemas.openxmlformats.org/officeDocument/2006/relationships">
+  <p:cSld>
+    <p:spTree>
+      <p:nvGrpSpPr>
+        <p:cNvPr id="1" name=""/>
+        <p:cNvGrpSpPr/>
+        <p:nvPr/>
+      </p:nvGrpSpPr>
+      <p:grpSpPr/>
+      <p:sp>
+        <p:nvSpPr>
+          <p:cNvPr id="57" name="Google Shape;57;p12"/>
+          <p:cNvSpPr txBox="1"/>
+          <p:nvPr>
+            <p:ph type="title"/>
+          </p:nvPr>
+        </p:nvSpPr>
+        <p:spPr>
+          <a:xfrm>
+            <a:off x="311700" y="195615"/>
+            <a:ext cx="8520600" cy="572700"/>
+          </a:xfrm>
+          <a:prstGeom prst="rect">
+            <a:avLst/>
+          </a:prstGeom>
+        </p:spPr>
+        <p:txBody>
+          <a:bodyPr anchorCtr="0" anchor="t" bIns="91425" lIns="91425" spcFirstLastPara="1" rIns="91425" wrap="square" tIns="91425">
+            <a:normAutofit fontScale="90000"/>
+          </a:bodyPr>
+          <a:lstStyle/>
+          <a:p>
+            <a:pPr indent="0" lvl="0" marL="0" rtl="0" algn="l">
+              <a:spcBef>
+                <a:spcPts val="0"/>
+              </a:spcBef>
+              <a:spcAft>
+                <a:spcPts val="0"/>
+              </a:spcAft>
+              <a:buNone/>
+            </a:pPr>
+            <a:r>
+              <a:rPr lang="en"/>
+              <a:t>Apply It to Your Project</a:t>
+            </a:r>
+            <a:endParaRPr/>
+          </a:p>
+        </p:txBody>
+      </p:sp>
+      <p:sp>
+        <p:nvSpPr>
+          <p:cNvPr id="58" name="Google Shape;58;p12"/>
+          <p:cNvSpPr txBox="1"/>
+          <p:nvPr>
+            <p:ph idx="1" type="body"/>
+          </p:nvPr>
+        </p:nvSpPr>
+        <p:spPr>
+          <a:xfrm>
+            <a:off x="311700" y="885950"/>
+            <a:ext cx="8520600" cy="4023300"/>
+          </a:xfrm>
+          <a:prstGeom prst="rect">
+            <a:avLst/>
+          </a:prstGeom>
+        </p:spPr>
+        <p:txBody>
+          <a:bodyPr anchorCtr="0" anchor="t" bIns="91425" lIns="91425" spcFirstLastPara="1" rIns="91425" wrap="square" tIns="91425">
+            <a:normAutofit/>
+          </a:bodyPr>
+          <a:lstStyle/>
+          <a:p>
+            <a:pPr indent="-330200" lvl="0" marL="457200" rtl="0" algn="l">
+              <a:spcBef>
+                <a:spcPts val="0"/>
+              </a:spcBef>
+              <a:spcAft>
+                <a:spcPts val="0"/>
+              </a:spcAft>
+              <a:buSzPts val="1600"/>
+              <a:buChar char="●"/>
+            </a:pPr>
+            <a:r>
+              <a:rPr lang="en"/>
+              <a:t>Which code in your game could another game reuse?</a:t>
+            </a:r>
+            <a:endParaRPr/>
+          </a:p>
+          <a:p>
+            <a:pPr indent="-317500" lvl="1" marL="914400" rtl="0" algn="l">
+              <a:spcBef>
+                <a:spcPts val="0"/>
+              </a:spcBef>
+              <a:spcAft>
+                <a:spcPts val="0"/>
+              </a:spcAft>
+              <a:buSzPts val="1400"/>
+              <a:buChar char="○"/>
+            </a:pPr>
+            <a:r>
+              <a:rPr lang="en"/>
+              <a:t>That belongs in a class library, like GMDCore</a:t>
+            </a:r>
+            <a:endParaRPr/>
+          </a:p>
+          <a:p>
+            <a:pPr indent="-330200" lvl="0" marL="457200" rtl="0" algn="l">
+              <a:spcBef>
+                <a:spcPts val="0"/>
+              </a:spcBef>
+              <a:spcAft>
+                <a:spcPts val="0"/>
+              </a:spcAft>
+              <a:buSzPts val="1600"/>
+              <a:buChar char="●"/>
+            </a:pPr>
+            <a:r>
+              <a:rPr lang="en"/>
+              <a:t>Which states does your game have? Draw them as a state diagram</a:t>
+            </a:r>
+            <a:endParaRPr/>
+          </a:p>
+          <a:p>
+            <a:pPr indent="-330200" lvl="0" marL="457200" rtl="0" algn="l">
+              <a:spcBef>
+                <a:spcPts val="0"/>
+              </a:spcBef>
+              <a:spcAft>
+                <a:spcPts val="0"/>
+              </a:spcAft>
+              <a:buSzPts val="1600"/>
+              <a:buChar char="●"/>
+            </a:pPr>
+            <a:r>
+              <a:rPr lang="en"/>
+              <a:t>Is anything in your game global? Does it need to be?</a:t>
+            </a:r>
+            <a:endParaRPr/>
+          </a:p>
+        </p:txBody>
+      </p:sp>
+    </p:spTree>
+  </p:cSld>
+  <p:clrMapOvr>
+    <a:masterClrMapping/>
+  </p:clrMapOvr>
+</p:sld>
+</file>
+
+<file path=ppt/slides/slide44.xml><?xml version="1.0" encoding="utf-8"?>
+<p:sld xmlns:a="http://schemas.openxmlformats.org/drawingml/2006/main" xmlns:p="http://schemas.openxmlformats.org/presentationml/2006/main" xmlns:r="http://schemas.openxmlformats.org/officeDocument/2006/relationships">
+  <p:cSld>
+    <p:spTree>
+      <p:nvGrpSpPr>
+        <p:cNvPr id="1" name=""/>
+        <p:cNvGrpSpPr/>
+        <p:nvPr/>
+      </p:nvGrpSpPr>
+      <p:grpSpPr/>
+      <p:sp>
+        <p:nvSpPr>
+          <p:cNvPr id="57" name="Google Shape;57;p12"/>
+          <p:cNvSpPr txBox="1"/>
+          <p:nvPr>
+            <p:ph type="title"/>
+          </p:nvPr>
+        </p:nvSpPr>
+        <p:spPr>
+          <a:xfrm>
+            <a:off x="311700" y="195615"/>
+            <a:ext cx="8520600" cy="572700"/>
+          </a:xfrm>
+          <a:prstGeom prst="rect">
+            <a:avLst/>
+          </a:prstGeom>
+        </p:spPr>
+        <p:txBody>
+          <a:bodyPr anchorCtr="0" anchor="t" bIns="91425" lIns="91425" spcFirstLastPara="1" rIns="91425" wrap="square" tIns="91425">
+            <a:normAutofit fontScale="90000"/>
+          </a:bodyPr>
+          <a:lstStyle/>
+          <a:p>
+            <a:pPr indent="0" lvl="0" marL="0" rtl="0" algn="l">
+              <a:spcBef>
+                <a:spcPts val="0"/>
+              </a:spcBef>
+              <a:spcAft>
+                <a:spcPts val="0"/>
+              </a:spcAft>
+              <a:buNone/>
+            </a:pPr>
+            <a:r>
+              <a:rPr lang="en"/>
+              <a:t>Your Course Project</a:t>
+            </a:r>
+            <a:endParaRPr/>
+          </a:p>
+        </p:txBody>
+      </p:sp>
+      <p:sp>
+        <p:nvSpPr>
+          <p:cNvPr id="58" name="Google Shape;58;p12"/>
+          <p:cNvSpPr txBox="1"/>
+          <p:nvPr>
+            <p:ph idx="1" type="body"/>
+          </p:nvPr>
+        </p:nvSpPr>
+        <p:spPr>
+          <a:xfrm>
+            <a:off x="311700" y="885950"/>
+            <a:ext cx="8520600" cy="4023300"/>
+          </a:xfrm>
+          <a:prstGeom prst="rect">
+            <a:avLst/>
+          </a:prstGeom>
+        </p:spPr>
+        <p:txBody>
+          <a:bodyPr anchorCtr="0" anchor="t" bIns="91425" lIns="91425" spcFirstLastPara="1" rIns="91425" wrap="square" tIns="91425">
+            <a:normAutofit/>
+          </a:bodyPr>
+          <a:lstStyle/>
+          <a:p>
+            <a:pPr indent="-330200" lvl="0" marL="457200" rtl="0" algn="l">
+              <a:spcBef>
+                <a:spcPts val="0"/>
+              </a:spcBef>
+              <a:spcAft>
+                <a:spcPts val="0"/>
+              </a:spcAft>
+              <a:buSzPts val="1600"/>
+              <a:buChar char="●"/>
+            </a:pPr>
+            <a:r>
+              <a:rPr lang="en"/>
+              <a:t>Start from the gar-starter template on GitHub</a:t>
+            </a:r>
+            <a:endParaRPr/>
+          </a:p>
+          <a:p>
+            <a:pPr indent="-317500" lvl="1" marL="914400" rtl="0" algn="l">
+              <a:spcBef>
+                <a:spcPts val="0"/>
+              </a:spcBef>
+              <a:spcAft>
+                <a:spcPts val="0"/>
+              </a:spcAft>
+              <a:buSzPts val="1400"/>
+              <a:buChar char="○"/>
+            </a:pPr>
+            <a:r>
+              <a:rPr lang="en"/>
+              <a:t>“Use this template”: an empty game with the content builder</a:t>
+            </a:r>
+            <a:endParaRPr/>
+          </a:p>
+          <a:p>
+            <a:pPr indent="-330200" lvl="0" marL="457200" rtl="0" algn="l">
+              <a:spcBef>
+                <a:spcPts val="0"/>
+              </a:spcBef>
+              <a:spcAft>
+                <a:spcPts val="0"/>
+              </a:spcAft>
+              <a:buSzPts val="1600"/>
+              <a:buChar char="●"/>
+            </a:pPr>
+            <a:r>
+              <a:rPr lang="en"/>
+              <a:t>First milestone, by session 04</a:t>
+            </a:r>
+            <a:endParaRPr/>
+          </a:p>
+          <a:p>
+            <a:pPr indent="-317500" lvl="1" marL="914400" rtl="0" algn="l">
+              <a:spcBef>
+                <a:spcPts val="0"/>
+              </a:spcBef>
+              <a:spcAft>
+                <a:spcPts val="0"/>
+              </a:spcAft>
+              <a:buSzPts val="1400"/>
+              <a:buChar char="○"/>
+            </a:pPr>
+            <a:r>
+              <a:rPr lang="en"/>
+              <a:t>Groups formed, game concept written, repository created and link uploaded to itslearning</a:t>
+            </a:r>
+            <a:endParaRPr/>
+          </a:p>
+        </p:txBody>
+      </p:sp>
+    </p:spTree>
+  </p:cSld>
+  <p:clrMapOvr>
+    <a:masterClrMapping/>
+  </p:clrMapOvr>
+</p:sld>
+</file>
+
+<file path=ppt/slides/slide5.xml><?xml version="1.0" encoding="utf-8"?>
 <p:sld xmlns:a="http://schemas.openxmlformats.org/drawingml/2006/main" xmlns:r="http://schemas.openxmlformats.org/officeDocument/2006/relationships" xmlns:mc="http://schemas.openxmlformats.org/markup-compatibility/2006" xmlns:mv="urn:schemas-microsoft-com:mac:vml" xmlns:p="http://schemas.openxmlformats.org/presentationml/2006/main" xmlns:c="http://schemas.openxmlformats.org/drawingml/2006/chart" xmlns:dgm="http://schemas.openxmlformats.org/drawingml/2006/diagram" xmlns:o="urn:schemas-microsoft-com:office:office" xmlns:v="urn:schemas-microsoft-com:vml" xmlns:pvml="urn:schemas-microsoft-com:office:powerpoint" xmlns:com="http://schemas.openxmlformats.org/drawingml/2006/compatibility" xmlns:p14="http://schemas.microsoft.com/office/powerpoint/2010/main" xmlns:p15="http://schemas.microsoft.com/office/powerpoint/2012/main" xmlns:ahyp="http://schemas.microsoft.com/office/drawing/2018/hyperlinkcolor">
   <p:cSld>
     <p:spTree>
@@ -28347,1182 +29792,7 @@
 </p:sld>
 </file>
 
-<file path=ppt/slides/slide40.xml><?xml version="1.0" encoding="utf-8"?>
-<p:sld xmlns:a="http://schemas.openxmlformats.org/drawingml/2006/main" xmlns:p="http://schemas.openxmlformats.org/presentationml/2006/main" xmlns:r="http://schemas.openxmlformats.org/officeDocument/2006/relationships">
-  <p:cSld>
-    <p:spTree>
-      <p:nvGrpSpPr>
-        <p:cNvPr id="1" name=""/>
-        <p:cNvGrpSpPr/>
-        <p:nvPr/>
-      </p:nvGrpSpPr>
-      <p:grpSpPr/>
-      <p:sp>
-        <p:nvSpPr>
-          <p:cNvPr id="263" name="Google Shape;263;p46"/>
-          <p:cNvSpPr txBox="1"/>
-          <p:nvPr>
-            <p:ph type="title"/>
-          </p:nvPr>
-        </p:nvSpPr>
-        <p:spPr>
-          <a:xfrm>
-            <a:off x="311700" y="195615"/>
-            <a:ext cx="8520600" cy="572700"/>
-          </a:xfrm>
-          <a:prstGeom prst="rect">
-            <a:avLst/>
-          </a:prstGeom>
-        </p:spPr>
-        <p:txBody>
-          <a:bodyPr anchorCtr="0" anchor="t" bIns="91425" lIns="91425" spcFirstLastPara="1" rIns="91425" wrap="square" tIns="91425">
-            <a:normAutofit fontScale="90000"/>
-          </a:bodyPr>
-          <a:lstStyle/>
-          <a:p>
-            <a:pPr indent="0" lvl="0" marL="0" rtl="0" algn="l">
-              <a:spcBef>
-                <a:spcPts val="0"/>
-              </a:spcBef>
-              <a:spcAft>
-                <a:spcPts val="0"/>
-              </a:spcAft>
-              <a:buNone/>
-            </a:pPr>
-            <a:r>
-              <a:rPr lang="en"/>
-              <a:t>Singleton in Flappy Bird</a:t>
-            </a:r>
-            <a:endParaRPr/>
-          </a:p>
-        </p:txBody>
-      </p:sp>
-      <p:sp>
-        <p:nvSpPr>
-          <p:cNvPr id="243" name="Google Shape;243;p43"/>
-          <p:cNvSpPr txBox="1"/>
-          <p:nvPr>
-            <p:ph idx="1" type="body"/>
-          </p:nvPr>
-        </p:nvSpPr>
-        <p:spPr>
-          <a:xfrm>
-            <a:off x="311700" y="1152475"/>
-            <a:ext cx="3900000" cy="3400000"/>
-          </a:xfrm>
-          <a:prstGeom prst="rect">
-            <a:avLst/>
-          </a:prstGeom>
-        </p:spPr>
-        <p:txBody>
-          <a:bodyPr anchorCtr="0" anchor="t" bIns="91425" lIns="91425" spcFirstLastPara="1" rIns="91425" wrap="square" tIns="91425">
-            <a:normAutofit/>
-          </a:bodyPr>
-          <a:lstStyle/>
-          <a:p>
-            <a:pPr indent="-330200" lvl="0" marL="457200" rtl="0" algn="l">
-              <a:spcBef>
-                <a:spcPts val="0"/>
-              </a:spcBef>
-              <a:spcAft>
-                <a:spcPts val="0"/>
-              </a:spcAft>
-              <a:buSzPts val="1600"/>
-              <a:buChar char="●"/>
-            </a:pPr>
-            <a:r>
-              <a:rPr lang="en"/>
-              <a:t>Audio is a Singleton: one object, reached through Audio.Instance</a:t>
-            </a:r>
-            <a:endParaRPr/>
-          </a:p>
-          <a:p>
-            <a:pPr indent="-330200" lvl="0" marL="457200" rtl="0" algn="l">
-              <a:spcBef>
-                <a:spcPts val="0"/>
-              </a:spcBef>
-              <a:spcAft>
-                <a:spcPts val="0"/>
-              </a:spcAft>
-              <a:buSzPts val="1600"/>
-              <a:buChar char="●"/>
-            </a:pPr>
-            <a:r>
-              <a:rPr lang="en"/>
-              <a:t>Art is a static class</a:t>
-            </a:r>
-            <a:endParaRPr/>
-          </a:p>
-          <a:p>
-            <a:pPr indent="-330200" lvl="0" marL="457200" rtl="0" algn="l">
-              <a:spcBef>
-                <a:spcPts val="0"/>
-              </a:spcBef>
-              <a:spcAft>
-                <a:spcPts val="0"/>
-              </a:spcAft>
-              <a:buSzPts val="1600"/>
-              <a:buChar char="●"/>
-            </a:pPr>
-            <a:r>
-              <a:rPr lang="en"/>
-              <a:t>Both give global access</a:t>
-            </a:r>
-            <a:endParaRPr/>
-          </a:p>
-          <a:p>
-            <a:pPr indent="-330200" lvl="0" marL="457200" rtl="0" algn="l">
-              <a:spcBef>
-                <a:spcPts val="0"/>
-              </a:spcBef>
-              <a:spcAft>
-                <a:spcPts val="0"/>
-              </a:spcAft>
-              <a:buSzPts val="1600"/>
-              <a:buChar char="●"/>
-            </a:pPr>
-            <a:r>
-              <a:rPr lang="en"/>
-              <a:t>But Audio is an object</a:t>
-            </a:r>
-            <a:endParaRPr/>
-          </a:p>
-          <a:p>
-            <a:pPr indent="-317500" lvl="1" marL="914400" rtl="0" algn="l">
-              <a:spcBef>
-                <a:spcPts val="0"/>
-              </a:spcBef>
-              <a:spcAft>
-                <a:spcPts val="0"/>
-              </a:spcAft>
-              <a:buSzPts val="1400"/>
-              <a:buChar char="○"/>
-            </a:pPr>
-            <a:r>
-              <a:rPr lang="en"/>
-              <a:t>It could implement an interface or be passed as a parameter</a:t>
-            </a:r>
-            <a:endParaRPr/>
-          </a:p>
-          <a:p>
-            <a:pPr indent="-317500" lvl="1" marL="914400" rtl="0" algn="l">
-              <a:spcBef>
-                <a:spcPts val="0"/>
-              </a:spcBef>
-              <a:spcAft>
-                <a:spcPts val="0"/>
-              </a:spcAft>
-              <a:buSzPts val="1400"/>
-              <a:buChar char="○"/>
-            </a:pPr>
-            <a:r>
-              <a:rPr lang="en"/>
-              <a:t>Pokemon builds on this with a Service Locator</a:t>
-            </a:r>
-            <a:endParaRPr/>
-          </a:p>
-          <a:p>
-            <a:pPr indent="-330200" lvl="0" marL="457200" rtl="0" algn="l">
-              <a:spcBef>
-                <a:spcPts val="0"/>
-              </a:spcBef>
-              <a:spcAft>
-                <a:spcPts val="0"/>
-              </a:spcAft>
-              <a:buSzPts val="1600"/>
-              <a:buChar char="●"/>
-            </a:pPr>
-            <a:r>
-              <a:rPr lang="en"/>
-              <a:t>Step: Flappy12</a:t>
-            </a:r>
-            <a:endParaRPr/>
-          </a:p>
-        </p:txBody>
-      </p:sp>
-      <p:sp>
-        <p:nvSpPr>
-          <p:cNvPr id="264" name="Google Shape;264;p46"/>
-          <p:cNvSpPr txBox="1"/>
-          <p:nvPr>
-            <p:ph idx="2" type="body"/>
-          </p:nvPr>
-        </p:nvSpPr>
-        <p:spPr>
-          <a:xfrm>
-            <a:off x="4500000" y="1152475"/>
-            <a:ext cx="4400000" cy="3600000"/>
-          </a:xfrm>
-          <a:prstGeom prst="rect">
-            <a:avLst/>
-          </a:prstGeom>
-        </p:spPr>
-        <p:txBody>
-          <a:bodyPr anchorCtr="0" anchor="t" bIns="91425" lIns="91425" spcFirstLastPara="1" rIns="91425" wrap="square" tIns="91425">
-            <a:noAutofit/>
-          </a:bodyPr>
-          <a:lstStyle/>
-          <a:p>
-            <a:pPr indent="0" lvl="0" marL="0" rtl="0" algn="l">
-              <a:lnSpc>
-                <a:spcPct val="115000"/>
-              </a:lnSpc>
-              <a:spcBef>
-                <a:spcPts val="0"/>
-              </a:spcBef>
-              <a:spcAft>
-                <a:spcPts val="0"/>
-              </a:spcAft>
-              <a:buNone/>
-            </a:pPr>
-            <a:r>
-              <a:rPr lang="en" sz="1000">
-                <a:highlight>
-                  <a:srgbClr val="1F1F1F"/>
-                </a:highlight>
-                <a:latin typeface="Consolas"/>
-                <a:ea typeface="Consolas"/>
-                <a:cs typeface="Consolas"/>
-                <a:sym typeface="Consolas"/>
-              </a:rPr>
-              <a:t>public class Audio</a:t>
-            </a:r>
-            <a:endParaRPr sz="1000">
-              <a:solidFill>
-                <a:srgbClr val="4EC9B0"/>
-              </a:solidFill>
-              <a:highlight>
-                <a:srgbClr val="1F1F1F"/>
-              </a:highlight>
-              <a:latin typeface="Consolas"/>
-              <a:ea typeface="Consolas"/>
-              <a:cs typeface="Consolas"/>
-              <a:sym typeface="Consolas"/>
-            </a:endParaRPr>
-          </a:p>
-          <a:p>
-            <a:pPr indent="0" lvl="0" marL="0" rtl="0" algn="l">
-              <a:lnSpc>
-                <a:spcPct val="115000"/>
-              </a:lnSpc>
-              <a:spcBef>
-                <a:spcPts val="0"/>
-              </a:spcBef>
-              <a:spcAft>
-                <a:spcPts val="0"/>
-              </a:spcAft>
-              <a:buNone/>
-            </a:pPr>
-            <a:r>
-              <a:rPr lang="en" sz="1000">
-                <a:highlight>
-                  <a:srgbClr val="1F1F1F"/>
-                </a:highlight>
-                <a:latin typeface="Consolas"/>
-                <a:ea typeface="Consolas"/>
-                <a:cs typeface="Consolas"/>
-                <a:sym typeface="Consolas"/>
-              </a:rPr>
-              <a:t>{</a:t>
-            </a:r>
-            <a:endParaRPr sz="1000">
-              <a:solidFill>
-                <a:srgbClr val="4EC9B0"/>
-              </a:solidFill>
-              <a:highlight>
-                <a:srgbClr val="1F1F1F"/>
-              </a:highlight>
-              <a:latin typeface="Consolas"/>
-              <a:ea typeface="Consolas"/>
-              <a:cs typeface="Consolas"/>
-              <a:sym typeface="Consolas"/>
-            </a:endParaRPr>
-          </a:p>
-          <a:p>
-            <a:pPr indent="0" lvl="0" marL="0" rtl="0" algn="l">
-              <a:lnSpc>
-                <a:spcPct val="115000"/>
-              </a:lnSpc>
-              <a:spcBef>
-                <a:spcPts val="0"/>
-              </a:spcBef>
-              <a:spcAft>
-                <a:spcPts val="0"/>
-              </a:spcAft>
-              <a:buNone/>
-            </a:pPr>
-            <a:r>
-              <a:rPr lang="en" sz="1000">
-                <a:highlight>
-                  <a:srgbClr val="1F1F1F"/>
-                </a:highlight>
-                <a:latin typeface="Consolas"/>
-                <a:ea typeface="Consolas"/>
-                <a:cs typeface="Consolas"/>
-                <a:sym typeface="Consolas"/>
-              </a:rPr>
-              <a:t>    public static Audio Instance { get; }</a:t>
-            </a:r>
-            <a:endParaRPr sz="1000">
-              <a:solidFill>
-                <a:srgbClr val="4EC9B0"/>
-              </a:solidFill>
-              <a:highlight>
-                <a:srgbClr val="1F1F1F"/>
-              </a:highlight>
-              <a:latin typeface="Consolas"/>
-              <a:ea typeface="Consolas"/>
-              <a:cs typeface="Consolas"/>
-              <a:sym typeface="Consolas"/>
-            </a:endParaRPr>
-          </a:p>
-          <a:p>
-            <a:pPr indent="0" lvl="0" marL="0" rtl="0" algn="l">
-              <a:lnSpc>
-                <a:spcPct val="115000"/>
-              </a:lnSpc>
-              <a:spcBef>
-                <a:spcPts val="0"/>
-              </a:spcBef>
-              <a:spcAft>
-                <a:spcPts val="0"/>
-              </a:spcAft>
-              <a:buNone/>
-            </a:pPr>
-            <a:r>
-              <a:rPr lang="en" sz="1000">
-                <a:highlight>
-                  <a:srgbClr val="1F1F1F"/>
-                </a:highlight>
-                <a:latin typeface="Consolas"/>
-                <a:ea typeface="Consolas"/>
-                <a:cs typeface="Consolas"/>
-                <a:sym typeface="Consolas"/>
-              </a:rPr>
-              <a:t>        = new Audio();</a:t>
-            </a:r>
-            <a:endParaRPr sz="1000">
-              <a:solidFill>
-                <a:srgbClr val="4EC9B0"/>
-              </a:solidFill>
-              <a:highlight>
-                <a:srgbClr val="1F1F1F"/>
-              </a:highlight>
-              <a:latin typeface="Consolas"/>
-              <a:ea typeface="Consolas"/>
-              <a:cs typeface="Consolas"/>
-              <a:sym typeface="Consolas"/>
-            </a:endParaRPr>
-          </a:p>
-          <a:p>
-            <a:pPr indent="0" lvl="0" marL="0" rtl="0" algn="l">
-              <a:lnSpc>
-                <a:spcPct val="115000"/>
-              </a:lnSpc>
-              <a:spcBef>
-                <a:spcPts val="0"/>
-              </a:spcBef>
-              <a:spcAft>
-                <a:spcPts val="0"/>
-              </a:spcAft>
-              <a:buNone/>
-            </a:pPr>
-            <a:r>
-              <a:rPr lang="en" sz="1000">
-                <a:highlight>
-                  <a:srgbClr val="1F1F1F"/>
-                </a:highlight>
-                <a:latin typeface="Consolas"/>
-                <a:ea typeface="Consolas"/>
-                <a:cs typeface="Consolas"/>
-                <a:sym typeface="Consolas"/>
-              </a:rPr>
-              <a:t/>
-            </a:r>
-            <a:endParaRPr sz="1000">
-              <a:solidFill>
-                <a:srgbClr val="4EC9B0"/>
-              </a:solidFill>
-              <a:highlight>
-                <a:srgbClr val="1F1F1F"/>
-              </a:highlight>
-              <a:latin typeface="Consolas"/>
-              <a:ea typeface="Consolas"/>
-              <a:cs typeface="Consolas"/>
-              <a:sym typeface="Consolas"/>
-            </a:endParaRPr>
-          </a:p>
-          <a:p>
-            <a:pPr indent="0" lvl="0" marL="0" rtl="0" algn="l">
-              <a:lnSpc>
-                <a:spcPct val="115000"/>
-              </a:lnSpc>
-              <a:spcBef>
-                <a:spcPts val="0"/>
-              </a:spcBef>
-              <a:spcAft>
-                <a:spcPts val="0"/>
-              </a:spcAft>
-              <a:buNone/>
-            </a:pPr>
-            <a:r>
-              <a:rPr lang="en" sz="1000">
-                <a:highlight>
-                  <a:srgbClr val="1F1F1F"/>
-                </a:highlight>
-                <a:latin typeface="Consolas"/>
-                <a:ea typeface="Consolas"/>
-                <a:cs typeface="Consolas"/>
-                <a:sym typeface="Consolas"/>
-              </a:rPr>
-              <a:t>    private Audio() { }</a:t>
-            </a:r>
-            <a:endParaRPr sz="1000">
-              <a:solidFill>
-                <a:srgbClr val="4EC9B0"/>
-              </a:solidFill>
-              <a:highlight>
-                <a:srgbClr val="1F1F1F"/>
-              </a:highlight>
-              <a:latin typeface="Consolas"/>
-              <a:ea typeface="Consolas"/>
-              <a:cs typeface="Consolas"/>
-              <a:sym typeface="Consolas"/>
-            </a:endParaRPr>
-          </a:p>
-          <a:p>
-            <a:pPr indent="0" lvl="0" marL="0" rtl="0" algn="l">
-              <a:lnSpc>
-                <a:spcPct val="115000"/>
-              </a:lnSpc>
-              <a:spcBef>
-                <a:spcPts val="0"/>
-              </a:spcBef>
-              <a:spcAft>
-                <a:spcPts val="0"/>
-              </a:spcAft>
-              <a:buNone/>
-            </a:pPr>
-            <a:r>
-              <a:rPr lang="en" sz="1000">
-                <a:highlight>
-                  <a:srgbClr val="1F1F1F"/>
-                </a:highlight>
-                <a:latin typeface="Consolas"/>
-                <a:ea typeface="Consolas"/>
-                <a:cs typeface="Consolas"/>
-                <a:sym typeface="Consolas"/>
-              </a:rPr>
-              <a:t/>
-            </a:r>
-            <a:endParaRPr sz="1000">
-              <a:solidFill>
-                <a:srgbClr val="4EC9B0"/>
-              </a:solidFill>
-              <a:highlight>
-                <a:srgbClr val="1F1F1F"/>
-              </a:highlight>
-              <a:latin typeface="Consolas"/>
-              <a:ea typeface="Consolas"/>
-              <a:cs typeface="Consolas"/>
-              <a:sym typeface="Consolas"/>
-            </a:endParaRPr>
-          </a:p>
-          <a:p>
-            <a:pPr indent="0" lvl="0" marL="0" rtl="0" algn="l">
-              <a:lnSpc>
-                <a:spcPct val="115000"/>
-              </a:lnSpc>
-              <a:spcBef>
-                <a:spcPts val="0"/>
-              </a:spcBef>
-              <a:spcAft>
-                <a:spcPts val="0"/>
-              </a:spcAft>
-              <a:buNone/>
-            </a:pPr>
-            <a:r>
-              <a:rPr lang="en" sz="1000">
-                <a:highlight>
-                  <a:srgbClr val="1F1F1F"/>
-                </a:highlight>
-                <a:latin typeface="Consolas"/>
-                <a:ea typeface="Consolas"/>
-                <a:cs typeface="Consolas"/>
-                <a:sym typeface="Consolas"/>
-              </a:rPr>
-              <a:t>    public void PlayFlap() =&gt; _flap.Play();</a:t>
-            </a:r>
-            <a:endParaRPr sz="1000">
-              <a:solidFill>
-                <a:srgbClr val="4EC9B0"/>
-              </a:solidFill>
-              <a:highlight>
-                <a:srgbClr val="1F1F1F"/>
-              </a:highlight>
-              <a:latin typeface="Consolas"/>
-              <a:ea typeface="Consolas"/>
-              <a:cs typeface="Consolas"/>
-              <a:sym typeface="Consolas"/>
-            </a:endParaRPr>
-          </a:p>
-          <a:p>
-            <a:pPr indent="0" lvl="0" marL="0" rtl="0" algn="l">
-              <a:lnSpc>
-                <a:spcPct val="115000"/>
-              </a:lnSpc>
-              <a:spcBef>
-                <a:spcPts val="0"/>
-              </a:spcBef>
-              <a:spcAft>
-                <a:spcPts val="0"/>
-              </a:spcAft>
-              <a:buNone/>
-            </a:pPr>
-            <a:r>
-              <a:rPr lang="en" sz="1000">
-                <a:highlight>
-                  <a:srgbClr val="1F1F1F"/>
-                </a:highlight>
-                <a:latin typeface="Consolas"/>
-                <a:ea typeface="Consolas"/>
-                <a:cs typeface="Consolas"/>
-                <a:sym typeface="Consolas"/>
-              </a:rPr>
-              <a:t>    // PlayMusic, PlayScore, PlayCrash...</a:t>
-            </a:r>
-            <a:endParaRPr sz="1000">
-              <a:solidFill>
-                <a:srgbClr val="4EC9B0"/>
-              </a:solidFill>
-              <a:highlight>
-                <a:srgbClr val="1F1F1F"/>
-              </a:highlight>
-              <a:latin typeface="Consolas"/>
-              <a:ea typeface="Consolas"/>
-              <a:cs typeface="Consolas"/>
-              <a:sym typeface="Consolas"/>
-            </a:endParaRPr>
-          </a:p>
-          <a:p>
-            <a:pPr indent="0" lvl="0" marL="0" rtl="0" algn="l">
-              <a:lnSpc>
-                <a:spcPct val="115000"/>
-              </a:lnSpc>
-              <a:spcBef>
-                <a:spcPts val="0"/>
-              </a:spcBef>
-              <a:spcAft>
-                <a:spcPts val="0"/>
-              </a:spcAft>
-              <a:buNone/>
-            </a:pPr>
-            <a:r>
-              <a:rPr lang="en" sz="1000">
-                <a:highlight>
-                  <a:srgbClr val="1F1F1F"/>
-                </a:highlight>
-                <a:latin typeface="Consolas"/>
-                <a:ea typeface="Consolas"/>
-                <a:cs typeface="Consolas"/>
-                <a:sym typeface="Consolas"/>
-              </a:rPr>
-              <a:t>}</a:t>
-            </a:r>
-            <a:endParaRPr sz="1000">
-              <a:solidFill>
-                <a:srgbClr val="4EC9B0"/>
-              </a:solidFill>
-              <a:highlight>
-                <a:srgbClr val="1F1F1F"/>
-              </a:highlight>
-              <a:latin typeface="Consolas"/>
-              <a:ea typeface="Consolas"/>
-              <a:cs typeface="Consolas"/>
-              <a:sym typeface="Consolas"/>
-            </a:endParaRPr>
-          </a:p>
-          <a:p>
-            <a:pPr indent="0" lvl="0" marL="0" rtl="0" algn="l">
-              <a:lnSpc>
-                <a:spcPct val="115000"/>
-              </a:lnSpc>
-              <a:spcBef>
-                <a:spcPts val="0"/>
-              </a:spcBef>
-              <a:spcAft>
-                <a:spcPts val="0"/>
-              </a:spcAft>
-              <a:buNone/>
-            </a:pPr>
-            <a:r>
-              <a:rPr lang="en" sz="1000">
-                <a:highlight>
-                  <a:srgbClr val="1F1F1F"/>
-                </a:highlight>
-                <a:latin typeface="Consolas"/>
-                <a:ea typeface="Consolas"/>
-                <a:cs typeface="Consolas"/>
-                <a:sym typeface="Consolas"/>
-              </a:rPr>
-              <a:t/>
-            </a:r>
-            <a:endParaRPr sz="1000">
-              <a:solidFill>
-                <a:srgbClr val="4EC9B0"/>
-              </a:solidFill>
-              <a:highlight>
-                <a:srgbClr val="1F1F1F"/>
-              </a:highlight>
-              <a:latin typeface="Consolas"/>
-              <a:ea typeface="Consolas"/>
-              <a:cs typeface="Consolas"/>
-              <a:sym typeface="Consolas"/>
-            </a:endParaRPr>
-          </a:p>
-          <a:p>
-            <a:pPr indent="0" lvl="0" marL="0" rtl="0" algn="l">
-              <a:lnSpc>
-                <a:spcPct val="115000"/>
-              </a:lnSpc>
-              <a:spcBef>
-                <a:spcPts val="0"/>
-              </a:spcBef>
-              <a:spcAft>
-                <a:spcPts val="0"/>
-              </a:spcAft>
-              <a:buNone/>
-            </a:pPr>
-            <a:r>
-              <a:rPr lang="en" sz="1000">
-                <a:highlight>
-                  <a:srgbClr val="1F1F1F"/>
-                </a:highlight>
-                <a:latin typeface="Consolas"/>
-                <a:ea typeface="Consolas"/>
-                <a:cs typeface="Consolas"/>
-                <a:sym typeface="Consolas"/>
-              </a:rPr>
-              <a:t>// Anywhere in the game</a:t>
-            </a:r>
-            <a:endParaRPr sz="1000">
-              <a:solidFill>
-                <a:srgbClr val="4EC9B0"/>
-              </a:solidFill>
-              <a:highlight>
-                <a:srgbClr val="1F1F1F"/>
-              </a:highlight>
-              <a:latin typeface="Consolas"/>
-              <a:ea typeface="Consolas"/>
-              <a:cs typeface="Consolas"/>
-              <a:sym typeface="Consolas"/>
-            </a:endParaRPr>
-          </a:p>
-          <a:p>
-            <a:pPr indent="0" lvl="0" marL="0" rtl="0" algn="l">
-              <a:lnSpc>
-                <a:spcPct val="115000"/>
-              </a:lnSpc>
-              <a:spcBef>
-                <a:spcPts val="0"/>
-              </a:spcBef>
-              <a:spcAft>
-                <a:spcPts val="0"/>
-              </a:spcAft>
-              <a:buNone/>
-            </a:pPr>
-            <a:r>
-              <a:rPr lang="en" sz="1000">
-                <a:highlight>
-                  <a:srgbClr val="1F1F1F"/>
-                </a:highlight>
-                <a:latin typeface="Consolas"/>
-                <a:ea typeface="Consolas"/>
-                <a:cs typeface="Consolas"/>
-                <a:sym typeface="Consolas"/>
-              </a:rPr>
-              <a:t>Audio.Instance.PlayFlap();</a:t>
-            </a:r>
-            <a:endParaRPr sz="1000">
-              <a:solidFill>
-                <a:srgbClr val="4EC9B0"/>
-              </a:solidFill>
-              <a:highlight>
-                <a:srgbClr val="1F1F1F"/>
-              </a:highlight>
-              <a:latin typeface="Consolas"/>
-              <a:ea typeface="Consolas"/>
-              <a:cs typeface="Consolas"/>
-              <a:sym typeface="Consolas"/>
-            </a:endParaRPr>
-          </a:p>
-        </p:txBody>
-      </p:sp>
-    </p:spTree>
-  </p:cSld>
-  <p:clrMapOvr>
-    <a:masterClrMapping/>
-  </p:clrMapOvr>
-</p:sld>
-</file>
-
-<file path=ppt/slides/slide41.xml><?xml version="1.0" encoding="utf-8"?>
-<p:sld xmlns:a="http://schemas.openxmlformats.org/drawingml/2006/main" xmlns:p="http://schemas.openxmlformats.org/presentationml/2006/main" xmlns:r="http://schemas.openxmlformats.org/officeDocument/2006/relationships">
-  <p:cSld>
-    <p:spTree>
-      <p:nvGrpSpPr>
-        <p:cNvPr id="1" name=""/>
-        <p:cNvGrpSpPr/>
-        <p:nvPr/>
-      </p:nvGrpSpPr>
-      <p:grpSpPr/>
-      <p:sp>
-        <p:nvSpPr>
-          <p:cNvPr id="2" name="Title 1"/>
-          <p:cNvSpPr>
-            <a:spLocks noGrp="1"/>
-          </p:cNvSpPr>
-          <p:nvPr>
-            <p:ph type="title"/>
-          </p:nvPr>
-        </p:nvSpPr>
-        <p:spPr/>
-        <p:txBody>
-          <a:bodyPr/>
-          <a:lstStyle/>
-          <a:p>
-            <a:pPr indent="0" lvl="0" marL="0" rtl="0" algn="l">
-              <a:spcBef>
-                <a:spcPts val="0"/>
-              </a:spcBef>
-              <a:spcAft>
-                <a:spcPts val="0"/>
-              </a:spcAft>
-              <a:buNone/>
-            </a:pPr>
-            <a:r>
-              <a:rPr lang="en"/>
-              <a:t>Check Yourself</a:t>
-            </a:r>
-            <a:endParaRPr/>
-          </a:p>
-        </p:txBody>
-      </p:sp>
-      <p:sp>
-        <p:nvSpPr>
-          <p:cNvPr id="3" name="Text Placeholder 2"/>
-          <p:cNvSpPr>
-            <a:spLocks noGrp="1"/>
-          </p:cNvSpPr>
-          <p:nvPr>
-            <p:ph type="body" idx="1"/>
-          </p:nvPr>
-        </p:nvSpPr>
-        <p:spPr>
-          <a:xfrm>
-            <a:off x="311700" y="885950"/>
-            <a:ext cx="8520600" cy="1335024"/>
-          </a:xfrm>
-        </p:spPr>
-        <p:txBody>
-          <a:bodyPr/>
-          <a:lstStyle/>
-          <a:p>
-            <a:pPr indent="-330200" lvl="0" marL="457200" rtl="0" algn="l">
-              <a:spcBef>
-                <a:spcPts val="0"/>
-              </a:spcBef>
-              <a:spcAft>
-                <a:spcPts val="0"/>
-              </a:spcAft>
-              <a:buSzPts val="1600"/>
-              <a:buChar char="●"/>
-            </a:pPr>
-            <a:r>
-              <a:rPr lang="en"/>
-              <a:t>What problem does a state machine solve compared to a string or enum field?</a:t>
-            </a:r>
-            <a:endParaRPr/>
-          </a:p>
-          <a:p>
-            <a:pPr indent="-330200" lvl="0" marL="457200" rtl="0" algn="l">
-              <a:spcBef>
-                <a:spcPts val="0"/>
-              </a:spcBef>
-              <a:spcAft>
-                <a:spcPts val="0"/>
-              </a:spcAft>
-              <a:buSzPts val="1600"/>
-              <a:buChar char="●"/>
-            </a:pPr>
-            <a:r>
-              <a:rPr lang="en"/>
-              <a:t>What happens if you forget to call Exit() when switching state?</a:t>
-            </a:r>
-            <a:endParaRPr/>
-          </a:p>
-          <a:p>
-            <a:pPr indent="-330200" lvl="0" marL="457200" rtl="0" algn="l">
-              <a:spcBef>
-                <a:spcPts val="0"/>
-              </a:spcBef>
-              <a:spcAft>
-                <a:spcPts val="0"/>
-              </a:spcAft>
-              <a:buSzPts val="1600"/>
-              <a:buChar char="●"/>
-            </a:pPr>
-            <a:r>
-              <a:rPr lang="en"/>
-              <a:t>Why is Singleton considered an anti-pattern by many game programmers?</a:t>
-            </a:r>
-            <a:endParaRPr/>
-          </a:p>
-        </p:txBody>
-      </p:sp>
-      <p:sp>
-        <p:nvSpPr>
-          <p:cNvPr id="4" name="TextBox 3"/>
-          <p:cNvSpPr txBox="1"/>
-          <p:nvPr/>
-        </p:nvSpPr>
-        <p:spPr>
-          <a:xfrm>
-            <a:off x="457200" y="2798064"/>
-            <a:ext cx="8229600" cy="457200"/>
-          </a:xfrm>
-          <a:prstGeom prst="rect">
-            <a:avLst/>
-          </a:prstGeom>
-          <a:noFill/>
-        </p:spPr>
-        <p:txBody>
-          <a:bodyPr wrap="square">
-            <a:spAutoFit/>
-          </a:bodyPr>
-          <a:lstStyle/>
-          <a:p>
-            <a:pPr algn="ctr"/>
-            <a:r>
-              <a:rPr sz="1400" b="0" i="0">
-                <a:solidFill>
-                  <a:srgbClr val="9AA3AB"/>
-                </a:solidFill>
-              </a:rPr>
-              <a:t>The answers, and more questions, are on the course site.</a:t>
-            </a:r>
-          </a:p>
-        </p:txBody>
-      </p:sp>
-    </p:spTree>
-  </p:cSld>
-  <p:clrMapOvr>
-    <a:masterClrMapping/>
-  </p:clrMapOvr>
-</p:sld>
-</file>
-
-<file path=ppt/slides/slide42.xml><?xml version="1.0" encoding="utf-8"?>
-<p:sld xmlns:a="http://schemas.openxmlformats.org/drawingml/2006/main" xmlns:p="http://schemas.openxmlformats.org/presentationml/2006/main" xmlns:r="http://schemas.openxmlformats.org/officeDocument/2006/relationships">
-  <p:cSld>
-    <p:spTree>
-      <p:nvGrpSpPr>
-        <p:cNvPr id="1" name=""/>
-        <p:cNvGrpSpPr/>
-        <p:nvPr/>
-      </p:nvGrpSpPr>
-      <p:grpSpPr/>
-      <p:sp>
-        <p:nvSpPr>
-          <p:cNvPr id="57" name="Google Shape;57;p12"/>
-          <p:cNvSpPr txBox="1"/>
-          <p:nvPr>
-            <p:ph type="title"/>
-          </p:nvPr>
-        </p:nvSpPr>
-        <p:spPr>
-          <a:xfrm>
-            <a:off x="311700" y="195615"/>
-            <a:ext cx="8520600" cy="572700"/>
-          </a:xfrm>
-          <a:prstGeom prst="rect">
-            <a:avLst/>
-          </a:prstGeom>
-        </p:spPr>
-        <p:txBody>
-          <a:bodyPr anchorCtr="0" anchor="t" bIns="91425" lIns="91425" spcFirstLastPara="1" rIns="91425" wrap="square" tIns="91425">
-            <a:normAutofit fontScale="90000"/>
-          </a:bodyPr>
-          <a:lstStyle/>
-          <a:p>
-            <a:pPr indent="0" lvl="0" marL="0" rtl="0" algn="l">
-              <a:spcBef>
-                <a:spcPts val="0"/>
-              </a:spcBef>
-              <a:spcAft>
-                <a:spcPts val="0"/>
-              </a:spcAft>
-              <a:buNone/>
-            </a:pPr>
-            <a:r>
-              <a:rPr lang="en"/>
-              <a:t>Apply It to Your Project</a:t>
-            </a:r>
-            <a:endParaRPr/>
-          </a:p>
-        </p:txBody>
-      </p:sp>
-      <p:sp>
-        <p:nvSpPr>
-          <p:cNvPr id="58" name="Google Shape;58;p12"/>
-          <p:cNvSpPr txBox="1"/>
-          <p:nvPr>
-            <p:ph idx="1" type="body"/>
-          </p:nvPr>
-        </p:nvSpPr>
-        <p:spPr>
-          <a:xfrm>
-            <a:off x="311700" y="885950"/>
-            <a:ext cx="8520600" cy="4023300"/>
-          </a:xfrm>
-          <a:prstGeom prst="rect">
-            <a:avLst/>
-          </a:prstGeom>
-        </p:spPr>
-        <p:txBody>
-          <a:bodyPr anchorCtr="0" anchor="t" bIns="91425" lIns="91425" spcFirstLastPara="1" rIns="91425" wrap="square" tIns="91425">
-            <a:normAutofit/>
-          </a:bodyPr>
-          <a:lstStyle/>
-          <a:p>
-            <a:pPr indent="-330200" lvl="0" marL="457200" rtl="0" algn="l">
-              <a:spcBef>
-                <a:spcPts val="0"/>
-              </a:spcBef>
-              <a:spcAft>
-                <a:spcPts val="0"/>
-              </a:spcAft>
-              <a:buSzPts val="1600"/>
-              <a:buChar char="●"/>
-            </a:pPr>
-            <a:r>
-              <a:rPr lang="en"/>
-              <a:t>Which code in your game could another game reuse?</a:t>
-            </a:r>
-            <a:endParaRPr/>
-          </a:p>
-          <a:p>
-            <a:pPr indent="-317500" lvl="1" marL="914400" rtl="0" algn="l">
-              <a:spcBef>
-                <a:spcPts val="0"/>
-              </a:spcBef>
-              <a:spcAft>
-                <a:spcPts val="0"/>
-              </a:spcAft>
-              <a:buSzPts val="1400"/>
-              <a:buChar char="○"/>
-            </a:pPr>
-            <a:r>
-              <a:rPr lang="en"/>
-              <a:t>That belongs in a class library, like GMDCore</a:t>
-            </a:r>
-            <a:endParaRPr/>
-          </a:p>
-          <a:p>
-            <a:pPr indent="-330200" lvl="0" marL="457200" rtl="0" algn="l">
-              <a:spcBef>
-                <a:spcPts val="0"/>
-              </a:spcBef>
-              <a:spcAft>
-                <a:spcPts val="0"/>
-              </a:spcAft>
-              <a:buSzPts val="1600"/>
-              <a:buChar char="●"/>
-            </a:pPr>
-            <a:r>
-              <a:rPr lang="en"/>
-              <a:t>Which states does your game have? Draw them as a state diagram</a:t>
-            </a:r>
-            <a:endParaRPr/>
-          </a:p>
-          <a:p>
-            <a:pPr indent="-330200" lvl="0" marL="457200" rtl="0" algn="l">
-              <a:spcBef>
-                <a:spcPts val="0"/>
-              </a:spcBef>
-              <a:spcAft>
-                <a:spcPts val="0"/>
-              </a:spcAft>
-              <a:buSzPts val="1600"/>
-              <a:buChar char="●"/>
-            </a:pPr>
-            <a:r>
-              <a:rPr lang="en"/>
-              <a:t>Is anything in your game global? Does it need to be?</a:t>
-            </a:r>
-            <a:endParaRPr/>
-          </a:p>
-        </p:txBody>
-      </p:sp>
-    </p:spTree>
-  </p:cSld>
-  <p:clrMapOvr>
-    <a:masterClrMapping/>
-  </p:clrMapOvr>
-</p:sld>
-</file>
-
-<file path=ppt/slides/slide43.xml><?xml version="1.0" encoding="utf-8"?>
-<p:sld xmlns:a="http://schemas.openxmlformats.org/drawingml/2006/main" xmlns:p="http://schemas.openxmlformats.org/presentationml/2006/main" xmlns:r="http://schemas.openxmlformats.org/officeDocument/2006/relationships">
-  <p:cSld>
-    <p:spTree>
-      <p:nvGrpSpPr>
-        <p:cNvPr id="1" name=""/>
-        <p:cNvGrpSpPr/>
-        <p:nvPr/>
-      </p:nvGrpSpPr>
-      <p:grpSpPr/>
-      <p:sp>
-        <p:nvSpPr>
-          <p:cNvPr id="57" name="Google Shape;57;p12"/>
-          <p:cNvSpPr txBox="1"/>
-          <p:nvPr>
-            <p:ph type="title"/>
-          </p:nvPr>
-        </p:nvSpPr>
-        <p:spPr>
-          <a:xfrm>
-            <a:off x="311700" y="195615"/>
-            <a:ext cx="8520600" cy="572700"/>
-          </a:xfrm>
-          <a:prstGeom prst="rect">
-            <a:avLst/>
-          </a:prstGeom>
-        </p:spPr>
-        <p:txBody>
-          <a:bodyPr anchorCtr="0" anchor="t" bIns="91425" lIns="91425" spcFirstLastPara="1" rIns="91425" wrap="square" tIns="91425">
-            <a:normAutofit fontScale="90000"/>
-          </a:bodyPr>
-          <a:lstStyle/>
-          <a:p>
-            <a:pPr indent="0" lvl="0" marL="0" rtl="0" algn="l">
-              <a:spcBef>
-                <a:spcPts val="0"/>
-              </a:spcBef>
-              <a:spcAft>
-                <a:spcPts val="0"/>
-              </a:spcAft>
-              <a:buNone/>
-            </a:pPr>
-            <a:r>
-              <a:rPr lang="en"/>
-              <a:t>Your Course Project</a:t>
-            </a:r>
-            <a:endParaRPr/>
-          </a:p>
-        </p:txBody>
-      </p:sp>
-      <p:sp>
-        <p:nvSpPr>
-          <p:cNvPr id="58" name="Google Shape;58;p12"/>
-          <p:cNvSpPr txBox="1"/>
-          <p:nvPr>
-            <p:ph idx="1" type="body"/>
-          </p:nvPr>
-        </p:nvSpPr>
-        <p:spPr>
-          <a:xfrm>
-            <a:off x="311700" y="885950"/>
-            <a:ext cx="8520600" cy="4023300"/>
-          </a:xfrm>
-          <a:prstGeom prst="rect">
-            <a:avLst/>
-          </a:prstGeom>
-        </p:spPr>
-        <p:txBody>
-          <a:bodyPr anchorCtr="0" anchor="t" bIns="91425" lIns="91425" spcFirstLastPara="1" rIns="91425" wrap="square" tIns="91425">
-            <a:normAutofit/>
-          </a:bodyPr>
-          <a:lstStyle/>
-          <a:p>
-            <a:pPr indent="-330200" lvl="0" marL="457200" rtl="0" algn="l">
-              <a:spcBef>
-                <a:spcPts val="0"/>
-              </a:spcBef>
-              <a:spcAft>
-                <a:spcPts val="0"/>
-              </a:spcAft>
-              <a:buSzPts val="1600"/>
-              <a:buChar char="●"/>
-            </a:pPr>
-            <a:r>
-              <a:rPr lang="en"/>
-              <a:t>Start from the gar-starter template on GitHub</a:t>
-            </a:r>
-            <a:endParaRPr/>
-          </a:p>
-          <a:p>
-            <a:pPr indent="-317500" lvl="1" marL="914400" rtl="0" algn="l">
-              <a:spcBef>
-                <a:spcPts val="0"/>
-              </a:spcBef>
-              <a:spcAft>
-                <a:spcPts val="0"/>
-              </a:spcAft>
-              <a:buSzPts val="1400"/>
-              <a:buChar char="○"/>
-            </a:pPr>
-            <a:r>
-              <a:rPr lang="en"/>
-              <a:t>“Use this template”: an empty game with the content builder</a:t>
-            </a:r>
-            <a:endParaRPr/>
-          </a:p>
-          <a:p>
-            <a:pPr indent="-330200" lvl="0" marL="457200" rtl="0" algn="l">
-              <a:spcBef>
-                <a:spcPts val="0"/>
-              </a:spcBef>
-              <a:spcAft>
-                <a:spcPts val="0"/>
-              </a:spcAft>
-              <a:buSzPts val="1600"/>
-              <a:buChar char="●"/>
-            </a:pPr>
-            <a:r>
-              <a:rPr lang="en"/>
-              <a:t>First milestone, by session 04</a:t>
-            </a:r>
-            <a:endParaRPr/>
-          </a:p>
-          <a:p>
-            <a:pPr indent="-317500" lvl="1" marL="914400" rtl="0" algn="l">
-              <a:spcBef>
-                <a:spcPts val="0"/>
-              </a:spcBef>
-              <a:spcAft>
-                <a:spcPts val="0"/>
-              </a:spcAft>
-              <a:buSzPts val="1400"/>
-              <a:buChar char="○"/>
-            </a:pPr>
-            <a:r>
-              <a:rPr lang="en"/>
-              <a:t>Groups formed, game concept written, repository created and link uploaded to itslearning</a:t>
-            </a:r>
-            <a:endParaRPr/>
-          </a:p>
-        </p:txBody>
-      </p:sp>
-    </p:spTree>
-  </p:cSld>
-  <p:clrMapOvr>
-    <a:masterClrMapping/>
-  </p:clrMapOvr>
-</p:sld>
-</file>
-
-<file path=ppt/slides/slide5.xml><?xml version="1.0" encoding="utf-8"?>
+<file path=ppt/slides/slide6.xml><?xml version="1.0" encoding="utf-8"?>
 <p:sld xmlns:a="http://schemas.openxmlformats.org/drawingml/2006/main" xmlns:r="http://schemas.openxmlformats.org/officeDocument/2006/relationships" xmlns:mc="http://schemas.openxmlformats.org/markup-compatibility/2006" xmlns:mv="urn:schemas-microsoft-com:mac:vml" xmlns:p="http://schemas.openxmlformats.org/presentationml/2006/main" xmlns:c="http://schemas.openxmlformats.org/drawingml/2006/chart" xmlns:dgm="http://schemas.openxmlformats.org/drawingml/2006/diagram" xmlns:o="urn:schemas-microsoft-com:office:office" xmlns:v="urn:schemas-microsoft-com:vml" xmlns:pvml="urn:schemas-microsoft-com:office:powerpoint" xmlns:com="http://schemas.openxmlformats.org/drawingml/2006/compatibility" xmlns:p14="http://schemas.microsoft.com/office/powerpoint/2010/main" xmlns:p15="http://schemas.microsoft.com/office/powerpoint/2012/main" xmlns:ahyp="http://schemas.microsoft.com/office/drawing/2018/hyperlinkcolor">
   <p:cSld>
     <p:spTree>
@@ -29575,7 +29845,7 @@
 </p:sld>
 </file>
 
-<file path=ppt/slides/slide6.xml><?xml version="1.0" encoding="utf-8"?>
+<file path=ppt/slides/slide7.xml><?xml version="1.0" encoding="utf-8"?>
 <p:sld xmlns:a="http://schemas.openxmlformats.org/drawingml/2006/main" xmlns:r="http://schemas.openxmlformats.org/officeDocument/2006/relationships" xmlns:mc="http://schemas.openxmlformats.org/markup-compatibility/2006" xmlns:mv="urn:schemas-microsoft-com:mac:vml" xmlns:p="http://schemas.openxmlformats.org/presentationml/2006/main" xmlns:c="http://schemas.openxmlformats.org/drawingml/2006/chart" xmlns:dgm="http://schemas.openxmlformats.org/drawingml/2006/diagram" xmlns:o="urn:schemas-microsoft-com:office:office" xmlns:v="urn:schemas-microsoft-com:vml" xmlns:pvml="urn:schemas-microsoft-com:office:powerpoint" xmlns:com="http://schemas.openxmlformats.org/drawingml/2006/compatibility" xmlns:p14="http://schemas.microsoft.com/office/powerpoint/2010/main" xmlns:p15="http://schemas.microsoft.com/office/powerpoint/2012/main" xmlns:ahyp="http://schemas.microsoft.com/office/drawing/2018/hyperlinkcolor">
   <p:cSld>
     <p:spTree>
@@ -29668,7 +29938,7 @@
 </p:sld>
 </file>
 
-<file path=ppt/slides/slide7.xml><?xml version="1.0" encoding="utf-8"?>
+<file path=ppt/slides/slide8.xml><?xml version="1.0" encoding="utf-8"?>
 <p:sld xmlns:a="http://schemas.openxmlformats.org/drawingml/2006/main" xmlns:r="http://schemas.openxmlformats.org/officeDocument/2006/relationships" xmlns:mc="http://schemas.openxmlformats.org/markup-compatibility/2006" xmlns:mv="urn:schemas-microsoft-com:mac:vml" xmlns:p="http://schemas.openxmlformats.org/presentationml/2006/main" xmlns:c="http://schemas.openxmlformats.org/drawingml/2006/chart" xmlns:dgm="http://schemas.openxmlformats.org/drawingml/2006/diagram" xmlns:o="urn:schemas-microsoft-com:office:office" xmlns:v="urn:schemas-microsoft-com:vml" xmlns:pvml="urn:schemas-microsoft-com:office:powerpoint" xmlns:com="http://schemas.openxmlformats.org/drawingml/2006/compatibility" xmlns:p14="http://schemas.microsoft.com/office/powerpoint/2010/main" xmlns:p15="http://schemas.microsoft.com/office/powerpoint/2012/main" xmlns:ahyp="http://schemas.microsoft.com/office/drawing/2018/hyperlinkcolor">
   <p:cSld>
     <p:spTree>
@@ -29761,7 +30031,7 @@
 </p:sld>
 </file>
 
-<file path=ppt/slides/slide8.xml><?xml version="1.0" encoding="utf-8"?>
+<file path=ppt/slides/slide9.xml><?xml version="1.0" encoding="utf-8"?>
 <p:sld xmlns:a="http://schemas.openxmlformats.org/drawingml/2006/main" xmlns:r="http://schemas.openxmlformats.org/officeDocument/2006/relationships" xmlns:mc="http://schemas.openxmlformats.org/markup-compatibility/2006" xmlns:mv="urn:schemas-microsoft-com:mac:vml" xmlns:p="http://schemas.openxmlformats.org/presentationml/2006/main" xmlns:c="http://schemas.openxmlformats.org/drawingml/2006/chart" xmlns:dgm="http://schemas.openxmlformats.org/drawingml/2006/diagram" xmlns:o="urn:schemas-microsoft-com:office:office" xmlns:v="urn:schemas-microsoft-com:vml" xmlns:pvml="urn:schemas-microsoft-com:office:powerpoint" xmlns:com="http://schemas.openxmlformats.org/drawingml/2006/compatibility" xmlns:p14="http://schemas.microsoft.com/office/powerpoint/2010/main" xmlns:p15="http://schemas.microsoft.com/office/powerpoint/2012/main" xmlns:ahyp="http://schemas.microsoft.com/office/drawing/2018/hyperlinkcolor">
   <p:cSld>
     <p:spTree>
@@ -29881,99 +30151,6 @@
           </a:p>
         </p:txBody>
       </p:sp>
-    </p:spTree>
-  </p:cSld>
-  <p:clrMapOvr>
-    <a:masterClrMapping/>
-  </p:clrMapOvr>
-</p:sld>
-</file>
-
-<file path=ppt/slides/slide9.xml><?xml version="1.0" encoding="utf-8"?>
-<p:sld xmlns:a="http://schemas.openxmlformats.org/drawingml/2006/main" xmlns:r="http://schemas.openxmlformats.org/officeDocument/2006/relationships" xmlns:mc="http://schemas.openxmlformats.org/markup-compatibility/2006" xmlns:mv="urn:schemas-microsoft-com:mac:vml" xmlns:p="http://schemas.openxmlformats.org/presentationml/2006/main" xmlns:c="http://schemas.openxmlformats.org/drawingml/2006/chart" xmlns:dgm="http://schemas.openxmlformats.org/drawingml/2006/diagram" xmlns:o="urn:schemas-microsoft-com:office:office" xmlns:v="urn:schemas-microsoft-com:vml" xmlns:pvml="urn:schemas-microsoft-com:office:powerpoint" xmlns:com="http://schemas.openxmlformats.org/drawingml/2006/compatibility" xmlns:p14="http://schemas.microsoft.com/office/powerpoint/2010/main" xmlns:p15="http://schemas.microsoft.com/office/powerpoint/2012/main" xmlns:ahyp="http://schemas.microsoft.com/office/drawing/2018/hyperlinkcolor">
-  <p:cSld>
-    <p:spTree>
-      <p:nvGrpSpPr>
-        <p:cNvPr id="85" name="Shape 85"/>
-        <p:cNvGrpSpPr/>
-        <p:nvPr/>
-      </p:nvGrpSpPr>
-      <p:grpSpPr>
-        <a:xfrm>
-          <a:off x="0" y="0"/>
-          <a:ext cx="0" cy="0"/>
-          <a:chOff x="0" y="0"/>
-          <a:chExt cx="0" cy="0"/>
-        </a:xfrm>
-      </p:grpSpPr>
-      <p:sp>
-        <p:nvSpPr>
-          <p:cNvPr id="86" name="Google Shape;86;p17"/>
-          <p:cNvSpPr txBox="1"/>
-          <p:nvPr>
-            <p:ph type="title"/>
-          </p:nvPr>
-        </p:nvSpPr>
-        <p:spPr>
-          <a:xfrm>
-            <a:off x="311700" y="195615"/>
-            <a:ext cx="8520600" cy="572700"/>
-          </a:xfrm>
-          <a:prstGeom prst="rect">
-            <a:avLst/>
-          </a:prstGeom>
-        </p:spPr>
-        <p:txBody>
-          <a:bodyPr anchorCtr="0" anchor="t" bIns="91425" lIns="91425" spcFirstLastPara="1" rIns="91425" wrap="square" tIns="91425">
-            <a:normAutofit fontScale="90000"/>
-          </a:bodyPr>
-          <a:lstStyle/>
-          <a:p>
-            <a:pPr indent="0" lvl="0" marL="0" rtl="0" algn="l">
-              <a:spcBef>
-                <a:spcPts val="0"/>
-              </a:spcBef>
-              <a:spcAft>
-                <a:spcPts val="0"/>
-              </a:spcAft>
-              <a:buNone/>
-            </a:pPr>
-            <a:r>
-              <a:rPr lang="en"/>
-              <a:t>Class Library</a:t>
-            </a:r>
-            <a:endParaRPr/>
-          </a:p>
-        </p:txBody>
-      </p:sp>
-      <p:pic>
-        <p:nvPicPr>
-          <p:cNvPr id="87" name="Google Shape;87;p17"/>
-          <p:cNvPicPr preferRelativeResize="0"/>
-          <p:nvPr/>
-        </p:nvPicPr>
-        <p:blipFill>
-          <a:blip r:embed="rId3">
-            <a:alphaModFix/>
-          </a:blip>
-          <a:stretch>
-            <a:fillRect/>
-          </a:stretch>
-        </p:blipFill>
-        <p:spPr>
-          <a:xfrm>
-            <a:off x="270188" y="1400650"/>
-            <a:ext cx="8603624" cy="2342200"/>
-          </a:xfrm>
-          <a:prstGeom prst="rect">
-            <a:avLst/>
-          </a:prstGeom>
-          <a:noFill/>
-          <a:ln>
-            <a:noFill/>
-          </a:ln>
-        </p:spPr>
-      </p:pic>
     </p:spTree>
   </p:cSld>
   <p:clrMapOvr>

</xml_diff>

<commit_message>
Slides keep to the topic: no milestones, due dates or course admin
- The Your Course Project slide goes from every deck; Pong also loses its session plan
  (it was out of date), course project and exam slides
- Flappy says "as in Pong" instead of "last week"

Co-Authored-By: Claude Opus 5.5 <noreply@anthropic.com>
Claude-Session: https://claude.ai/code/session_012sjsUQBbC7zon57rWHoo9d
</commit_message>
<xml_diff>
--- a/slides/02 Flappy Bird.pptx
+++ b/slides/02 Flappy Bird.pptx
@@ -51,7 +51,6 @@
     <p:sldId id="295" r:id="rId54"/>
     <p:sldId id="298" r:id="rId57"/>
     <p:sldId id="296" r:id="rId55"/>
-    <p:sldId id="297" r:id="rId56"/>
   </p:sldIdLst>
   <p:sldSz cy="5143500" cx="9144000"/>
   <p:notesSz cx="6858000" cy="9144000"/>
@@ -4027,64 +4026,6 @@
           <a:p>
             <a:r>
               <a:t>Art is a static class, Audio a Singleton. Both global; but Audio is an object, so it could implement an interface. Pokemon builds on that with a Service Locator.</a:t>
-            </a:r>
-          </a:p>
-        </p:txBody>
-      </p:sp>
-    </p:spTree>
-  </p:cSld>
-  <p:clrMapOvr>
-    <a:masterClrMapping/>
-  </p:clrMapOvr>
-</p:notes>
-</file>
-
-<file path=ppt/notesSlides/notesSlide42.xml><?xml version="1.0" encoding="utf-8"?>
-<p:notes xmlns:a="http://schemas.openxmlformats.org/drawingml/2006/main" xmlns:p="http://schemas.openxmlformats.org/presentationml/2006/main" xmlns:r="http://schemas.openxmlformats.org/officeDocument/2006/relationships">
-  <p:cSld>
-    <p:spTree>
-      <p:nvGrpSpPr>
-        <p:cNvPr id="1" name=""/>
-        <p:cNvGrpSpPr/>
-        <p:nvPr/>
-      </p:nvGrpSpPr>
-      <p:grpSpPr>
-        <a:xfrm>
-          <a:off x="0" y="0"/>
-          <a:ext cx="0" cy="0"/>
-          <a:chOff x="0" y="0"/>
-          <a:chExt cx="0" cy="0"/>
-        </a:xfrm>
-      </p:grpSpPr>
-      <p:sp>
-        <p:nvSpPr>
-          <p:cNvPr id="2" name="Slide Image Placeholder 1"/>
-          <p:cNvSpPr>
-            <a:spLocks noGrp="1"/>
-          </p:cNvSpPr>
-          <p:nvPr>
-            <p:ph type="sldImg" idx="2"/>
-          </p:nvPr>
-        </p:nvSpPr>
-        <p:spPr/>
-      </p:sp>
-      <p:sp>
-        <p:nvSpPr>
-          <p:cNvPr id="3" name="Notes Placeholder 2"/>
-          <p:cNvSpPr>
-            <a:spLocks noGrp="1"/>
-          </p:cNvSpPr>
-          <p:nvPr>
-            <p:ph type="body" idx="1"/>
-          </p:nvPr>
-        </p:nvSpPr>
-        <p:spPr/>
-        <p:txBody>
-          <a:bodyPr/>
-          <a:lstStyle/>
-          <a:p>
-            <a:r>
-              <a:t>Start from the gar-starter template. First milestone by session 04: groups, a concept, a repository, the link on itslearning.</a:t>
             </a:r>
           </a:p>
         </p:txBody>
@@ -10616,7 +10557,7 @@
             </a:pPr>
             <a:r>
               <a:rPr lang="en"/>
-              <a:t>Remember from last week?</a:t>
+              <a:t>Remember from Pong?</a:t>
             </a:r>
             <a:endParaRPr/>
           </a:p>
@@ -16902,7 +16843,7 @@
             </a:pPr>
             <a:r>
               <a:rPr lang="en"/>
-              <a:t>AABB - same as last week!</a:t>
+              <a:t>AABB, as in Pong</a:t>
             </a:r>
             <a:endParaRPr/>
           </a:p>
@@ -29193,156 +29134,6 @@
 </p:sld>
 </file>
 
-<file path=ppt/slides/slide44.xml><?xml version="1.0" encoding="utf-8"?>
-<p:sld xmlns:a="http://schemas.openxmlformats.org/drawingml/2006/main" xmlns:p="http://schemas.openxmlformats.org/presentationml/2006/main" xmlns:r="http://schemas.openxmlformats.org/officeDocument/2006/relationships">
-  <p:cSld>
-    <p:spTree>
-      <p:nvGrpSpPr>
-        <p:cNvPr id="1" name=""/>
-        <p:cNvGrpSpPr/>
-        <p:nvPr/>
-      </p:nvGrpSpPr>
-      <p:grpSpPr/>
-      <p:sp>
-        <p:nvSpPr>
-          <p:cNvPr id="57" name="Google Shape;57;p12"/>
-          <p:cNvSpPr txBox="1"/>
-          <p:nvPr>
-            <p:ph type="title"/>
-          </p:nvPr>
-        </p:nvSpPr>
-        <p:spPr>
-          <a:xfrm>
-            <a:off x="311700" y="195615"/>
-            <a:ext cx="8520600" cy="572700"/>
-          </a:xfrm>
-          <a:prstGeom prst="rect">
-            <a:avLst/>
-          </a:prstGeom>
-        </p:spPr>
-        <p:txBody>
-          <a:bodyPr anchorCtr="0" anchor="t" bIns="91425" lIns="91425" spcFirstLastPara="1" rIns="91425" wrap="square" tIns="91425">
-            <a:normAutofit fontScale="90000"/>
-          </a:bodyPr>
-          <a:lstStyle/>
-          <a:p>
-            <a:pPr indent="0" lvl="0" marL="0" rtl="0" algn="l">
-              <a:spcBef>
-                <a:spcPts val="0"/>
-              </a:spcBef>
-              <a:spcAft>
-                <a:spcPts val="0"/>
-              </a:spcAft>
-              <a:buNone/>
-            </a:pPr>
-            <a:r>
-              <a:rPr lang="en"/>
-              <a:t>Your Course Project</a:t>
-            </a:r>
-            <a:endParaRPr/>
-          </a:p>
-        </p:txBody>
-      </p:sp>
-      <p:sp>
-        <p:nvSpPr>
-          <p:cNvPr id="58" name="Google Shape;58;p12"/>
-          <p:cNvSpPr txBox="1"/>
-          <p:nvPr>
-            <p:ph idx="1" type="body"/>
-          </p:nvPr>
-        </p:nvSpPr>
-        <p:spPr>
-          <a:xfrm>
-            <a:off x="311700" y="885950"/>
-            <a:ext cx="8520600" cy="4023300"/>
-          </a:xfrm>
-          <a:prstGeom prst="rect">
-            <a:avLst/>
-          </a:prstGeom>
-        </p:spPr>
-        <p:txBody>
-          <a:bodyPr anchorCtr="0" anchor="t" bIns="91425" lIns="91425" spcFirstLastPara="1" rIns="91425" wrap="square" tIns="91425">
-            <a:normAutofit/>
-          </a:bodyPr>
-          <a:lstStyle/>
-          <a:p>
-            <a:pPr indent="-330200" lvl="0" marL="457200" rtl="0" algn="l">
-              <a:spcBef>
-                <a:spcPts val="0"/>
-              </a:spcBef>
-              <a:spcAft>
-                <a:spcPts val="0"/>
-              </a:spcAft>
-              <a:buSzPts val="1600"/>
-              <a:buChar char="●"/>
-            </a:pPr>
-            <a:r>
-              <a:rPr lang="en"/>
-              <a:t>Start from the gar-starter template on GitHub</a:t>
-            </a:r>
-            <a:endParaRPr/>
-          </a:p>
-          <a:p>
-            <a:pPr indent="-317500" lvl="1" marL="914400" rtl="0" algn="l">
-              <a:spcBef>
-                <a:spcPts val="0"/>
-              </a:spcBef>
-              <a:spcAft>
-                <a:spcPts val="0"/>
-              </a:spcAft>
-              <a:buSzPts val="1400"/>
-              <a:buChar char="○"/>
-            </a:pPr>
-            <a:r>
-              <a:rPr lang="en"/>
-              <a:t>“Use this template”: an empty game with the content builder</a:t>
-            </a:r>
-            <a:endParaRPr/>
-          </a:p>
-          <a:p>
-            <a:pPr indent="-330200" lvl="0" marL="457200" rtl="0" algn="l">
-              <a:spcBef>
-                <a:spcPts val="0"/>
-              </a:spcBef>
-              <a:spcAft>
-                <a:spcPts val="0"/>
-              </a:spcAft>
-              <a:buSzPts val="1600"/>
-              <a:buChar char="●"/>
-            </a:pPr>
-            <a:r>
-              <a:rPr lang="en"/>
-              <a:t>First milestone, by session 04</a:t>
-            </a:r>
-            <a:endParaRPr/>
-          </a:p>
-          <a:p>
-            <a:pPr indent="-317500" lvl="1" marL="914400" rtl="0" algn="l">
-              <a:spcBef>
-                <a:spcPts val="0"/>
-              </a:spcBef>
-              <a:spcAft>
-                <a:spcPts val="0"/>
-              </a:spcAft>
-              <a:buSzPts val="1400"/>
-              <a:buChar char="○"/>
-            </a:pPr>
-            <a:r>
-              <a:rPr lang="en"/>
-              <a:t>Groups formed, game concept written, repository created and link uploaded to itslearning</a:t>
-            </a:r>
-            <a:endParaRPr/>
-          </a:p>
-        </p:txBody>
-      </p:sp>
-    </p:spTree>
-  </p:cSld>
-  <p:clrMapOvr>
-    <a:masterClrMapping/>
-  </p:clrMapOvr>
-</p:sld>
-</file>
-
 <file path=ppt/slides/slide5.xml><?xml version="1.0" encoding="utf-8"?>
 <p:sld xmlns:a="http://schemas.openxmlformats.org/drawingml/2006/main" xmlns:r="http://schemas.openxmlformats.org/officeDocument/2006/relationships" xmlns:mc="http://schemas.openxmlformats.org/markup-compatibility/2006" xmlns:mv="urn:schemas-microsoft-com:mac:vml" xmlns:p="http://schemas.openxmlformats.org/presentationml/2006/main" xmlns:c="http://schemas.openxmlformats.org/drawingml/2006/chart" xmlns:dgm="http://schemas.openxmlformats.org/drawingml/2006/diagram" xmlns:o="urn:schemas-microsoft-com:office:office" xmlns:v="urn:schemas-microsoft-com:vml" xmlns:pvml="urn:schemas-microsoft-com:office:powerpoint" xmlns:com="http://schemas.openxmlformats.org/drawingml/2006/compatibility" xmlns:p14="http://schemas.microsoft.com/office/powerpoint/2010/main" xmlns:p15="http://schemas.microsoft.com/office/powerpoint/2012/main" xmlns:ahyp="http://schemas.microsoft.com/office/drawing/2018/hyperlinkcolor">
   <p:cSld>

</xml_diff>

<commit_message>
Game folders named after the games in gar-games; Mario's steps are Mario0-8
Co-Authored-By: Claude Opus 5.5 <noreply@anthropic.com>
Claude-Session: https://claude.ai/code/session_012sjsUQBbC7zon57rWHoo9d
</commit_message>
<xml_diff>
--- a/slides/02 Flappy Bird.pptx
+++ b/slides/02 Flappy Bird.pptx
@@ -4512,7 +4512,7 @@
           <a:lstStyle/>
           <a:p>
             <a:r>
-              <a:t>Open gar-games/02-flappy live. Show the README: the step table, the code map, how to run a step.</a:t>
+              <a:t>Open gar-games/02-flappy-bird live. Show the README: the step table, the code map, how to run a step.</a:t>
             </a:r>
           </a:p>
           <a:p>
@@ -29936,7 +29936,7 @@
                 </a:solidFill>
                 <a:hlinkClick r:id="rId3"/>
               </a:rPr>
-              <a:t>github.com/Metamate/gar-games (folder 02-flappy)</a:t>
+              <a:t>github.com/Metamate/gar-games (folder 02-flappy-bird)</a:t>
             </a:r>
             <a:endParaRPr/>
           </a:p>

</xml_diff>

<commit_message>
GMDCore becomes GARCore: the course is GAR now
Co-Authored-By: Claude Opus 5.5 <noreply@anthropic.com>
Claude-Session: https://claude.ai/code/session_012sjsUQBbC7zon57rWHoo9d
</commit_message>
<xml_diff>
--- a/slides/02 Flappy Bird.pptx
+++ b/slides/02 Flappy Bird.pptx
@@ -918,7 +918,7 @@
           <a:lstStyle/>
           <a:p>
             <a:r>
-              <a:t>The shape we’re building: GMDCore, referenced by each game. It grows through the course.</a:t>
+              <a:t>The shape we’re building: GARCore, referenced by each game. It grows through the course.</a:t>
             </a:r>
           </a:p>
         </p:txBody>
@@ -1007,7 +1007,7 @@
           <a:lstStyle/>
           <a:p>
             <a:r>
-              <a:t>Exercise: a repository from gar-starter, which comes with an empty GMDCore library. They write a Core class in it that derives from Game and owns the window and screen scaling.</a:t>
+              <a:t>Exercise: a repository from gar-starter, which comes with an empty GARCore library. They write a Core class in it that derives from Game and owns the window and screen scaling.</a:t>
             </a:r>
           </a:p>
           <a:p>
@@ -8468,7 +8468,7 @@
             </a:pPr>
             <a:r>
               <a:rPr lang="en"/>
-              <a:t>Goal: move what every game needs into a class library, GMDCore.</a:t>
+              <a:t>Goal: move what every game needs into a class library, GARCore.</a:t>
             </a:r>
             <a:endParaRPr/>
           </a:p>
@@ -8542,7 +8542,7 @@
                   <a:srgbClr val="DEE2E6"/>
                 </a:solidFill>
               </a:rPr>
-              <a:t>GMDCore</a:t>
+              <a:t>GARCore</a:t>
             </a:r>
           </a:p>
           <a:p>
@@ -13347,7 +13347,7 @@
             </a:pPr>
             <a:r>
               <a:rPr lang="en"/>
-              <a:t>Goal: flap on Space or a click, with input classes in GMDCore.</a:t>
+              <a:t>Goal: flap on Space or a click, with input classes in GARCore.</a:t>
             </a:r>
             <a:endParaRPr/>
           </a:p>
@@ -27593,7 +27593,7 @@
             </a:pPr>
             <a:r>
               <a:rPr lang="en"/>
-              <a:t>That belongs in a class library, like GMDCore</a:t>
+              <a:t>That belongs in a class library, like GARCore</a:t>
             </a:r>
             <a:endParaRPr/>
           </a:p>

</xml_diff>

<commit_message>
Main topics get plain names, the way they'd be said in class
Co-Authored-By: Claude Opus 5.5 <noreply@anthropic.com>
Claude-Session: https://claude.ai/code/session_012sjsUQBbC7zon57rWHoo9d
</commit_message>
<xml_diff>
--- a/slides/02 Flappy Bird.pptx
+++ b/slides/02 Flappy Bird.pptx
@@ -824,7 +824,7 @@
           <a:lstStyle/>
           <a:p>
             <a:r>
-              <a:t>Welcome. Today we build Flappy Bird. The main topic: organizing a growing game.</a:t>
+              <a:t>Welcome. Today we build Flappy Bird. The main topic: structuring the code.</a:t>
             </a:r>
           </a:p>
           <a:p>
@@ -2737,7 +2737,7 @@
           <a:lstStyle/>
           <a:p>
             <a:r>
-              <a:t>The main topic: organizing a game as it grows. A class library for what every game needs, and a state machine for the game’s modes.</a:t>
+              <a:t>Today’s main topic is structuring the code as the game grows. We move shared code into a class library, and the game’s modes into a state machine.</a:t>
             </a:r>
           </a:p>
           <a:p>
@@ -25928,7 +25928,7 @@
             </a:pPr>
             <a:r>
               <a:rPr lang="en" b="1"/>
-              <a:t>Main topic: Organizing a growing game</a:t>
+              <a:t>Main topic: Structuring the code</a:t>
             </a:r>
             <a:endParaRPr/>
           </a:p>

</xml_diff>

<commit_message>
New recordings and deck pictures after the art pass
- Every GIF re-recorded from the fixed games, scaled with nearest neighbour to a width where
  one art pixel is a whole number of GIF pixels (the old ones were smoothed with Lanczos)
- Flappy Bird is recorded by a bot too (flappy_bot.py); both bots capture only the game's
  window (winshot.py)
- The Snake and Flappy Bird decks show the new art; the home page stills follow the new GIFs

Co-Authored-By: Claude Opus 5.5 <noreply@anthropic.com>
Claude-Session: https://claude.ai/code/session_012sjsUQBbC7zon57rWHoo9d
</commit_message>
<xml_diff>
--- a/slides/02 Flappy Bird.pptx
+++ b/slides/02 Flappy Bird.pptx
@@ -10880,14 +10880,14 @@
       </p:sp>
       <p:pic>
         <p:nvPicPr>
-          <p:cNvPr id="132" name="Picture 131" descr="f2.png"/>
+          <p:cNvPr id="132" name="Picture 132" descr="Flappy2.png"/>
           <p:cNvPicPr>
             <a:picLocks noChangeAspect="1"/>
           </p:cNvPicPr>
           <p:nvPr/>
         </p:nvPicPr>
         <p:blipFill>
-          <a:blip r:embed="rId3"/>
+          <a:blip r:embed="rId4"/>
           <a:stretch>
             <a:fillRect/>
           </a:stretch>
@@ -12991,14 +12991,14 @@
       </p:sp>
       <p:pic>
         <p:nvPicPr>
-          <p:cNvPr id="150" name="Picture 149" descr="f3.png"/>
+          <p:cNvPr id="150" name="Picture 150" descr="Flappy3.png"/>
           <p:cNvPicPr>
             <a:picLocks noChangeAspect="1"/>
           </p:cNvPicPr>
           <p:nvPr/>
         </p:nvPicPr>
         <p:blipFill>
-          <a:blip r:embed="rId3"/>
+          <a:blip r:embed="rId4"/>
           <a:stretch>
             <a:fillRect/>
           </a:stretch>
@@ -14499,7 +14499,7 @@
           <p:nvPr/>
         </p:nvPicPr>
         <p:blipFill>
-          <a:blip r:embed="rId4"/>
+          <a:blip r:embed="rId3"/>
           <a:stretch>
             <a:fillRect/>
           </a:stretch>
@@ -14507,7 +14507,7 @@
         <p:spPr>
           <a:xfrm>
             <a:off x="1521325" y="332167"/>
-            <a:ext cx="6101351" cy="4479166"/>
+            <a:ext cx="6101350" cy="4479166"/>
           </a:xfrm>
           <a:prstGeom prst="rect">
             <a:avLst/>
@@ -14647,14 +14647,14 @@
       </p:sp>
       <p:pic>
         <p:nvPicPr>
-          <p:cNvPr id="179" name="Picture 178" descr="f7.png"/>
+          <p:cNvPr id="179" name="Picture 179" descr="Flappy7.png"/>
           <p:cNvPicPr>
             <a:picLocks noChangeAspect="1"/>
           </p:cNvPicPr>
           <p:nvPr/>
         </p:nvPicPr>
         <p:blipFill>
-          <a:blip r:embed="rId5"/>
+          <a:blip r:embed="rId6"/>
           <a:stretch>
             <a:fillRect/>
           </a:stretch>
@@ -16283,14 +16283,14 @@
       </p:sp>
       <p:pic>
         <p:nvPicPr>
-          <p:cNvPr id="191" name="Picture 190" descr="f8.png"/>
+          <p:cNvPr id="191" name="Picture 191" descr="Flappy8.png"/>
           <p:cNvPicPr>
             <a:picLocks noChangeAspect="1"/>
           </p:cNvPicPr>
           <p:nvPr/>
         </p:nvPicPr>
         <p:blipFill>
-          <a:blip r:embed="rId3"/>
+          <a:blip r:embed="rId4"/>
           <a:stretch>
             <a:fillRect/>
           </a:stretch>
@@ -17138,14 +17138,14 @@
       </p:sp>
       <p:pic>
         <p:nvPicPr>
-          <p:cNvPr id="46" name="Picture 46" descr="gif-flappy.gif"/>
+          <p:cNvPr id="46" name="Picture 46" descr="flappy-bird.gif"/>
           <p:cNvPicPr>
             <a:picLocks noChangeAspect="1"/>
           </p:cNvPicPr>
           <p:nvPr/>
         </p:nvPicPr>
         <p:blipFill>
-          <a:blip r:embed="rId4"/>
+          <a:blip r:embed="rId3"/>
           <a:stretch>
             <a:fillRect/>
           </a:stretch>
@@ -22103,14 +22103,14 @@
       </p:sp>
       <p:pic>
         <p:nvPicPr>
-          <p:cNvPr id="226" name="Picture 225" descr="f9.png"/>
+          <p:cNvPr id="226" name="Picture 226" descr="Flappy9.png"/>
           <p:cNvPicPr>
             <a:picLocks noChangeAspect="1"/>
           </p:cNvPicPr>
           <p:nvPr/>
         </p:nvPicPr>
         <p:blipFill>
-          <a:blip r:embed="rId4"/>
+          <a:blip r:embed="rId5"/>
           <a:stretch>
             <a:fillRect/>
           </a:stretch>
@@ -23202,14 +23202,14 @@
       </p:sp>
       <p:pic>
         <p:nvPicPr>
-          <p:cNvPr id="238" name="Picture 237" descr="f11.png"/>
+          <p:cNvPr id="238" name="Picture 238" descr="Flappy11.png"/>
           <p:cNvPicPr>
             <a:picLocks noChangeAspect="1"/>
           </p:cNvPicPr>
           <p:nvPr/>
         </p:nvPicPr>
         <p:blipFill>
-          <a:blip r:embed="rId3"/>
+          <a:blip r:embed="rId4"/>
           <a:stretch>
             <a:fillRect/>
           </a:stretch>

</xml_diff>

<commit_message>
Exercises and slide wording that followed another course are now our own
Mario's chunk exercise asks which chunks may follow which; Pokemon's stretch
exercise is switching monsters; the parallax slide and one Zelda example are
reworded.

Co-Authored-By: Claude Opus 5.5 <noreply@anthropic.com>
Claude-Session: https://claude.ai/code/session_012sjsUQBbC7zon57rWHoo9d
</commit_message>
<xml_diff>
--- a/slides/02 Flappy Bird.pptx
+++ b/slides/02 Flappy Bird.pptx
@@ -10565,11 +10565,7 @@
             </a:pPr>
             <a:r>
               <a:rPr lang="en"/>
-              <a:t>Illusion of movement </a:t>
-            </a:r>
-            <a:r>
-              <a:rPr lang="en"/>
-              <a:t>given two frames of reference that are moving at different rates</a:t>
+              <a:t>Layers that scroll at different speeds look as if they are at different distances</a:t>
             </a:r>
             <a:endParaRPr/>
           </a:p>
@@ -16920,7 +16916,7 @@
             </a:pPr>
             <a:r>
               <a:rPr lang="en"/>
-              <a:t>Flappy Bird State Machine</a:t>
+              <a:t>The States of the Game</a:t>
             </a:r>
             <a:endParaRPr/>
           </a:p>

</xml_diff>

<commit_message>
Consistency pass: plain class boxes, the closing frame documented, stiff notes reworded
Class diagrams draw a class without members as a plain box. The overview, the
recap and the course notes describe The Whole Game and Summary. Eight speaker
notes and one slide lose a sentence that started with So or ended on a
negation.

Co-Authored-By: Claude Opus 5.5 <noreply@anthropic.com>
Claude-Session: https://claude.ai/code/session_012sjsUQBbC7zon57rWHoo9d
</commit_message>
<xml_diff>
--- a/slides/02 Flappy Bird.pptx
+++ b/slides/02 Flappy Bird.pptx
@@ -989,7 +989,7 @@
           </a:p>
           <a:p>
             <a:r>
-              <a:t>Before they code, ask: where is the library connected to the game, and which way does the reference point? Answer: the ProjectReference in the game’s .csproj; the game knows the library, never the other way round. So nothing in Core may mention Flappy.</a:t>
+              <a:t>Before they code, ask: where is the library connected to the game, and which way does the reference point? Answer: the ProjectReference in the game’s .csproj; the game knows the library, never the other way round. Nothing in Core may therefore mention Flappy.</a:t>
             </a:r>
           </a:p>
           <a:p>
@@ -27442,312 +27442,6 @@
             </a:pPr>
             <a:r>
               <a:rPr lang="en"/>
-              <a:t>Check Yourself</a:t>
-            </a:r>
-            <a:endParaRPr/>
-          </a:p>
-        </p:txBody>
-      </p:sp>
-      <p:sp>
-        <p:nvSpPr>
-          <p:cNvPr id="3" name="Text Placeholder 2"/>
-          <p:cNvSpPr>
-            <a:spLocks noGrp="1"/>
-          </p:cNvSpPr>
-          <p:nvPr>
-            <p:ph type="body" idx="1"/>
-          </p:nvPr>
-        </p:nvSpPr>
-        <p:spPr>
-          <a:xfrm>
-            <a:off x="311700" y="885950"/>
-            <a:ext cx="8520600" cy="1335024"/>
-          </a:xfrm>
-        </p:spPr>
-        <p:txBody>
-          <a:bodyPr/>
-          <a:lstStyle/>
-          <a:p>
-            <a:pPr indent="-330200" lvl="0" marL="457200" rtl="0" algn="l">
-              <a:spcBef>
-                <a:spcPts val="0"/>
-              </a:spcBef>
-              <a:spcAft>
-                <a:spcPts val="0"/>
-              </a:spcAft>
-              <a:buSzPts val="1600"/>
-              <a:buChar char="●"/>
-            </a:pPr>
-            <a:r>
-              <a:rPr lang="en"/>
-              <a:t>What problem does a state machine solve compared to a string or enum field?</a:t>
-            </a:r>
-            <a:endParaRPr/>
-          </a:p>
-          <a:p>
-            <a:pPr indent="-330200" lvl="0" marL="457200" rtl="0" algn="l">
-              <a:spcBef>
-                <a:spcPts val="0"/>
-              </a:spcBef>
-              <a:spcAft>
-                <a:spcPts val="0"/>
-              </a:spcAft>
-              <a:buSzPts val="1600"/>
-              <a:buChar char="●"/>
-            </a:pPr>
-            <a:r>
-              <a:rPr lang="en"/>
-              <a:t>What happens if you forget to call Exit() when switching state?</a:t>
-            </a:r>
-            <a:endParaRPr/>
-          </a:p>
-          <a:p>
-            <a:pPr indent="-330200" lvl="0" marL="457200" rtl="0" algn="l">
-              <a:spcBef>
-                <a:spcPts val="0"/>
-              </a:spcBef>
-              <a:spcAft>
-                <a:spcPts val="0"/>
-              </a:spcAft>
-              <a:buSzPts val="1600"/>
-              <a:buChar char="●"/>
-            </a:pPr>
-            <a:r>
-              <a:rPr lang="en"/>
-              <a:t>Why is Singleton considered an anti-pattern by many game programmers?</a:t>
-            </a:r>
-            <a:endParaRPr/>
-          </a:p>
-        </p:txBody>
-      </p:sp>
-      <p:sp>
-        <p:nvSpPr>
-          <p:cNvPr id="4" name="TextBox 3"/>
-          <p:cNvSpPr txBox="1"/>
-          <p:nvPr/>
-        </p:nvSpPr>
-        <p:spPr>
-          <a:xfrm>
-            <a:off x="457200" y="2798064"/>
-            <a:ext cx="8229600" cy="457200"/>
-          </a:xfrm>
-          <a:prstGeom prst="rect">
-            <a:avLst/>
-          </a:prstGeom>
-          <a:noFill/>
-        </p:spPr>
-        <p:txBody>
-          <a:bodyPr wrap="square">
-            <a:spAutoFit/>
-          </a:bodyPr>
-          <a:lstStyle/>
-          <a:p>
-            <a:pPr algn="ctr"/>
-            <a:r>
-              <a:rPr sz="1400" b="0" i="0">
-                <a:solidFill>
-                  <a:srgbClr val="9AA3AB"/>
-                </a:solidFill>
-              </a:rPr>
-              <a:t>The answers, and more questions, are on the course site.</a:t>
-            </a:r>
-          </a:p>
-        </p:txBody>
-      </p:sp>
-    </p:spTree>
-  </p:cSld>
-  <p:clrMapOvr>
-    <a:masterClrMapping/>
-  </p:clrMapOvr>
-</p:sld>
-</file>
-
-<file path=ppt/slides/slide44.xml><?xml version="1.0" encoding="utf-8"?>
-<p:sld xmlns:a="http://schemas.openxmlformats.org/drawingml/2006/main" xmlns:p="http://schemas.openxmlformats.org/presentationml/2006/main" xmlns:r="http://schemas.openxmlformats.org/officeDocument/2006/relationships">
-  <p:cSld>
-    <p:spTree>
-      <p:nvGrpSpPr>
-        <p:cNvPr id="1" name=""/>
-        <p:cNvGrpSpPr/>
-        <p:nvPr/>
-      </p:nvGrpSpPr>
-      <p:grpSpPr/>
-      <p:sp>
-        <p:nvSpPr>
-          <p:cNvPr id="57" name="Google Shape;57;p12"/>
-          <p:cNvSpPr txBox="1"/>
-          <p:nvPr>
-            <p:ph type="title"/>
-          </p:nvPr>
-        </p:nvSpPr>
-        <p:spPr>
-          <a:xfrm>
-            <a:off x="311700" y="195615"/>
-            <a:ext cx="8520600" cy="572700"/>
-          </a:xfrm>
-          <a:prstGeom prst="rect">
-            <a:avLst/>
-          </a:prstGeom>
-        </p:spPr>
-        <p:txBody>
-          <a:bodyPr anchorCtr="0" anchor="t" bIns="91425" lIns="91425" spcFirstLastPara="1" rIns="91425" wrap="square" tIns="91425">
-            <a:normAutofit fontScale="90000"/>
-          </a:bodyPr>
-          <a:lstStyle/>
-          <a:p>
-            <a:pPr indent="0" lvl="0" marL="0" rtl="0" algn="l">
-              <a:spcBef>
-                <a:spcPts val="0"/>
-              </a:spcBef>
-              <a:spcAft>
-                <a:spcPts val="0"/>
-              </a:spcAft>
-              <a:buNone/>
-            </a:pPr>
-            <a:r>
-              <a:rPr lang="en"/>
-              <a:t>Apply It to Your Project</a:t>
-            </a:r>
-            <a:endParaRPr/>
-          </a:p>
-        </p:txBody>
-      </p:sp>
-      <p:sp>
-        <p:nvSpPr>
-          <p:cNvPr id="58" name="Google Shape;58;p12"/>
-          <p:cNvSpPr txBox="1"/>
-          <p:nvPr>
-            <p:ph idx="1" type="body"/>
-          </p:nvPr>
-        </p:nvSpPr>
-        <p:spPr>
-          <a:xfrm>
-            <a:off x="311700" y="885950"/>
-            <a:ext cx="8520600" cy="4023300"/>
-          </a:xfrm>
-          <a:prstGeom prst="rect">
-            <a:avLst/>
-          </a:prstGeom>
-        </p:spPr>
-        <p:txBody>
-          <a:bodyPr anchorCtr="0" anchor="t" bIns="91425" lIns="91425" spcFirstLastPara="1" rIns="91425" wrap="square" tIns="91425">
-            <a:normAutofit/>
-          </a:bodyPr>
-          <a:lstStyle/>
-          <a:p>
-            <a:pPr indent="-330200" lvl="0" marL="457200" rtl="0" algn="l">
-              <a:spcBef>
-                <a:spcPts val="0"/>
-              </a:spcBef>
-              <a:spcAft>
-                <a:spcPts val="0"/>
-              </a:spcAft>
-              <a:buSzPts val="1600"/>
-              <a:buChar char="●"/>
-            </a:pPr>
-            <a:r>
-              <a:rPr lang="en"/>
-              <a:t>Which code in your game could another game reuse?</a:t>
-            </a:r>
-            <a:endParaRPr/>
-          </a:p>
-          <a:p>
-            <a:pPr indent="-317500" lvl="1" marL="914400" rtl="0" algn="l">
-              <a:spcBef>
-                <a:spcPts val="0"/>
-              </a:spcBef>
-              <a:spcAft>
-                <a:spcPts val="0"/>
-              </a:spcAft>
-              <a:buSzPts val="1400"/>
-              <a:buChar char="○"/>
-            </a:pPr>
-            <a:r>
-              <a:rPr lang="en"/>
-              <a:t>That belongs in a class library, like GARCore</a:t>
-            </a:r>
-            <a:endParaRPr/>
-          </a:p>
-          <a:p>
-            <a:pPr indent="-330200" lvl="0" marL="457200" rtl="0" algn="l">
-              <a:spcBef>
-                <a:spcPts val="0"/>
-              </a:spcBef>
-              <a:spcAft>
-                <a:spcPts val="0"/>
-              </a:spcAft>
-              <a:buSzPts val="1600"/>
-              <a:buChar char="●"/>
-            </a:pPr>
-            <a:r>
-              <a:rPr lang="en"/>
-              <a:t>Which states does your game have? Draw them as a state diagram</a:t>
-            </a:r>
-            <a:endParaRPr/>
-          </a:p>
-          <a:p>
-            <a:pPr indent="-330200" lvl="0" marL="457200" rtl="0" algn="l">
-              <a:spcBef>
-                <a:spcPts val="0"/>
-              </a:spcBef>
-              <a:spcAft>
-                <a:spcPts val="0"/>
-              </a:spcAft>
-              <a:buSzPts val="1600"/>
-              <a:buChar char="●"/>
-            </a:pPr>
-            <a:r>
-              <a:rPr lang="en"/>
-              <a:t>Is anything in your game global? Does it need to be?</a:t>
-            </a:r>
-            <a:endParaRPr/>
-          </a:p>
-        </p:txBody>
-      </p:sp>
-    </p:spTree>
-  </p:cSld>
-  <p:clrMapOvr>
-    <a:masterClrMapping/>
-  </p:clrMapOvr>
-</p:sld>
-</file>
-
-<file path=ppt/slides/slide45.xml><?xml version="1.0" encoding="utf-8"?>
-<p:sld xmlns:a="http://schemas.openxmlformats.org/drawingml/2006/main" xmlns:p="http://schemas.openxmlformats.org/presentationml/2006/main" xmlns:r="http://schemas.openxmlformats.org/officeDocument/2006/relationships">
-  <p:cSld>
-    <p:spTree>
-      <p:nvGrpSpPr>
-        <p:cNvPr id="1" name=""/>
-        <p:cNvGrpSpPr/>
-        <p:nvPr/>
-      </p:nvGrpSpPr>
-      <p:grpSpPr/>
-      <p:sp>
-        <p:nvSpPr>
-          <p:cNvPr id="2" name="Title 1"/>
-          <p:cNvSpPr>
-            <a:spLocks noGrp="1"/>
-          </p:cNvSpPr>
-          <p:nvPr>
-            <p:ph type="title"/>
-          </p:nvPr>
-        </p:nvSpPr>
-        <p:spPr/>
-        <p:txBody>
-          <a:bodyPr/>
-          <a:lstStyle/>
-          <a:p>
-            <a:pPr indent="0" lvl="0" marL="0" rtl="0" algn="l">
-              <a:spcBef>
-                <a:spcPts val="0"/>
-              </a:spcBef>
-              <a:spcAft>
-                <a:spcPts val="0"/>
-              </a:spcAft>
-              <a:buNone/>
-            </a:pPr>
-            <a:r>
-              <a:rPr lang="en"/>
               <a:t>The Whole Game</a:t>
             </a:r>
             <a:endParaRPr/>
@@ -28553,7 +28247,7 @@
 </p:sld>
 </file>
 
-<file path=ppt/slides/slide46.xml><?xml version="1.0" encoding="utf-8"?>
+<file path=ppt/slides/slide44.xml><?xml version="1.0" encoding="utf-8"?>
 <p:sld xmlns:a="http://schemas.openxmlformats.org/drawingml/2006/main" xmlns:p="http://schemas.openxmlformats.org/presentationml/2006/main" xmlns:r="http://schemas.openxmlformats.org/officeDocument/2006/relationships">
   <p:cSld>
     <p:spTree>
@@ -29020,6 +28714,312 @@
               </a:rPr>
               <a:t>Singleton, and what it costs</a:t>
             </a:r>
+          </a:p>
+        </p:txBody>
+      </p:sp>
+    </p:spTree>
+  </p:cSld>
+  <p:clrMapOvr>
+    <a:masterClrMapping/>
+  </p:clrMapOvr>
+</p:sld>
+</file>
+
+<file path=ppt/slides/slide45.xml><?xml version="1.0" encoding="utf-8"?>
+<p:sld xmlns:a="http://schemas.openxmlformats.org/drawingml/2006/main" xmlns:p="http://schemas.openxmlformats.org/presentationml/2006/main" xmlns:r="http://schemas.openxmlformats.org/officeDocument/2006/relationships">
+  <p:cSld>
+    <p:spTree>
+      <p:nvGrpSpPr>
+        <p:cNvPr id="1" name=""/>
+        <p:cNvGrpSpPr/>
+        <p:nvPr/>
+      </p:nvGrpSpPr>
+      <p:grpSpPr/>
+      <p:sp>
+        <p:nvSpPr>
+          <p:cNvPr id="2" name="Title 1"/>
+          <p:cNvSpPr>
+            <a:spLocks noGrp="1"/>
+          </p:cNvSpPr>
+          <p:nvPr>
+            <p:ph type="title"/>
+          </p:nvPr>
+        </p:nvSpPr>
+        <p:spPr/>
+        <p:txBody>
+          <a:bodyPr/>
+          <a:lstStyle/>
+          <a:p>
+            <a:pPr indent="0" lvl="0" marL="0" rtl="0" algn="l">
+              <a:spcBef>
+                <a:spcPts val="0"/>
+              </a:spcBef>
+              <a:spcAft>
+                <a:spcPts val="0"/>
+              </a:spcAft>
+              <a:buNone/>
+            </a:pPr>
+            <a:r>
+              <a:rPr lang="en"/>
+              <a:t>Check Yourself</a:t>
+            </a:r>
+            <a:endParaRPr/>
+          </a:p>
+        </p:txBody>
+      </p:sp>
+      <p:sp>
+        <p:nvSpPr>
+          <p:cNvPr id="3" name="Text Placeholder 2"/>
+          <p:cNvSpPr>
+            <a:spLocks noGrp="1"/>
+          </p:cNvSpPr>
+          <p:nvPr>
+            <p:ph type="body" idx="1"/>
+          </p:nvPr>
+        </p:nvSpPr>
+        <p:spPr>
+          <a:xfrm>
+            <a:off x="311700" y="885950"/>
+            <a:ext cx="8520600" cy="1335024"/>
+          </a:xfrm>
+        </p:spPr>
+        <p:txBody>
+          <a:bodyPr/>
+          <a:lstStyle/>
+          <a:p>
+            <a:pPr indent="-330200" lvl="0" marL="457200" rtl="0" algn="l">
+              <a:spcBef>
+                <a:spcPts val="0"/>
+              </a:spcBef>
+              <a:spcAft>
+                <a:spcPts val="0"/>
+              </a:spcAft>
+              <a:buSzPts val="1600"/>
+              <a:buChar char="●"/>
+            </a:pPr>
+            <a:r>
+              <a:rPr lang="en"/>
+              <a:t>What problem does a state machine solve compared to a string or enum field?</a:t>
+            </a:r>
+            <a:endParaRPr/>
+          </a:p>
+          <a:p>
+            <a:pPr indent="-330200" lvl="0" marL="457200" rtl="0" algn="l">
+              <a:spcBef>
+                <a:spcPts val="0"/>
+              </a:spcBef>
+              <a:spcAft>
+                <a:spcPts val="0"/>
+              </a:spcAft>
+              <a:buSzPts val="1600"/>
+              <a:buChar char="●"/>
+            </a:pPr>
+            <a:r>
+              <a:rPr lang="en"/>
+              <a:t>What happens if you forget to call Exit() when switching state?</a:t>
+            </a:r>
+            <a:endParaRPr/>
+          </a:p>
+          <a:p>
+            <a:pPr indent="-330200" lvl="0" marL="457200" rtl="0" algn="l">
+              <a:spcBef>
+                <a:spcPts val="0"/>
+              </a:spcBef>
+              <a:spcAft>
+                <a:spcPts val="0"/>
+              </a:spcAft>
+              <a:buSzPts val="1600"/>
+              <a:buChar char="●"/>
+            </a:pPr>
+            <a:r>
+              <a:rPr lang="en"/>
+              <a:t>Why is Singleton considered an anti-pattern by many game programmers?</a:t>
+            </a:r>
+            <a:endParaRPr/>
+          </a:p>
+        </p:txBody>
+      </p:sp>
+      <p:sp>
+        <p:nvSpPr>
+          <p:cNvPr id="4" name="TextBox 3"/>
+          <p:cNvSpPr txBox="1"/>
+          <p:nvPr/>
+        </p:nvSpPr>
+        <p:spPr>
+          <a:xfrm>
+            <a:off x="457200" y="2798064"/>
+            <a:ext cx="8229600" cy="457200"/>
+          </a:xfrm>
+          <a:prstGeom prst="rect">
+            <a:avLst/>
+          </a:prstGeom>
+          <a:noFill/>
+        </p:spPr>
+        <p:txBody>
+          <a:bodyPr wrap="square">
+            <a:spAutoFit/>
+          </a:bodyPr>
+          <a:lstStyle/>
+          <a:p>
+            <a:pPr algn="ctr"/>
+            <a:r>
+              <a:rPr sz="1400" b="0" i="0">
+                <a:solidFill>
+                  <a:srgbClr val="9AA3AB"/>
+                </a:solidFill>
+              </a:rPr>
+              <a:t>The answers, and more questions, are on the course site.</a:t>
+            </a:r>
+          </a:p>
+        </p:txBody>
+      </p:sp>
+    </p:spTree>
+  </p:cSld>
+  <p:clrMapOvr>
+    <a:masterClrMapping/>
+  </p:clrMapOvr>
+</p:sld>
+</file>
+
+<file path=ppt/slides/slide46.xml><?xml version="1.0" encoding="utf-8"?>
+<p:sld xmlns:a="http://schemas.openxmlformats.org/drawingml/2006/main" xmlns:p="http://schemas.openxmlformats.org/presentationml/2006/main" xmlns:r="http://schemas.openxmlformats.org/officeDocument/2006/relationships">
+  <p:cSld>
+    <p:spTree>
+      <p:nvGrpSpPr>
+        <p:cNvPr id="1" name=""/>
+        <p:cNvGrpSpPr/>
+        <p:nvPr/>
+      </p:nvGrpSpPr>
+      <p:grpSpPr/>
+      <p:sp>
+        <p:nvSpPr>
+          <p:cNvPr id="57" name="Google Shape;57;p12"/>
+          <p:cNvSpPr txBox="1"/>
+          <p:nvPr>
+            <p:ph type="title"/>
+          </p:nvPr>
+        </p:nvSpPr>
+        <p:spPr>
+          <a:xfrm>
+            <a:off x="311700" y="195615"/>
+            <a:ext cx="8520600" cy="572700"/>
+          </a:xfrm>
+          <a:prstGeom prst="rect">
+            <a:avLst/>
+          </a:prstGeom>
+        </p:spPr>
+        <p:txBody>
+          <a:bodyPr anchorCtr="0" anchor="t" bIns="91425" lIns="91425" spcFirstLastPara="1" rIns="91425" wrap="square" tIns="91425">
+            <a:normAutofit fontScale="90000"/>
+          </a:bodyPr>
+          <a:lstStyle/>
+          <a:p>
+            <a:pPr indent="0" lvl="0" marL="0" rtl="0" algn="l">
+              <a:spcBef>
+                <a:spcPts val="0"/>
+              </a:spcBef>
+              <a:spcAft>
+                <a:spcPts val="0"/>
+              </a:spcAft>
+              <a:buNone/>
+            </a:pPr>
+            <a:r>
+              <a:rPr lang="en"/>
+              <a:t>Apply It to Your Project</a:t>
+            </a:r>
+            <a:endParaRPr/>
+          </a:p>
+        </p:txBody>
+      </p:sp>
+      <p:sp>
+        <p:nvSpPr>
+          <p:cNvPr id="58" name="Google Shape;58;p12"/>
+          <p:cNvSpPr txBox="1"/>
+          <p:nvPr>
+            <p:ph idx="1" type="body"/>
+          </p:nvPr>
+        </p:nvSpPr>
+        <p:spPr>
+          <a:xfrm>
+            <a:off x="311700" y="885950"/>
+            <a:ext cx="8520600" cy="4023300"/>
+          </a:xfrm>
+          <a:prstGeom prst="rect">
+            <a:avLst/>
+          </a:prstGeom>
+        </p:spPr>
+        <p:txBody>
+          <a:bodyPr anchorCtr="0" anchor="t" bIns="91425" lIns="91425" spcFirstLastPara="1" rIns="91425" wrap="square" tIns="91425">
+            <a:normAutofit/>
+          </a:bodyPr>
+          <a:lstStyle/>
+          <a:p>
+            <a:pPr indent="-330200" lvl="0" marL="457200" rtl="0" algn="l">
+              <a:spcBef>
+                <a:spcPts val="0"/>
+              </a:spcBef>
+              <a:spcAft>
+                <a:spcPts val="0"/>
+              </a:spcAft>
+              <a:buSzPts val="1600"/>
+              <a:buChar char="●"/>
+            </a:pPr>
+            <a:r>
+              <a:rPr lang="en"/>
+              <a:t>Which code in your game could another game reuse?</a:t>
+            </a:r>
+            <a:endParaRPr/>
+          </a:p>
+          <a:p>
+            <a:pPr indent="-317500" lvl="1" marL="914400" rtl="0" algn="l">
+              <a:spcBef>
+                <a:spcPts val="0"/>
+              </a:spcBef>
+              <a:spcAft>
+                <a:spcPts val="0"/>
+              </a:spcAft>
+              <a:buSzPts val="1400"/>
+              <a:buChar char="○"/>
+            </a:pPr>
+            <a:r>
+              <a:rPr lang="en"/>
+              <a:t>That belongs in a class library, like GARCore</a:t>
+            </a:r>
+            <a:endParaRPr/>
+          </a:p>
+          <a:p>
+            <a:pPr indent="-330200" lvl="0" marL="457200" rtl="0" algn="l">
+              <a:spcBef>
+                <a:spcPts val="0"/>
+              </a:spcBef>
+              <a:spcAft>
+                <a:spcPts val="0"/>
+              </a:spcAft>
+              <a:buSzPts val="1600"/>
+              <a:buChar char="●"/>
+            </a:pPr>
+            <a:r>
+              <a:rPr lang="en"/>
+              <a:t>Which states does your game have? Draw them as a state diagram</a:t>
+            </a:r>
+            <a:endParaRPr/>
+          </a:p>
+          <a:p>
+            <a:pPr indent="-330200" lvl="0" marL="457200" rtl="0" algn="l">
+              <a:spcBef>
+                <a:spcPts val="0"/>
+              </a:spcBef>
+              <a:spcAft>
+                <a:spcPts val="0"/>
+              </a:spcAft>
+              <a:buSzPts val="1600"/>
+              <a:buChar char="●"/>
+            </a:pPr>
+            <a:r>
+              <a:rPr lang="en"/>
+              <a:t>Is anything in your game global? Does it need to be?</a:t>
+            </a:r>
+            <a:endParaRPr/>
           </a:p>
         </p:txBody>
       </p:sp>

</xml_diff>